<commit_message>
COSTAR slides: original deck layout in a purple color scheme
Co-Authored-By: Claude Opus 5.5 <noreply@anthropic.com>
Claude-Session: https://claude.ai/code/session_01Nu81SmmHj1XfYpohCK6uwS
</commit_message>
<xml_diff>
--- a/costar-slides.pptx
+++ b/costar-slides.pptx
@@ -8,7 +8,7 @@
     <p:sldId id="256" r:id="rId7"/>
     <p:sldId id="257" r:id="rId9"/>
   </p:sldIdLst>
-  <p:sldSz cx="12191695" cy="6858000" type="screen4x3"/>
+  <p:sldSz cx="12192000" cy="6858000" type="screen4x3"/>
   <p:notesSz cx="6858000" cy="9144000"/>
   <p:defaultTextStyle>
     <a:defPPr>
@@ -3617,7 +3617,7 @@
       <p:grpSpPr/>
       <p:pic>
         <p:nvPicPr>
-          <p:cNvPr id="2" name="Background" descr="bg.jpg"/>
+          <p:cNvPr id="2" name="Or use a framework: COSTAR" descr="Or use a framework: COSTAR"/>
           <p:cNvPicPr>
             <a:picLocks noChangeAspect="1"/>
           </p:cNvPicPr>
@@ -3632,1246 +3632,13 @@
         <p:spPr>
           <a:xfrm>
             <a:off x="0" y="0"/>
-            <a:ext cx="12191695" cy="6858000"/>
+            <a:ext cx="12192000" cy="6858000"/>
           </a:xfrm>
           <a:prstGeom prst="rect">
             <a:avLst/>
           </a:prstGeom>
         </p:spPr>
       </p:pic>
-      <p:sp>
-        <p:nvSpPr>
-          <p:cNvPr id="3" name="Nav Home"/>
-          <p:cNvSpPr txBox="1"/>
-          <p:nvPr/>
-        </p:nvSpPr>
-        <p:spPr>
-          <a:xfrm>
-            <a:off x="4160520" y="502920"/>
-            <a:ext cx="1463040" cy="365760"/>
-          </a:xfrm>
-          <a:prstGeom prst="rect">
-            <a:avLst/>
-          </a:prstGeom>
-          <a:noFill/>
-        </p:spPr>
-        <p:txBody>
-          <a:bodyPr wrap="square" anchor="ctr" lIns="0" rIns="0" tIns="0" bIns="0">
-            <a:spAutoFit/>
-          </a:bodyPr>
-          <a:lstStyle/>
-          <a:p>
-            <a:pPr algn="ctr"/>
-            <a:r>
-              <a:rPr sz="1600" b="0">
-                <a:solidFill>
-                  <a:srgbClr val="222222"/>
-                </a:solidFill>
-                <a:latin typeface="Arial"/>
-              </a:rPr>
-              <a:t>Home</a:t>
-            </a:r>
-          </a:p>
-        </p:txBody>
-      </p:sp>
-      <p:sp>
-        <p:nvSpPr>
-          <p:cNvPr id="4" name="Nav Activity"/>
-          <p:cNvSpPr txBox="1"/>
-          <p:nvPr/>
-        </p:nvSpPr>
-        <p:spPr>
-          <a:xfrm>
-            <a:off x="5715000" y="502920"/>
-            <a:ext cx="1463040" cy="365760"/>
-          </a:xfrm>
-          <a:prstGeom prst="rect">
-            <a:avLst/>
-          </a:prstGeom>
-          <a:noFill/>
-        </p:spPr>
-        <p:txBody>
-          <a:bodyPr wrap="square" anchor="ctr" lIns="0" rIns="0" tIns="0" bIns="0">
-            <a:spAutoFit/>
-          </a:bodyPr>
-          <a:lstStyle/>
-          <a:p>
-            <a:pPr algn="ctr"/>
-            <a:r>
-              <a:rPr sz="1600" b="1">
-                <a:solidFill>
-                  <a:srgbClr val="222222"/>
-                </a:solidFill>
-                <a:latin typeface="Arial"/>
-              </a:rPr>
-              <a:t>Activity</a:t>
-            </a:r>
-          </a:p>
-        </p:txBody>
-      </p:sp>
-      <p:sp>
-        <p:nvSpPr>
-          <p:cNvPr id="5" name="Nav Discussion"/>
-          <p:cNvSpPr txBox="1"/>
-          <p:nvPr/>
-        </p:nvSpPr>
-        <p:spPr>
-          <a:xfrm>
-            <a:off x="7269480" y="502920"/>
-            <a:ext cx="1463040" cy="365760"/>
-          </a:xfrm>
-          <a:prstGeom prst="rect">
-            <a:avLst/>
-          </a:prstGeom>
-          <a:noFill/>
-        </p:spPr>
-        <p:txBody>
-          <a:bodyPr wrap="square" anchor="ctr" lIns="0" rIns="0" tIns="0" bIns="0">
-            <a:spAutoFit/>
-          </a:bodyPr>
-          <a:lstStyle/>
-          <a:p>
-            <a:pPr algn="ctr"/>
-            <a:r>
-              <a:rPr sz="1600" b="0">
-                <a:solidFill>
-                  <a:srgbClr val="222222"/>
-                </a:solidFill>
-                <a:latin typeface="Arial"/>
-              </a:rPr>
-              <a:t>Discussion</a:t>
-            </a:r>
-          </a:p>
-        </p:txBody>
-      </p:sp>
-      <p:pic>
-        <p:nvPicPr>
-          <p:cNvPr id="6" name="OCBC logo" descr="ocbc-logo.png"/>
-          <p:cNvPicPr>
-            <a:picLocks noChangeAspect="1"/>
-          </p:cNvPicPr>
-          <p:nvPr/>
-        </p:nvPicPr>
-        <p:blipFill>
-          <a:blip r:embed="rId3"/>
-          <a:stretch>
-            <a:fillRect/>
-          </a:stretch>
-        </p:blipFill>
-        <p:spPr>
-          <a:xfrm>
-            <a:off x="9921240" y="457200"/>
-            <a:ext cx="1451786" cy="393192"/>
-          </a:xfrm>
-          <a:prstGeom prst="rect">
-            <a:avLst/>
-          </a:prstGeom>
-        </p:spPr>
-      </p:pic>
-      <p:cxnSp>
-        <p:nvCxnSpPr>
-          <p:cNvPr id="7" name="Nav rule"/>
-          <p:cNvCxnSpPr/>
-          <p:nvPr/>
-        </p:nvCxnSpPr>
-        <p:spPr>
-          <a:xfrm>
-            <a:off x="731520" y="1097280"/>
-            <a:ext cx="10725912" cy="0"/>
-          </a:xfrm>
-          <a:prstGeom prst="line">
-            <a:avLst/>
-          </a:prstGeom>
-          <a:ln w="12700">
-            <a:solidFill>
-              <a:srgbClr val="5A5A60"/>
-            </a:solidFill>
-          </a:ln>
-        </p:spPr>
-      </p:cxnSp>
-      <p:sp>
-        <p:nvSpPr>
-          <p:cNvPr id="8" name="Kicker"/>
-          <p:cNvSpPr txBox="1"/>
-          <p:nvPr/>
-        </p:nvSpPr>
-        <p:spPr>
-          <a:xfrm>
-            <a:off x="777240" y="1298448"/>
-            <a:ext cx="7315200" cy="502920"/>
-          </a:xfrm>
-          <a:prstGeom prst="rect">
-            <a:avLst/>
-          </a:prstGeom>
-          <a:noFill/>
-        </p:spPr>
-        <p:txBody>
-          <a:bodyPr wrap="square" anchor="t" lIns="0" rIns="0" tIns="0" bIns="0">
-            <a:spAutoFit/>
-          </a:bodyPr>
-          <a:lstStyle/>
-          <a:p>
-            <a:pPr algn="l"/>
-            <a:r>
-              <a:rPr sz="3000" b="1">
-                <a:solidFill>
-                  <a:srgbClr val="222222"/>
-                </a:solidFill>
-                <a:latin typeface="Arial"/>
-              </a:rPr>
-              <a:t>PROMPTING</a:t>
-            </a:r>
-          </a:p>
-        </p:txBody>
-      </p:sp>
-      <p:sp>
-        <p:nvSpPr>
-          <p:cNvPr id="9" name="Title"/>
-          <p:cNvSpPr txBox="1"/>
-          <p:nvPr/>
-        </p:nvSpPr>
-        <p:spPr>
-          <a:xfrm>
-            <a:off x="777240" y="1783080"/>
-            <a:ext cx="10515600" cy="822960"/>
-          </a:xfrm>
-          <a:prstGeom prst="rect">
-            <a:avLst/>
-          </a:prstGeom>
-          <a:noFill/>
-        </p:spPr>
-        <p:txBody>
-          <a:bodyPr wrap="square" anchor="t" lIns="0" rIns="0" tIns="0" bIns="0">
-            <a:spAutoFit/>
-          </a:bodyPr>
-          <a:lstStyle/>
-          <a:p>
-            <a:pPr algn="l"/>
-            <a:r>
-              <a:rPr sz="5000" b="1">
-                <a:gradFill rotWithShape="1">
-                  <a:gsLst>
-                    <a:gs pos="0">
-                      <a:srgbClr val="6B3FA8"/>
-                    </a:gs>
-                    <a:gs pos="100000">
-                      <a:srgbClr val="C64FC0"/>
-                    </a:gs>
-                  </a:gsLst>
-                  <a:lin ang="0" scaled="0"/>
-                </a:gradFill>
-                <a:latin typeface="Arial"/>
-              </a:rPr>
-              <a:t>COSTAR FRAMEWORK</a:t>
-            </a:r>
-          </a:p>
-        </p:txBody>
-      </p:sp>
-      <p:sp>
-        <p:nvSpPr>
-          <p:cNvPr id="10" name="Gradient bar"/>
-          <p:cNvSpPr/>
-          <p:nvPr/>
-        </p:nvSpPr>
-        <p:spPr>
-          <a:xfrm>
-            <a:off x="347472" y="6199632"/>
-            <a:ext cx="11503152" cy="658368"/>
-          </a:xfrm>
-          <a:prstGeom prst="rect">
-            <a:avLst/>
-          </a:prstGeom>
-          <a:gradFill rotWithShape="1">
-            <a:gsLst>
-              <a:gs pos="0">
-                <a:srgbClr val="7A3CC8"/>
-              </a:gs>
-              <a:gs pos="55000">
-                <a:srgbClr val="D774D6"/>
-              </a:gs>
-              <a:gs pos="100000">
-                <a:srgbClr val="8B40C8"/>
-              </a:gs>
-            </a:gsLst>
-            <a:lin ang="0" scaled="0"/>
-          </a:gradFill>
-          <a:ln>
-            <a:noFill/>
-          </a:ln>
-        </p:spPr>
-        <p:txBody>
-          <a:bodyPr rtlCol="0" anchor="ctr"/>
-          <a:lstStyle/>
-          <a:p>
-            <a:pPr algn="ctr"/>
-          </a:p>
-        </p:txBody>
-      </p:sp>
-      <p:sp>
-        <p:nvSpPr>
-          <p:cNvPr id="11" name="Label THE SIX BOXES"/>
-          <p:cNvSpPr txBox="1"/>
-          <p:nvPr/>
-        </p:nvSpPr>
-        <p:spPr>
-          <a:xfrm>
-            <a:off x="914400" y="2834640"/>
-            <a:ext cx="4572000" cy="274320"/>
-          </a:xfrm>
-          <a:prstGeom prst="rect">
-            <a:avLst/>
-          </a:prstGeom>
-          <a:noFill/>
-        </p:spPr>
-        <p:txBody>
-          <a:bodyPr wrap="square" anchor="t" lIns="0" rIns="0" tIns="0" bIns="0">
-            <a:spAutoFit/>
-          </a:bodyPr>
-          <a:lstStyle/>
-          <a:p>
-            <a:pPr algn="l"/>
-            <a:r>
-              <a:rPr sz="1500" b="1">
-                <a:solidFill>
-                  <a:srgbClr val="222222"/>
-                </a:solidFill>
-                <a:latin typeface="Arial"/>
-              </a:rPr>
-              <a:t>THE SIX BOXES</a:t>
-            </a:r>
-          </a:p>
-        </p:txBody>
-      </p:sp>
-      <p:sp>
-        <p:nvSpPr>
-          <p:cNvPr id="12" name="Label HOW TO USE IT"/>
-          <p:cNvSpPr txBox="1"/>
-          <p:nvPr/>
-        </p:nvSpPr>
-        <p:spPr>
-          <a:xfrm>
-            <a:off x="7589520" y="2834640"/>
-            <a:ext cx="4572000" cy="274320"/>
-          </a:xfrm>
-          <a:prstGeom prst="rect">
-            <a:avLst/>
-          </a:prstGeom>
-          <a:noFill/>
-        </p:spPr>
-        <p:txBody>
-          <a:bodyPr wrap="square" anchor="t" lIns="0" rIns="0" tIns="0" bIns="0">
-            <a:spAutoFit/>
-          </a:bodyPr>
-          <a:lstStyle/>
-          <a:p>
-            <a:pPr algn="l"/>
-            <a:r>
-              <a:rPr sz="1500" b="1">
-                <a:solidFill>
-                  <a:srgbClr val="222222"/>
-                </a:solidFill>
-                <a:latin typeface="Arial"/>
-              </a:rPr>
-              <a:t>HOW TO USE IT</a:t>
-            </a:r>
-          </a:p>
-        </p:txBody>
-      </p:sp>
-      <p:sp>
-        <p:nvSpPr>
-          <p:cNvPr id="13" name="Six boxes card"/>
-          <p:cNvSpPr/>
-          <p:nvPr/>
-        </p:nvSpPr>
-        <p:spPr>
-          <a:xfrm>
-            <a:off x="868680" y="3154680"/>
-            <a:ext cx="6446520" cy="2834640"/>
-          </a:xfrm>
-          <a:prstGeom prst="rect">
-            <a:avLst/>
-          </a:prstGeom>
-          <a:solidFill>
-            <a:srgbClr val="FFFFFF">
-              <a:alpha val="96000"/>
-            </a:srgbClr>
-          </a:solidFill>
-          <a:ln>
-            <a:noFill/>
-          </a:ln>
-        </p:spPr>
-        <p:txBody>
-          <a:bodyPr rtlCol="0" anchor="ctr"/>
-          <a:lstStyle/>
-          <a:p>
-            <a:pPr algn="ctr"/>
-          </a:p>
-        </p:txBody>
-      </p:sp>
-      <p:sp>
-        <p:nvSpPr>
-          <p:cNvPr id="14" name="How to use card"/>
-          <p:cNvSpPr/>
-          <p:nvPr/>
-        </p:nvSpPr>
-        <p:spPr>
-          <a:xfrm>
-            <a:off x="7589520" y="3154680"/>
-            <a:ext cx="4114800" cy="2834640"/>
-          </a:xfrm>
-          <a:prstGeom prst="rect">
-            <a:avLst/>
-          </a:prstGeom>
-          <a:solidFill>
-            <a:srgbClr val="FFFFFF">
-              <a:alpha val="96000"/>
-            </a:srgbClr>
-          </a:solidFill>
-          <a:ln>
-            <a:noFill/>
-          </a:ln>
-        </p:spPr>
-        <p:txBody>
-          <a:bodyPr rtlCol="0" anchor="ctr"/>
-          <a:lstStyle/>
-          <a:p>
-            <a:pPr algn="ctr"/>
-          </a:p>
-        </p:txBody>
-      </p:sp>
-      <p:sp>
-        <p:nvSpPr>
-          <p:cNvPr id="15" name="Letter C"/>
-          <p:cNvSpPr txBox="1"/>
-          <p:nvPr/>
-        </p:nvSpPr>
-        <p:spPr>
-          <a:xfrm>
-            <a:off x="1097280" y="3310128"/>
-            <a:ext cx="457200" cy="384048"/>
-          </a:xfrm>
-          <a:prstGeom prst="rect">
-            <a:avLst/>
-          </a:prstGeom>
-          <a:noFill/>
-        </p:spPr>
-        <p:txBody>
-          <a:bodyPr wrap="square" anchor="ctr" lIns="0" rIns="0" tIns="0" bIns="0">
-            <a:spAutoFit/>
-          </a:bodyPr>
-          <a:lstStyle/>
-          <a:p>
-            <a:pPr algn="l"/>
-            <a:r>
-              <a:rPr sz="2200" b="1">
-                <a:gradFill rotWithShape="1">
-                  <a:gsLst>
-                    <a:gs pos="0">
-                      <a:srgbClr val="6B3FA8"/>
-                    </a:gs>
-                    <a:gs pos="100000">
-                      <a:srgbClr val="C64FC0"/>
-                    </a:gs>
-                  </a:gsLst>
-                  <a:lin ang="0" scaled="0"/>
-                </a:gradFill>
-                <a:latin typeface="Arial"/>
-              </a:rPr>
-              <a:t>C</a:t>
-            </a:r>
-          </a:p>
-        </p:txBody>
-      </p:sp>
-      <p:sp>
-        <p:nvSpPr>
-          <p:cNvPr id="16" name="Word Context"/>
-          <p:cNvSpPr txBox="1"/>
-          <p:nvPr/>
-        </p:nvSpPr>
-        <p:spPr>
-          <a:xfrm>
-            <a:off x="1554480" y="3310128"/>
-            <a:ext cx="1325880" cy="384048"/>
-          </a:xfrm>
-          <a:prstGeom prst="rect">
-            <a:avLst/>
-          </a:prstGeom>
-          <a:noFill/>
-        </p:spPr>
-        <p:txBody>
-          <a:bodyPr wrap="square" anchor="ctr" lIns="0" rIns="0" tIns="0" bIns="0">
-            <a:spAutoFit/>
-          </a:bodyPr>
-          <a:lstStyle/>
-          <a:p>
-            <a:pPr algn="l"/>
-            <a:r>
-              <a:rPr sz="1600" b="1">
-                <a:solidFill>
-                  <a:srgbClr val="222222"/>
-                </a:solidFill>
-                <a:latin typeface="Arial"/>
-              </a:rPr>
-              <a:t>Context</a:t>
-            </a:r>
-          </a:p>
-        </p:txBody>
-      </p:sp>
-      <p:sp>
-        <p:nvSpPr>
-          <p:cNvPr id="17" name="Desc Context"/>
-          <p:cNvSpPr txBox="1"/>
-          <p:nvPr/>
-        </p:nvSpPr>
-        <p:spPr>
-          <a:xfrm>
-            <a:off x="2880360" y="3310128"/>
-            <a:ext cx="4297680" cy="384048"/>
-          </a:xfrm>
-          <a:prstGeom prst="rect">
-            <a:avLst/>
-          </a:prstGeom>
-          <a:noFill/>
-        </p:spPr>
-        <p:txBody>
-          <a:bodyPr wrap="square" anchor="ctr" lIns="0" rIns="0" tIns="0" bIns="0">
-            <a:spAutoFit/>
-          </a:bodyPr>
-          <a:lstStyle/>
-          <a:p>
-            <a:pPr algn="l"/>
-            <a:r>
-              <a:rPr sz="1500" b="0">
-                <a:solidFill>
-                  <a:srgbClr val="55555E"/>
-                </a:solidFill>
-                <a:latin typeface="Arial"/>
-              </a:rPr>
-              <a:t>the background the model needs to know</a:t>
-            </a:r>
-          </a:p>
-        </p:txBody>
-      </p:sp>
-      <p:sp>
-        <p:nvSpPr>
-          <p:cNvPr id="18" name="Letter O"/>
-          <p:cNvSpPr txBox="1"/>
-          <p:nvPr/>
-        </p:nvSpPr>
-        <p:spPr>
-          <a:xfrm>
-            <a:off x="1097280" y="3735324"/>
-            <a:ext cx="457200" cy="384048"/>
-          </a:xfrm>
-          <a:prstGeom prst="rect">
-            <a:avLst/>
-          </a:prstGeom>
-          <a:noFill/>
-        </p:spPr>
-        <p:txBody>
-          <a:bodyPr wrap="square" anchor="ctr" lIns="0" rIns="0" tIns="0" bIns="0">
-            <a:spAutoFit/>
-          </a:bodyPr>
-          <a:lstStyle/>
-          <a:p>
-            <a:pPr algn="l"/>
-            <a:r>
-              <a:rPr sz="2200" b="1">
-                <a:gradFill rotWithShape="1">
-                  <a:gsLst>
-                    <a:gs pos="0">
-                      <a:srgbClr val="6B3FA8"/>
-                    </a:gs>
-                    <a:gs pos="100000">
-                      <a:srgbClr val="C64FC0"/>
-                    </a:gs>
-                  </a:gsLst>
-                  <a:lin ang="0" scaled="0"/>
-                </a:gradFill>
-                <a:latin typeface="Arial"/>
-              </a:rPr>
-              <a:t>O</a:t>
-            </a:r>
-          </a:p>
-        </p:txBody>
-      </p:sp>
-      <p:sp>
-        <p:nvSpPr>
-          <p:cNvPr id="19" name="Word Objective"/>
-          <p:cNvSpPr txBox="1"/>
-          <p:nvPr/>
-        </p:nvSpPr>
-        <p:spPr>
-          <a:xfrm>
-            <a:off x="1554480" y="3735324"/>
-            <a:ext cx="1325880" cy="384048"/>
-          </a:xfrm>
-          <a:prstGeom prst="rect">
-            <a:avLst/>
-          </a:prstGeom>
-          <a:noFill/>
-        </p:spPr>
-        <p:txBody>
-          <a:bodyPr wrap="square" anchor="ctr" lIns="0" rIns="0" tIns="0" bIns="0">
-            <a:spAutoFit/>
-          </a:bodyPr>
-          <a:lstStyle/>
-          <a:p>
-            <a:pPr algn="l"/>
-            <a:r>
-              <a:rPr sz="1600" b="1">
-                <a:solidFill>
-                  <a:srgbClr val="222222"/>
-                </a:solidFill>
-                <a:latin typeface="Arial"/>
-              </a:rPr>
-              <a:t>Objective</a:t>
-            </a:r>
-          </a:p>
-        </p:txBody>
-      </p:sp>
-      <p:sp>
-        <p:nvSpPr>
-          <p:cNvPr id="20" name="Desc Objective"/>
-          <p:cNvSpPr txBox="1"/>
-          <p:nvPr/>
-        </p:nvSpPr>
-        <p:spPr>
-          <a:xfrm>
-            <a:off x="2880360" y="3735324"/>
-            <a:ext cx="4297680" cy="384048"/>
-          </a:xfrm>
-          <a:prstGeom prst="rect">
-            <a:avLst/>
-          </a:prstGeom>
-          <a:noFill/>
-        </p:spPr>
-        <p:txBody>
-          <a:bodyPr wrap="square" anchor="ctr" lIns="0" rIns="0" tIns="0" bIns="0">
-            <a:spAutoFit/>
-          </a:bodyPr>
-          <a:lstStyle/>
-          <a:p>
-            <a:pPr algn="l"/>
-            <a:r>
-              <a:rPr sz="1500" b="0">
-                <a:solidFill>
-                  <a:srgbClr val="55555E"/>
-                </a:solidFill>
-                <a:latin typeface="Arial"/>
-              </a:rPr>
-              <a:t>the task, stated exactly</a:t>
-            </a:r>
-          </a:p>
-        </p:txBody>
-      </p:sp>
-      <p:sp>
-        <p:nvSpPr>
-          <p:cNvPr id="21" name="Letter S"/>
-          <p:cNvSpPr txBox="1"/>
-          <p:nvPr/>
-        </p:nvSpPr>
-        <p:spPr>
-          <a:xfrm>
-            <a:off x="1097280" y="4160520"/>
-            <a:ext cx="457200" cy="384048"/>
-          </a:xfrm>
-          <a:prstGeom prst="rect">
-            <a:avLst/>
-          </a:prstGeom>
-          <a:noFill/>
-        </p:spPr>
-        <p:txBody>
-          <a:bodyPr wrap="square" anchor="ctr" lIns="0" rIns="0" tIns="0" bIns="0">
-            <a:spAutoFit/>
-          </a:bodyPr>
-          <a:lstStyle/>
-          <a:p>
-            <a:pPr algn="l"/>
-            <a:r>
-              <a:rPr sz="2200" b="1">
-                <a:gradFill rotWithShape="1">
-                  <a:gsLst>
-                    <a:gs pos="0">
-                      <a:srgbClr val="6B3FA8"/>
-                    </a:gs>
-                    <a:gs pos="100000">
-                      <a:srgbClr val="C64FC0"/>
-                    </a:gs>
-                  </a:gsLst>
-                  <a:lin ang="0" scaled="0"/>
-                </a:gradFill>
-                <a:latin typeface="Arial"/>
-              </a:rPr>
-              <a:t>S</a:t>
-            </a:r>
-          </a:p>
-        </p:txBody>
-      </p:sp>
-      <p:sp>
-        <p:nvSpPr>
-          <p:cNvPr id="22" name="Word Style"/>
-          <p:cNvSpPr txBox="1"/>
-          <p:nvPr/>
-        </p:nvSpPr>
-        <p:spPr>
-          <a:xfrm>
-            <a:off x="1554480" y="4160520"/>
-            <a:ext cx="1325880" cy="384048"/>
-          </a:xfrm>
-          <a:prstGeom prst="rect">
-            <a:avLst/>
-          </a:prstGeom>
-          <a:noFill/>
-        </p:spPr>
-        <p:txBody>
-          <a:bodyPr wrap="square" anchor="ctr" lIns="0" rIns="0" tIns="0" bIns="0">
-            <a:spAutoFit/>
-          </a:bodyPr>
-          <a:lstStyle/>
-          <a:p>
-            <a:pPr algn="l"/>
-            <a:r>
-              <a:rPr sz="1600" b="1">
-                <a:solidFill>
-                  <a:srgbClr val="222222"/>
-                </a:solidFill>
-                <a:latin typeface="Arial"/>
-              </a:rPr>
-              <a:t>Style</a:t>
-            </a:r>
-          </a:p>
-        </p:txBody>
-      </p:sp>
-      <p:sp>
-        <p:nvSpPr>
-          <p:cNvPr id="23" name="Desc Style"/>
-          <p:cNvSpPr txBox="1"/>
-          <p:nvPr/>
-        </p:nvSpPr>
-        <p:spPr>
-          <a:xfrm>
-            <a:off x="2880360" y="4160520"/>
-            <a:ext cx="4297680" cy="384048"/>
-          </a:xfrm>
-          <a:prstGeom prst="rect">
-            <a:avLst/>
-          </a:prstGeom>
-          <a:noFill/>
-        </p:spPr>
-        <p:txBody>
-          <a:bodyPr wrap="square" anchor="ctr" lIns="0" rIns="0" tIns="0" bIns="0">
-            <a:spAutoFit/>
-          </a:bodyPr>
-          <a:lstStyle/>
-          <a:p>
-            <a:pPr algn="l"/>
-            <a:r>
-              <a:rPr sz="1500" b="0">
-                <a:solidFill>
-                  <a:srgbClr val="55555E"/>
-                </a:solidFill>
-                <a:latin typeface="Arial"/>
-              </a:rPr>
-              <a:t>how it should be written</a:t>
-            </a:r>
-          </a:p>
-        </p:txBody>
-      </p:sp>
-      <p:sp>
-        <p:nvSpPr>
-          <p:cNvPr id="24" name="Letter T"/>
-          <p:cNvSpPr txBox="1"/>
-          <p:nvPr/>
-        </p:nvSpPr>
-        <p:spPr>
-          <a:xfrm>
-            <a:off x="1097280" y="4585716"/>
-            <a:ext cx="457200" cy="384048"/>
-          </a:xfrm>
-          <a:prstGeom prst="rect">
-            <a:avLst/>
-          </a:prstGeom>
-          <a:noFill/>
-        </p:spPr>
-        <p:txBody>
-          <a:bodyPr wrap="square" anchor="ctr" lIns="0" rIns="0" tIns="0" bIns="0">
-            <a:spAutoFit/>
-          </a:bodyPr>
-          <a:lstStyle/>
-          <a:p>
-            <a:pPr algn="l"/>
-            <a:r>
-              <a:rPr sz="2200" b="1">
-                <a:gradFill rotWithShape="1">
-                  <a:gsLst>
-                    <a:gs pos="0">
-                      <a:srgbClr val="6B3FA8"/>
-                    </a:gs>
-                    <a:gs pos="100000">
-                      <a:srgbClr val="C64FC0"/>
-                    </a:gs>
-                  </a:gsLst>
-                  <a:lin ang="0" scaled="0"/>
-                </a:gradFill>
-                <a:latin typeface="Arial"/>
-              </a:rPr>
-              <a:t>T</a:t>
-            </a:r>
-          </a:p>
-        </p:txBody>
-      </p:sp>
-      <p:sp>
-        <p:nvSpPr>
-          <p:cNvPr id="25" name="Word Tone"/>
-          <p:cNvSpPr txBox="1"/>
-          <p:nvPr/>
-        </p:nvSpPr>
-        <p:spPr>
-          <a:xfrm>
-            <a:off x="1554480" y="4585716"/>
-            <a:ext cx="1325880" cy="384048"/>
-          </a:xfrm>
-          <a:prstGeom prst="rect">
-            <a:avLst/>
-          </a:prstGeom>
-          <a:noFill/>
-        </p:spPr>
-        <p:txBody>
-          <a:bodyPr wrap="square" anchor="ctr" lIns="0" rIns="0" tIns="0" bIns="0">
-            <a:spAutoFit/>
-          </a:bodyPr>
-          <a:lstStyle/>
-          <a:p>
-            <a:pPr algn="l"/>
-            <a:r>
-              <a:rPr sz="1600" b="1">
-                <a:solidFill>
-                  <a:srgbClr val="222222"/>
-                </a:solidFill>
-                <a:latin typeface="Arial"/>
-              </a:rPr>
-              <a:t>Tone</a:t>
-            </a:r>
-          </a:p>
-        </p:txBody>
-      </p:sp>
-      <p:sp>
-        <p:nvSpPr>
-          <p:cNvPr id="26" name="Desc Tone"/>
-          <p:cNvSpPr txBox="1"/>
-          <p:nvPr/>
-        </p:nvSpPr>
-        <p:spPr>
-          <a:xfrm>
-            <a:off x="2880360" y="4585716"/>
-            <a:ext cx="4297680" cy="384048"/>
-          </a:xfrm>
-          <a:prstGeom prst="rect">
-            <a:avLst/>
-          </a:prstGeom>
-          <a:noFill/>
-        </p:spPr>
-        <p:txBody>
-          <a:bodyPr wrap="square" anchor="ctr" lIns="0" rIns="0" tIns="0" bIns="0">
-            <a:spAutoFit/>
-          </a:bodyPr>
-          <a:lstStyle/>
-          <a:p>
-            <a:pPr algn="l"/>
-            <a:r>
-              <a:rPr sz="1500" b="0">
-                <a:solidFill>
-                  <a:srgbClr val="55555E"/>
-                </a:solidFill>
-                <a:latin typeface="Arial"/>
-              </a:rPr>
-              <a:t>how it should feel to the reader</a:t>
-            </a:r>
-          </a:p>
-        </p:txBody>
-      </p:sp>
-      <p:sp>
-        <p:nvSpPr>
-          <p:cNvPr id="27" name="Letter A"/>
-          <p:cNvSpPr txBox="1"/>
-          <p:nvPr/>
-        </p:nvSpPr>
-        <p:spPr>
-          <a:xfrm>
-            <a:off x="1097280" y="5010912"/>
-            <a:ext cx="457200" cy="384048"/>
-          </a:xfrm>
-          <a:prstGeom prst="rect">
-            <a:avLst/>
-          </a:prstGeom>
-          <a:noFill/>
-        </p:spPr>
-        <p:txBody>
-          <a:bodyPr wrap="square" anchor="ctr" lIns="0" rIns="0" tIns="0" bIns="0">
-            <a:spAutoFit/>
-          </a:bodyPr>
-          <a:lstStyle/>
-          <a:p>
-            <a:pPr algn="l"/>
-            <a:r>
-              <a:rPr sz="2200" b="1">
-                <a:gradFill rotWithShape="1">
-                  <a:gsLst>
-                    <a:gs pos="0">
-                      <a:srgbClr val="6B3FA8"/>
-                    </a:gs>
-                    <a:gs pos="100000">
-                      <a:srgbClr val="C64FC0"/>
-                    </a:gs>
-                  </a:gsLst>
-                  <a:lin ang="0" scaled="0"/>
-                </a:gradFill>
-                <a:latin typeface="Arial"/>
-              </a:rPr>
-              <a:t>A</a:t>
-            </a:r>
-          </a:p>
-        </p:txBody>
-      </p:sp>
-      <p:sp>
-        <p:nvSpPr>
-          <p:cNvPr id="28" name="Word Audience"/>
-          <p:cNvSpPr txBox="1"/>
-          <p:nvPr/>
-        </p:nvSpPr>
-        <p:spPr>
-          <a:xfrm>
-            <a:off x="1554480" y="5010912"/>
-            <a:ext cx="1325880" cy="384048"/>
-          </a:xfrm>
-          <a:prstGeom prst="rect">
-            <a:avLst/>
-          </a:prstGeom>
-          <a:noFill/>
-        </p:spPr>
-        <p:txBody>
-          <a:bodyPr wrap="square" anchor="ctr" lIns="0" rIns="0" tIns="0" bIns="0">
-            <a:spAutoFit/>
-          </a:bodyPr>
-          <a:lstStyle/>
-          <a:p>
-            <a:pPr algn="l"/>
-            <a:r>
-              <a:rPr sz="1600" b="1">
-                <a:solidFill>
-                  <a:srgbClr val="222222"/>
-                </a:solidFill>
-                <a:latin typeface="Arial"/>
-              </a:rPr>
-              <a:t>Audience</a:t>
-            </a:r>
-          </a:p>
-        </p:txBody>
-      </p:sp>
-      <p:sp>
-        <p:nvSpPr>
-          <p:cNvPr id="29" name="Desc Audience"/>
-          <p:cNvSpPr txBox="1"/>
-          <p:nvPr/>
-        </p:nvSpPr>
-        <p:spPr>
-          <a:xfrm>
-            <a:off x="2880360" y="5010912"/>
-            <a:ext cx="4297680" cy="384048"/>
-          </a:xfrm>
-          <a:prstGeom prst="rect">
-            <a:avLst/>
-          </a:prstGeom>
-          <a:noFill/>
-        </p:spPr>
-        <p:txBody>
-          <a:bodyPr wrap="square" anchor="ctr" lIns="0" rIns="0" tIns="0" bIns="0">
-            <a:spAutoFit/>
-          </a:bodyPr>
-          <a:lstStyle/>
-          <a:p>
-            <a:pPr algn="l"/>
-            <a:r>
-              <a:rPr sz="1500" b="0">
-                <a:solidFill>
-                  <a:srgbClr val="55555E"/>
-                </a:solidFill>
-                <a:latin typeface="Arial"/>
-              </a:rPr>
-              <a:t>who will read it</a:t>
-            </a:r>
-          </a:p>
-        </p:txBody>
-      </p:sp>
-      <p:sp>
-        <p:nvSpPr>
-          <p:cNvPr id="30" name="Letter R"/>
-          <p:cNvSpPr txBox="1"/>
-          <p:nvPr/>
-        </p:nvSpPr>
-        <p:spPr>
-          <a:xfrm>
-            <a:off x="1097280" y="5436108"/>
-            <a:ext cx="457200" cy="384048"/>
-          </a:xfrm>
-          <a:prstGeom prst="rect">
-            <a:avLst/>
-          </a:prstGeom>
-          <a:noFill/>
-        </p:spPr>
-        <p:txBody>
-          <a:bodyPr wrap="square" anchor="ctr" lIns="0" rIns="0" tIns="0" bIns="0">
-            <a:spAutoFit/>
-          </a:bodyPr>
-          <a:lstStyle/>
-          <a:p>
-            <a:pPr algn="l"/>
-            <a:r>
-              <a:rPr sz="2200" b="1">
-                <a:gradFill rotWithShape="1">
-                  <a:gsLst>
-                    <a:gs pos="0">
-                      <a:srgbClr val="6B3FA8"/>
-                    </a:gs>
-                    <a:gs pos="100000">
-                      <a:srgbClr val="C64FC0"/>
-                    </a:gs>
-                  </a:gsLst>
-                  <a:lin ang="0" scaled="0"/>
-                </a:gradFill>
-                <a:latin typeface="Arial"/>
-              </a:rPr>
-              <a:t>R</a:t>
-            </a:r>
-          </a:p>
-        </p:txBody>
-      </p:sp>
-      <p:sp>
-        <p:nvSpPr>
-          <p:cNvPr id="31" name="Word Response"/>
-          <p:cNvSpPr txBox="1"/>
-          <p:nvPr/>
-        </p:nvSpPr>
-        <p:spPr>
-          <a:xfrm>
-            <a:off x="1554480" y="5436108"/>
-            <a:ext cx="1325880" cy="384048"/>
-          </a:xfrm>
-          <a:prstGeom prst="rect">
-            <a:avLst/>
-          </a:prstGeom>
-          <a:noFill/>
-        </p:spPr>
-        <p:txBody>
-          <a:bodyPr wrap="square" anchor="ctr" lIns="0" rIns="0" tIns="0" bIns="0">
-            <a:spAutoFit/>
-          </a:bodyPr>
-          <a:lstStyle/>
-          <a:p>
-            <a:pPr algn="l"/>
-            <a:r>
-              <a:rPr sz="1600" b="1">
-                <a:solidFill>
-                  <a:srgbClr val="222222"/>
-                </a:solidFill>
-                <a:latin typeface="Arial"/>
-              </a:rPr>
-              <a:t>Response</a:t>
-            </a:r>
-          </a:p>
-        </p:txBody>
-      </p:sp>
-      <p:sp>
-        <p:nvSpPr>
-          <p:cNvPr id="32" name="Desc Response"/>
-          <p:cNvSpPr txBox="1"/>
-          <p:nvPr/>
-        </p:nvSpPr>
-        <p:spPr>
-          <a:xfrm>
-            <a:off x="2880360" y="5436108"/>
-            <a:ext cx="4297680" cy="384048"/>
-          </a:xfrm>
-          <a:prstGeom prst="rect">
-            <a:avLst/>
-          </a:prstGeom>
-          <a:noFill/>
-        </p:spPr>
-        <p:txBody>
-          <a:bodyPr wrap="square" anchor="ctr" lIns="0" rIns="0" tIns="0" bIns="0">
-            <a:spAutoFit/>
-          </a:bodyPr>
-          <a:lstStyle/>
-          <a:p>
-            <a:pPr algn="l"/>
-            <a:r>
-              <a:rPr sz="1500" b="0">
-                <a:solidFill>
-                  <a:srgbClr val="55555E"/>
-                </a:solidFill>
-                <a:latin typeface="Arial"/>
-              </a:rPr>
-              <a:t>format, length and language of the answer</a:t>
-            </a:r>
-          </a:p>
-        </p:txBody>
-      </p:sp>
-      <p:sp>
-        <p:nvSpPr>
-          <p:cNvPr id="33" name="Steps"/>
-          <p:cNvSpPr txBox="1"/>
-          <p:nvPr/>
-        </p:nvSpPr>
-        <p:spPr>
-          <a:xfrm>
-            <a:off x="7818120" y="3310128"/>
-            <a:ext cx="3703320" cy="2560320"/>
-          </a:xfrm>
-          <a:prstGeom prst="rect">
-            <a:avLst/>
-          </a:prstGeom>
-          <a:noFill/>
-        </p:spPr>
-        <p:txBody>
-          <a:bodyPr wrap="square" anchor="t" lIns="0" rIns="0" tIns="0" bIns="0">
-            <a:spAutoFit/>
-          </a:bodyPr>
-          <a:lstStyle/>
-          <a:p>
-            <a:pPr algn="l">
-              <a:spcAft>
-                <a:spcPts val="1400"/>
-              </a:spcAft>
-            </a:pPr>
-            <a:r>
-              <a:rPr sz="1600" b="1">
-                <a:gradFill rotWithShape="1">
-                  <a:gsLst>
-                    <a:gs pos="0">
-                      <a:srgbClr val="6B3FA8"/>
-                    </a:gs>
-                    <a:gs pos="100000">
-                      <a:srgbClr val="C64FC0"/>
-                    </a:gs>
-                  </a:gsLst>
-                  <a:lin ang="0" scaled="0"/>
-                </a:gradFill>
-                <a:latin typeface="Arial"/>
-              </a:rPr>
-              <a:t>1.  </a:t>
-            </a:r>
-            <a:r>
-              <a:rPr sz="1600" b="0">
-                <a:solidFill>
-                  <a:srgbClr val="222222"/>
-                </a:solidFill>
-                <a:latin typeface="Arial"/>
-              </a:rPr>
-              <a:t>Fill the six boxes before you press enter.</a:t>
-            </a:r>
-          </a:p>
-          <a:p>
-            <a:pPr algn="l">
-              <a:spcAft>
-                <a:spcPts val="1400"/>
-              </a:spcAft>
-            </a:pPr>
-            <a:r>
-              <a:rPr sz="1600" b="1">
-                <a:gradFill rotWithShape="1">
-                  <a:gsLst>
-                    <a:gs pos="0">
-                      <a:srgbClr val="6B3FA8"/>
-                    </a:gs>
-                    <a:gs pos="100000">
-                      <a:srgbClr val="C64FC0"/>
-                    </a:gs>
-                  </a:gsLst>
-                  <a:lin ang="0" scaled="0"/>
-                </a:gradFill>
-                <a:latin typeface="Arial"/>
-              </a:rPr>
-              <a:t>2.  </a:t>
-            </a:r>
-            <a:r>
-              <a:rPr sz="1600" b="0">
-                <a:solidFill>
-                  <a:srgbClr val="222222"/>
-                </a:solidFill>
-                <a:latin typeface="Arial"/>
-              </a:rPr>
-              <a:t>Skip what you do not need.</a:t>
-            </a:r>
-          </a:p>
-          <a:p>
-            <a:pPr algn="l">
-              <a:spcAft>
-                <a:spcPts val="1400"/>
-              </a:spcAft>
-            </a:pPr>
-            <a:r>
-              <a:rPr sz="1600" b="1">
-                <a:gradFill rotWithShape="1">
-                  <a:gsLst>
-                    <a:gs pos="0">
-                      <a:srgbClr val="6B3FA8"/>
-                    </a:gs>
-                    <a:gs pos="100000">
-                      <a:srgbClr val="C64FC0"/>
-                    </a:gs>
-                  </a:gsLst>
-                  <a:lin ang="0" scaled="0"/>
-                </a:gradFill>
-                <a:latin typeface="Arial"/>
-              </a:rPr>
-              <a:t>3.  </a:t>
-            </a:r>
-            <a:r>
-              <a:rPr sz="1600" b="0">
-                <a:solidFill>
-                  <a:srgbClr val="222222"/>
-                </a:solidFill>
-                <a:latin typeface="Arial"/>
-              </a:rPr>
-              <a:t>R does the heavy lifting: exact format, length and language.</a:t>
-            </a:r>
-          </a:p>
-          <a:p>
-            <a:pPr algn="l">
-              <a:spcAft>
-                <a:spcPts val="1400"/>
-              </a:spcAft>
-            </a:pPr>
-            <a:r>
-              <a:rPr sz="1600" b="1">
-                <a:gradFill rotWithShape="1">
-                  <a:gsLst>
-                    <a:gs pos="0">
-                      <a:srgbClr val="6B3FA8"/>
-                    </a:gs>
-                    <a:gs pos="100000">
-                      <a:srgbClr val="C64FC0"/>
-                    </a:gs>
-                  </a:gsLst>
-                  <a:lin ang="0" scaled="0"/>
-                </a:gradFill>
-                <a:latin typeface="Arial"/>
-              </a:rPr>
-              <a:t>4.  </a:t>
-            </a:r>
-            <a:r>
-              <a:rPr sz="1600" b="0">
-                <a:solidFill>
-                  <a:srgbClr val="222222"/>
-                </a:solidFill>
-                <a:latin typeface="Arial"/>
-              </a:rPr>
-              <a:t>Not happy? Refine and ask again.</a:t>
-            </a:r>
-          </a:p>
-        </p:txBody>
-      </p:sp>
     </p:spTree>
   </p:cSld>
   <p:clrMapOvr>
@@ -4892,7 +3659,7 @@
       <p:grpSpPr/>
       <p:pic>
         <p:nvPicPr>
-          <p:cNvPr id="2" name="Background" descr="bg.jpg"/>
+          <p:cNvPr id="2" name="COSTAR, filled in" descr="COSTAR, filled in"/>
           <p:cNvPicPr>
             <a:picLocks noChangeAspect="1"/>
           </p:cNvPicPr>
@@ -4907,1593 +3674,13 @@
         <p:spPr>
           <a:xfrm>
             <a:off x="0" y="0"/>
-            <a:ext cx="12191695" cy="6858000"/>
+            <a:ext cx="12192000" cy="6858000"/>
           </a:xfrm>
           <a:prstGeom prst="rect">
             <a:avLst/>
           </a:prstGeom>
         </p:spPr>
       </p:pic>
-      <p:sp>
-        <p:nvSpPr>
-          <p:cNvPr id="3" name="Nav Home"/>
-          <p:cNvSpPr txBox="1"/>
-          <p:nvPr/>
-        </p:nvSpPr>
-        <p:spPr>
-          <a:xfrm>
-            <a:off x="4160520" y="502920"/>
-            <a:ext cx="1463040" cy="365760"/>
-          </a:xfrm>
-          <a:prstGeom prst="rect">
-            <a:avLst/>
-          </a:prstGeom>
-          <a:noFill/>
-        </p:spPr>
-        <p:txBody>
-          <a:bodyPr wrap="square" anchor="ctr" lIns="0" rIns="0" tIns="0" bIns="0">
-            <a:spAutoFit/>
-          </a:bodyPr>
-          <a:lstStyle/>
-          <a:p>
-            <a:pPr algn="ctr"/>
-            <a:r>
-              <a:rPr sz="1600" b="0">
-                <a:solidFill>
-                  <a:srgbClr val="222222"/>
-                </a:solidFill>
-                <a:latin typeface="Arial"/>
-              </a:rPr>
-              <a:t>Home</a:t>
-            </a:r>
-          </a:p>
-        </p:txBody>
-      </p:sp>
-      <p:sp>
-        <p:nvSpPr>
-          <p:cNvPr id="4" name="Nav Activity"/>
-          <p:cNvSpPr txBox="1"/>
-          <p:nvPr/>
-        </p:nvSpPr>
-        <p:spPr>
-          <a:xfrm>
-            <a:off x="5715000" y="502920"/>
-            <a:ext cx="1463040" cy="365760"/>
-          </a:xfrm>
-          <a:prstGeom prst="rect">
-            <a:avLst/>
-          </a:prstGeom>
-          <a:noFill/>
-        </p:spPr>
-        <p:txBody>
-          <a:bodyPr wrap="square" anchor="ctr" lIns="0" rIns="0" tIns="0" bIns="0">
-            <a:spAutoFit/>
-          </a:bodyPr>
-          <a:lstStyle/>
-          <a:p>
-            <a:pPr algn="ctr"/>
-            <a:r>
-              <a:rPr sz="1600" b="1">
-                <a:solidFill>
-                  <a:srgbClr val="222222"/>
-                </a:solidFill>
-                <a:latin typeface="Arial"/>
-              </a:rPr>
-              <a:t>Activity</a:t>
-            </a:r>
-          </a:p>
-        </p:txBody>
-      </p:sp>
-      <p:sp>
-        <p:nvSpPr>
-          <p:cNvPr id="5" name="Nav Discussion"/>
-          <p:cNvSpPr txBox="1"/>
-          <p:nvPr/>
-        </p:nvSpPr>
-        <p:spPr>
-          <a:xfrm>
-            <a:off x="7269480" y="502920"/>
-            <a:ext cx="1463040" cy="365760"/>
-          </a:xfrm>
-          <a:prstGeom prst="rect">
-            <a:avLst/>
-          </a:prstGeom>
-          <a:noFill/>
-        </p:spPr>
-        <p:txBody>
-          <a:bodyPr wrap="square" anchor="ctr" lIns="0" rIns="0" tIns="0" bIns="0">
-            <a:spAutoFit/>
-          </a:bodyPr>
-          <a:lstStyle/>
-          <a:p>
-            <a:pPr algn="ctr"/>
-            <a:r>
-              <a:rPr sz="1600" b="0">
-                <a:solidFill>
-                  <a:srgbClr val="222222"/>
-                </a:solidFill>
-                <a:latin typeface="Arial"/>
-              </a:rPr>
-              <a:t>Discussion</a:t>
-            </a:r>
-          </a:p>
-        </p:txBody>
-      </p:sp>
-      <p:pic>
-        <p:nvPicPr>
-          <p:cNvPr id="6" name="OCBC logo" descr="ocbc-logo.png"/>
-          <p:cNvPicPr>
-            <a:picLocks noChangeAspect="1"/>
-          </p:cNvPicPr>
-          <p:nvPr/>
-        </p:nvPicPr>
-        <p:blipFill>
-          <a:blip r:embed="rId3"/>
-          <a:stretch>
-            <a:fillRect/>
-          </a:stretch>
-        </p:blipFill>
-        <p:spPr>
-          <a:xfrm>
-            <a:off x="9921240" y="457200"/>
-            <a:ext cx="1451786" cy="393192"/>
-          </a:xfrm>
-          <a:prstGeom prst="rect">
-            <a:avLst/>
-          </a:prstGeom>
-        </p:spPr>
-      </p:pic>
-      <p:cxnSp>
-        <p:nvCxnSpPr>
-          <p:cNvPr id="7" name="Nav rule"/>
-          <p:cNvCxnSpPr/>
-          <p:nvPr/>
-        </p:nvCxnSpPr>
-        <p:spPr>
-          <a:xfrm>
-            <a:off x="731520" y="1097280"/>
-            <a:ext cx="10725912" cy="0"/>
-          </a:xfrm>
-          <a:prstGeom prst="line">
-            <a:avLst/>
-          </a:prstGeom>
-          <a:ln w="12700">
-            <a:solidFill>
-              <a:srgbClr val="5A5A60"/>
-            </a:solidFill>
-          </a:ln>
-        </p:spPr>
-      </p:cxnSp>
-      <p:sp>
-        <p:nvSpPr>
-          <p:cNvPr id="8" name="Kicker"/>
-          <p:cNvSpPr txBox="1"/>
-          <p:nvPr/>
-        </p:nvSpPr>
-        <p:spPr>
-          <a:xfrm>
-            <a:off x="777240" y="1298448"/>
-            <a:ext cx="7315200" cy="502920"/>
-          </a:xfrm>
-          <a:prstGeom prst="rect">
-            <a:avLst/>
-          </a:prstGeom>
-          <a:noFill/>
-        </p:spPr>
-        <p:txBody>
-          <a:bodyPr wrap="square" anchor="t" lIns="0" rIns="0" tIns="0" bIns="0">
-            <a:spAutoFit/>
-          </a:bodyPr>
-          <a:lstStyle/>
-          <a:p>
-            <a:pPr algn="l"/>
-            <a:r>
-              <a:rPr sz="3000" b="1">
-                <a:solidFill>
-                  <a:srgbClr val="222222"/>
-                </a:solidFill>
-                <a:latin typeface="Arial"/>
-              </a:rPr>
-              <a:t>PROMPTING</a:t>
-            </a:r>
-          </a:p>
-        </p:txBody>
-      </p:sp>
-      <p:sp>
-        <p:nvSpPr>
-          <p:cNvPr id="9" name="Title"/>
-          <p:cNvSpPr txBox="1"/>
-          <p:nvPr/>
-        </p:nvSpPr>
-        <p:spPr>
-          <a:xfrm>
-            <a:off x="777240" y="1783080"/>
-            <a:ext cx="10515600" cy="822960"/>
-          </a:xfrm>
-          <a:prstGeom prst="rect">
-            <a:avLst/>
-          </a:prstGeom>
-          <a:noFill/>
-        </p:spPr>
-        <p:txBody>
-          <a:bodyPr wrap="square" anchor="t" lIns="0" rIns="0" tIns="0" bIns="0">
-            <a:spAutoFit/>
-          </a:bodyPr>
-          <a:lstStyle/>
-          <a:p>
-            <a:pPr algn="l"/>
-            <a:r>
-              <a:rPr sz="5000" b="1">
-                <a:gradFill rotWithShape="1">
-                  <a:gsLst>
-                    <a:gs pos="0">
-                      <a:srgbClr val="6B3FA8"/>
-                    </a:gs>
-                    <a:gs pos="100000">
-                      <a:srgbClr val="C64FC0"/>
-                    </a:gs>
-                  </a:gsLst>
-                  <a:lin ang="0" scaled="0"/>
-                </a:gradFill>
-                <a:latin typeface="Arial"/>
-              </a:rPr>
-              <a:t>COSTAR, FILLED IN</a:t>
-            </a:r>
-          </a:p>
-        </p:txBody>
-      </p:sp>
-      <p:sp>
-        <p:nvSpPr>
-          <p:cNvPr id="10" name="Gradient bar"/>
-          <p:cNvSpPr/>
-          <p:nvPr/>
-        </p:nvSpPr>
-        <p:spPr>
-          <a:xfrm>
-            <a:off x="347472" y="6199632"/>
-            <a:ext cx="11503152" cy="658368"/>
-          </a:xfrm>
-          <a:prstGeom prst="rect">
-            <a:avLst/>
-          </a:prstGeom>
-          <a:gradFill rotWithShape="1">
-            <a:gsLst>
-              <a:gs pos="0">
-                <a:srgbClr val="7A3CC8"/>
-              </a:gs>
-              <a:gs pos="55000">
-                <a:srgbClr val="D774D6"/>
-              </a:gs>
-              <a:gs pos="100000">
-                <a:srgbClr val="8B40C8"/>
-              </a:gs>
-            </a:gsLst>
-            <a:lin ang="0" scaled="0"/>
-          </a:gradFill>
-          <a:ln>
-            <a:noFill/>
-          </a:ln>
-        </p:spPr>
-        <p:txBody>
-          <a:bodyPr rtlCol="0" anchor="ctr"/>
-          <a:lstStyle/>
-          <a:p>
-            <a:pPr algn="ctr"/>
-          </a:p>
-        </p:txBody>
-      </p:sp>
-      <p:sp>
-        <p:nvSpPr>
-          <p:cNvPr id="11" name="Label PROMPT"/>
-          <p:cNvSpPr txBox="1"/>
-          <p:nvPr/>
-        </p:nvSpPr>
-        <p:spPr>
-          <a:xfrm>
-            <a:off x="914400" y="2834640"/>
-            <a:ext cx="4572000" cy="274320"/>
-          </a:xfrm>
-          <a:prstGeom prst="rect">
-            <a:avLst/>
-          </a:prstGeom>
-          <a:noFill/>
-        </p:spPr>
-        <p:txBody>
-          <a:bodyPr wrap="square" anchor="t" lIns="0" rIns="0" tIns="0" bIns="0">
-            <a:spAutoFit/>
-          </a:bodyPr>
-          <a:lstStyle/>
-          <a:p>
-            <a:pPr algn="l"/>
-            <a:r>
-              <a:rPr sz="1500" b="1">
-                <a:solidFill>
-                  <a:srgbClr val="222222"/>
-                </a:solidFill>
-                <a:latin typeface="Arial"/>
-              </a:rPr>
-              <a:t>PROMPT</a:t>
-            </a:r>
-          </a:p>
-        </p:txBody>
-      </p:sp>
-      <p:sp>
-        <p:nvSpPr>
-          <p:cNvPr id="12" name="Label RESULT"/>
-          <p:cNvSpPr txBox="1"/>
-          <p:nvPr/>
-        </p:nvSpPr>
-        <p:spPr>
-          <a:xfrm>
-            <a:off x="6263640" y="2834640"/>
-            <a:ext cx="4572000" cy="274320"/>
-          </a:xfrm>
-          <a:prstGeom prst="rect">
-            <a:avLst/>
-          </a:prstGeom>
-          <a:noFill/>
-        </p:spPr>
-        <p:txBody>
-          <a:bodyPr wrap="square" anchor="t" lIns="0" rIns="0" tIns="0" bIns="0">
-            <a:spAutoFit/>
-          </a:bodyPr>
-          <a:lstStyle/>
-          <a:p>
-            <a:pPr algn="l"/>
-            <a:r>
-              <a:rPr sz="1500" b="1">
-                <a:solidFill>
-                  <a:srgbClr val="222222"/>
-                </a:solidFill>
-                <a:latin typeface="Arial"/>
-              </a:rPr>
-              <a:t>RESULT</a:t>
-            </a:r>
-          </a:p>
-        </p:txBody>
-      </p:sp>
-      <p:sp>
-        <p:nvSpPr>
-          <p:cNvPr id="13" name="Prompt card"/>
-          <p:cNvSpPr/>
-          <p:nvPr/>
-        </p:nvSpPr>
-        <p:spPr>
-          <a:xfrm>
-            <a:off x="868680" y="3154680"/>
-            <a:ext cx="5120640" cy="2880360"/>
-          </a:xfrm>
-          <a:prstGeom prst="rect">
-            <a:avLst/>
-          </a:prstGeom>
-          <a:solidFill>
-            <a:srgbClr val="FFFFFF">
-              <a:alpha val="96000"/>
-            </a:srgbClr>
-          </a:solidFill>
-          <a:ln>
-            <a:noFill/>
-          </a:ln>
-        </p:spPr>
-        <p:txBody>
-          <a:bodyPr rtlCol="0" anchor="ctr"/>
-          <a:lstStyle/>
-          <a:p>
-            <a:pPr algn="ctr"/>
-          </a:p>
-        </p:txBody>
-      </p:sp>
-      <p:sp>
-        <p:nvSpPr>
-          <p:cNvPr id="14" name="Result card"/>
-          <p:cNvSpPr/>
-          <p:nvPr/>
-        </p:nvSpPr>
-        <p:spPr>
-          <a:xfrm>
-            <a:off x="6263640" y="3154680"/>
-            <a:ext cx="5440680" cy="2880360"/>
-          </a:xfrm>
-          <a:prstGeom prst="rect">
-            <a:avLst/>
-          </a:prstGeom>
-          <a:solidFill>
-            <a:srgbClr val="FFFFFF">
-              <a:alpha val="96000"/>
-            </a:srgbClr>
-          </a:solidFill>
-          <a:ln>
-            <a:noFill/>
-          </a:ln>
-        </p:spPr>
-        <p:txBody>
-          <a:bodyPr rtlCol="0" anchor="ctr"/>
-          <a:lstStyle/>
-          <a:p>
-            <a:pPr algn="ctr"/>
-          </a:p>
-        </p:txBody>
-      </p:sp>
-      <p:sp>
-        <p:nvSpPr>
-          <p:cNvPr id="15" name="Prompt"/>
-          <p:cNvSpPr txBox="1"/>
-          <p:nvPr/>
-        </p:nvSpPr>
-        <p:spPr>
-          <a:xfrm>
-            <a:off x="1051560" y="3273552"/>
-            <a:ext cx="4800600" cy="2697480"/>
-          </a:xfrm>
-          <a:prstGeom prst="rect">
-            <a:avLst/>
-          </a:prstGeom>
-          <a:noFill/>
-        </p:spPr>
-        <p:txBody>
-          <a:bodyPr wrap="square" lIns="0" rIns="0" tIns="0" bIns="0">
-            <a:spAutoFit/>
-          </a:bodyPr>
-          <a:lstStyle/>
-          <a:p>
-            <a:pPr marL="347472" indent="-347472">
-              <a:spcAft>
-                <a:spcPts val="500"/>
-              </a:spcAft>
-              <a:tabLst>
-                <a:tab pos="347472" algn="l"/>
-              </a:tabLst>
-            </a:pPr>
-            <a:r>
-              <a:rPr sz="1500" b="1">
-                <a:gradFill rotWithShape="1">
-                  <a:gsLst>
-                    <a:gs pos="0">
-                      <a:srgbClr val="6B3FA8"/>
-                    </a:gs>
-                    <a:gs pos="100000">
-                      <a:srgbClr val="C64FC0"/>
-                    </a:gs>
-                  </a:gsLst>
-                  <a:lin ang="0" scaled="0"/>
-                </a:gradFill>
-                <a:latin typeface="Arial"/>
-              </a:rPr>
-              <a:t>C	</a:t>
-            </a:r>
-            <a:r>
-              <a:rPr sz="1400" b="0">
-                <a:solidFill>
-                  <a:srgbClr val="222222"/>
-                </a:solidFill>
-                <a:latin typeface="Arial"/>
-              </a:rPr>
-              <a:t>Saya team leader operasional cabang. Di bawah saya tempel </a:t>
-            </a:r>
-            <a:r>
-              <a:rPr sz="1400" b="1">
-                <a:solidFill>
-                  <a:srgbClr val="222222"/>
-                </a:solidFill>
-                <a:latin typeface="Arial"/>
-              </a:rPr>
-              <a:t>catatan komplain nasabah</a:t>
-            </a:r>
-            <a:r>
-              <a:rPr sz="1400" b="0">
-                <a:solidFill>
-                  <a:srgbClr val="222222"/>
-                </a:solidFill>
-                <a:latin typeface="Arial"/>
-              </a:rPr>
-              <a:t> minggu ini.</a:t>
-            </a:r>
-          </a:p>
-          <a:p>
-            <a:pPr marL="347472" indent="-347472">
-              <a:spcAft>
-                <a:spcPts val="500"/>
-              </a:spcAft>
-              <a:tabLst>
-                <a:tab pos="347472" algn="l"/>
-              </a:tabLst>
-            </a:pPr>
-            <a:r>
-              <a:rPr sz="1500" b="1">
-                <a:gradFill rotWithShape="1">
-                  <a:gsLst>
-                    <a:gs pos="0">
-                      <a:srgbClr val="6B3FA8"/>
-                    </a:gs>
-                    <a:gs pos="100000">
-                      <a:srgbClr val="C64FC0"/>
-                    </a:gs>
-                  </a:gsLst>
-                  <a:lin ang="0" scaled="0"/>
-                </a:gradFill>
-                <a:latin typeface="Arial"/>
-              </a:rPr>
-              <a:t>O	</a:t>
-            </a:r>
-            <a:r>
-              <a:rPr sz="1400" b="0">
-                <a:solidFill>
-                  <a:srgbClr val="222222"/>
-                </a:solidFill>
-                <a:latin typeface="Arial"/>
-              </a:rPr>
-              <a:t>Buat </a:t>
-            </a:r>
-            <a:r>
-              <a:rPr sz="1400" b="1">
-                <a:solidFill>
-                  <a:srgbClr val="222222"/>
-                </a:solidFill>
-                <a:latin typeface="Arial"/>
-              </a:rPr>
-              <a:t>laporan rekap komplain</a:t>
-            </a:r>
-            <a:r>
-              <a:rPr sz="1400" b="0">
-                <a:solidFill>
-                  <a:srgbClr val="222222"/>
-                </a:solidFill>
-                <a:latin typeface="Arial"/>
-              </a:rPr>
-              <a:t> berbentuk tabel.</a:t>
-            </a:r>
-          </a:p>
-          <a:p>
-            <a:pPr marL="347472" indent="-347472">
-              <a:spcAft>
-                <a:spcPts val="500"/>
-              </a:spcAft>
-              <a:tabLst>
-                <a:tab pos="347472" algn="l"/>
-              </a:tabLst>
-            </a:pPr>
-            <a:r>
-              <a:rPr sz="1500" b="1">
-                <a:gradFill rotWithShape="1">
-                  <a:gsLst>
-                    <a:gs pos="0">
-                      <a:srgbClr val="6B3FA8"/>
-                    </a:gs>
-                    <a:gs pos="100000">
-                      <a:srgbClr val="C64FC0"/>
-                    </a:gs>
-                  </a:gsLst>
-                  <a:lin ang="0" scaled="0"/>
-                </a:gradFill>
-                <a:latin typeface="Arial"/>
-              </a:rPr>
-              <a:t>S	</a:t>
-            </a:r>
-            <a:r>
-              <a:rPr sz="1400" b="1">
-                <a:solidFill>
-                  <a:srgbClr val="222222"/>
-                </a:solidFill>
-                <a:latin typeface="Arial"/>
-              </a:rPr>
-              <a:t>Ringkas dan rapi</a:t>
-            </a:r>
-            <a:r>
-              <a:rPr sz="1400" b="0">
-                <a:solidFill>
-                  <a:srgbClr val="222222"/>
-                </a:solidFill>
-                <a:latin typeface="Arial"/>
-              </a:rPr>
-              <a:t>, siap tempel ke email.</a:t>
-            </a:r>
-          </a:p>
-          <a:p>
-            <a:pPr marL="347472" indent="-347472">
-              <a:spcAft>
-                <a:spcPts val="500"/>
-              </a:spcAft>
-              <a:tabLst>
-                <a:tab pos="347472" algn="l"/>
-              </a:tabLst>
-            </a:pPr>
-            <a:r>
-              <a:rPr sz="1500" b="1">
-                <a:gradFill rotWithShape="1">
-                  <a:gsLst>
-                    <a:gs pos="0">
-                      <a:srgbClr val="6B3FA8"/>
-                    </a:gs>
-                    <a:gs pos="100000">
-                      <a:srgbClr val="C64FC0"/>
-                    </a:gs>
-                  </a:gsLst>
-                  <a:lin ang="0" scaled="0"/>
-                </a:gradFill>
-                <a:latin typeface="Arial"/>
-              </a:rPr>
-              <a:t>T	</a:t>
-            </a:r>
-            <a:r>
-              <a:rPr sz="1400" b="1">
-                <a:solidFill>
-                  <a:srgbClr val="222222"/>
-                </a:solidFill>
-                <a:latin typeface="Arial"/>
-              </a:rPr>
-              <a:t>Netral dan faktual.</a:t>
-            </a:r>
-          </a:p>
-          <a:p>
-            <a:pPr marL="347472" indent="-347472">
-              <a:spcAft>
-                <a:spcPts val="500"/>
-              </a:spcAft>
-              <a:tabLst>
-                <a:tab pos="347472" algn="l"/>
-              </a:tabLst>
-            </a:pPr>
-            <a:r>
-              <a:rPr sz="1500" b="1">
-                <a:gradFill rotWithShape="1">
-                  <a:gsLst>
-                    <a:gs pos="0">
-                      <a:srgbClr val="6B3FA8"/>
-                    </a:gs>
-                    <a:gs pos="100000">
-                      <a:srgbClr val="C64FC0"/>
-                    </a:gs>
-                  </a:gsLst>
-                  <a:lin ang="0" scaled="0"/>
-                </a:gradFill>
-                <a:latin typeface="Arial"/>
-              </a:rPr>
-              <a:t>A	</a:t>
-            </a:r>
-            <a:r>
-              <a:rPr sz="1400" b="0">
-                <a:solidFill>
-                  <a:srgbClr val="222222"/>
-                </a:solidFill>
-                <a:latin typeface="Arial"/>
-              </a:rPr>
-              <a:t>Kepala cabang, membaca dalam </a:t>
-            </a:r>
-            <a:r>
-              <a:rPr sz="1400" b="1">
-                <a:solidFill>
-                  <a:srgbClr val="222222"/>
-                </a:solidFill>
-                <a:latin typeface="Arial"/>
-              </a:rPr>
-              <a:t>1 menit</a:t>
-            </a:r>
-            <a:r>
-              <a:rPr sz="1400" b="0">
-                <a:solidFill>
-                  <a:srgbClr val="222222"/>
-                </a:solidFill>
-                <a:latin typeface="Arial"/>
-              </a:rPr>
-              <a:t>.</a:t>
-            </a:r>
-          </a:p>
-          <a:p>
-            <a:pPr marL="347472" indent="-347472">
-              <a:spcAft>
-                <a:spcPts val="500"/>
-              </a:spcAft>
-              <a:tabLst>
-                <a:tab pos="347472" algn="l"/>
-              </a:tabLst>
-            </a:pPr>
-            <a:r>
-              <a:rPr sz="1500" b="1">
-                <a:gradFill rotWithShape="1">
-                  <a:gsLst>
-                    <a:gs pos="0">
-                      <a:srgbClr val="6B3FA8"/>
-                    </a:gs>
-                    <a:gs pos="100000">
-                      <a:srgbClr val="C64FC0"/>
-                    </a:gs>
-                  </a:gsLst>
-                  <a:lin ang="0" scaled="0"/>
-                </a:gradFill>
-                <a:latin typeface="Arial"/>
-              </a:rPr>
-              <a:t>R	</a:t>
-            </a:r>
-            <a:r>
-              <a:rPr sz="1400" b="0">
-                <a:solidFill>
-                  <a:srgbClr val="222222"/>
-                </a:solidFill>
-                <a:latin typeface="Arial"/>
-              </a:rPr>
-              <a:t>Kolom persis: </a:t>
-            </a:r>
-            <a:r>
-              <a:rPr sz="1400" b="1">
-                <a:solidFill>
-                  <a:srgbClr val="222222"/>
-                </a:solidFill>
-                <a:latin typeface="Arial"/>
-              </a:rPr>
-              <a:t>Tanggal, Kanal, Jenis Komplain, Status, Tindak Lanjut</a:t>
-            </a:r>
-            <a:r>
-              <a:rPr sz="1400" b="0">
-                <a:solidFill>
-                  <a:srgbClr val="222222"/>
-                </a:solidFill>
-                <a:latin typeface="Arial"/>
-              </a:rPr>
-              <a:t>. Hanya dari catatan saya; data yang tidak ada tulis </a:t>
-            </a:r>
-            <a:r>
-              <a:rPr sz="1400" b="1">
-                <a:solidFill>
-                  <a:srgbClr val="222222"/>
-                </a:solidFill>
-                <a:latin typeface="Arial"/>
-              </a:rPr>
-              <a:t>N/A</a:t>
-            </a:r>
-            <a:r>
-              <a:rPr sz="1400" b="0">
-                <a:solidFill>
-                  <a:srgbClr val="222222"/>
-                </a:solidFill>
-                <a:latin typeface="Arial"/>
-              </a:rPr>
-              <a:t>. Jangan menambah atau mengarang.</a:t>
-            </a:r>
-          </a:p>
-        </p:txBody>
-      </p:sp>
-      <p:sp>
-        <p:nvSpPr>
-          <p:cNvPr id="16" name="Table title"/>
-          <p:cNvSpPr txBox="1"/>
-          <p:nvPr/>
-        </p:nvSpPr>
-        <p:spPr>
-          <a:xfrm>
-            <a:off x="6446520" y="3273552"/>
-            <a:ext cx="5120640" cy="292608"/>
-          </a:xfrm>
-          <a:prstGeom prst="rect">
-            <a:avLst/>
-          </a:prstGeom>
-          <a:noFill/>
-        </p:spPr>
-        <p:txBody>
-          <a:bodyPr wrap="square" anchor="t" lIns="0" rIns="0" tIns="0" bIns="0">
-            <a:spAutoFit/>
-          </a:bodyPr>
-          <a:lstStyle/>
-          <a:p>
-            <a:pPr algn="l"/>
-            <a:r>
-              <a:rPr sz="1400" b="1">
-                <a:solidFill>
-                  <a:srgbClr val="222222"/>
-                </a:solidFill>
-                <a:latin typeface="Arial"/>
-              </a:rPr>
-              <a:t>Rekap Komplain Nasabah · Minggu ke-2 Agustus</a:t>
-            </a:r>
-          </a:p>
-        </p:txBody>
-      </p:sp>
-      <p:graphicFrame>
-        <p:nvGraphicFramePr>
-          <p:cNvPr id="17" name="Result table"/>
-          <p:cNvGraphicFramePr>
-            <a:graphicFrameLocks noGrp="1"/>
-          </p:cNvGraphicFramePr>
-          <p:nvPr/>
-        </p:nvGraphicFramePr>
-        <p:xfrm>
-          <a:off x="6446520" y="3657600"/>
-          <a:ext cx="5074920" cy="1810512"/>
-        </p:xfrm>
-        <a:graphic>
-          <a:graphicData uri="http://schemas.openxmlformats.org/drawingml/2006/table">
-            <a:tbl>
-              <a:tblPr firstRow="1" bandRow="0"/>
-              <a:tblGrid>
-                <a:gridCol w="713232"/>
-                <a:gridCol w="1024128"/>
-                <a:gridCol w="1234440"/>
-                <a:gridCol w="731520"/>
-                <a:gridCol w="1371600"/>
-              </a:tblGrid>
-              <a:tr h="384048">
-                <a:tc>
-                  <a:txBody>
-                    <a:bodyPr/>
-                    <a:lstStyle/>
-                    <a:p>
-                      <a:r>
-                        <a:rPr sz="1100" b="1">
-                          <a:solidFill>
-                            <a:srgbClr val="5B2E96"/>
-                          </a:solidFill>
-                          <a:latin typeface="Arial"/>
-                        </a:rPr>
-                        <a:t>Tanggal</a:t>
-                      </a:r>
-                    </a:p>
-                  </a:txBody>
-                  <a:tcPr marL="54864" marR="54864" marT="27432" marB="27432" anchor="ctr">
-                    <a:lnL w="0">
-                      <a:noFill/>
-                    </a:lnL>
-                    <a:lnR w="0">
-                      <a:noFill/>
-                    </a:lnR>
-                    <a:lnT w="0">
-                      <a:noFill/>
-                    </a:lnT>
-                    <a:lnB w="9525">
-                      <a:solidFill>
-                        <a:srgbClr val="E2DAEC"/>
-                      </a:solidFill>
-                    </a:lnB>
-                    <a:solidFill>
-                      <a:srgbClr val="F1EAF8"/>
-                    </a:solidFill>
-                  </a:tcPr>
-                </a:tc>
-                <a:tc>
-                  <a:txBody>
-                    <a:bodyPr/>
-                    <a:lstStyle/>
-                    <a:p>
-                      <a:r>
-                        <a:rPr sz="1100" b="1">
-                          <a:solidFill>
-                            <a:srgbClr val="5B2E96"/>
-                          </a:solidFill>
-                          <a:latin typeface="Arial"/>
-                        </a:rPr>
-                        <a:t>Kanal</a:t>
-                      </a:r>
-                    </a:p>
-                  </a:txBody>
-                  <a:tcPr marL="54864" marR="54864" marT="27432" marB="27432" anchor="ctr">
-                    <a:lnL w="0">
-                      <a:noFill/>
-                    </a:lnL>
-                    <a:lnR w="0">
-                      <a:noFill/>
-                    </a:lnR>
-                    <a:lnT w="0">
-                      <a:noFill/>
-                    </a:lnT>
-                    <a:lnB w="9525">
-                      <a:solidFill>
-                        <a:srgbClr val="E2DAEC"/>
-                      </a:solidFill>
-                    </a:lnB>
-                    <a:solidFill>
-                      <a:srgbClr val="F1EAF8"/>
-                    </a:solidFill>
-                  </a:tcPr>
-                </a:tc>
-                <a:tc>
-                  <a:txBody>
-                    <a:bodyPr/>
-                    <a:lstStyle/>
-                    <a:p>
-                      <a:r>
-                        <a:rPr sz="1100" b="1">
-                          <a:solidFill>
-                            <a:srgbClr val="5B2E96"/>
-                          </a:solidFill>
-                          <a:latin typeface="Arial"/>
-                        </a:rPr>
-                        <a:t>Jenis Komplain</a:t>
-                      </a:r>
-                    </a:p>
-                  </a:txBody>
-                  <a:tcPr marL="54864" marR="54864" marT="27432" marB="27432" anchor="ctr">
-                    <a:lnL w="0">
-                      <a:noFill/>
-                    </a:lnL>
-                    <a:lnR w="0">
-                      <a:noFill/>
-                    </a:lnR>
-                    <a:lnT w="0">
-                      <a:noFill/>
-                    </a:lnT>
-                    <a:lnB w="9525">
-                      <a:solidFill>
-                        <a:srgbClr val="E2DAEC"/>
-                      </a:solidFill>
-                    </a:lnB>
-                    <a:solidFill>
-                      <a:srgbClr val="F1EAF8"/>
-                    </a:solidFill>
-                  </a:tcPr>
-                </a:tc>
-                <a:tc>
-                  <a:txBody>
-                    <a:bodyPr/>
-                    <a:lstStyle/>
-                    <a:p>
-                      <a:r>
-                        <a:rPr sz="1100" b="1">
-                          <a:solidFill>
-                            <a:srgbClr val="5B2E96"/>
-                          </a:solidFill>
-                          <a:latin typeface="Arial"/>
-                        </a:rPr>
-                        <a:t>Status</a:t>
-                      </a:r>
-                    </a:p>
-                  </a:txBody>
-                  <a:tcPr marL="54864" marR="54864" marT="27432" marB="27432" anchor="ctr">
-                    <a:lnL w="0">
-                      <a:noFill/>
-                    </a:lnL>
-                    <a:lnR w="0">
-                      <a:noFill/>
-                    </a:lnR>
-                    <a:lnT w="0">
-                      <a:noFill/>
-                    </a:lnT>
-                    <a:lnB w="9525">
-                      <a:solidFill>
-                        <a:srgbClr val="E2DAEC"/>
-                      </a:solidFill>
-                    </a:lnB>
-                    <a:solidFill>
-                      <a:srgbClr val="F1EAF8"/>
-                    </a:solidFill>
-                  </a:tcPr>
-                </a:tc>
-                <a:tc>
-                  <a:txBody>
-                    <a:bodyPr/>
-                    <a:lstStyle/>
-                    <a:p>
-                      <a:r>
-                        <a:rPr sz="1100" b="1">
-                          <a:solidFill>
-                            <a:srgbClr val="5B2E96"/>
-                          </a:solidFill>
-                          <a:latin typeface="Arial"/>
-                        </a:rPr>
-                        <a:t>Tindak Lanjut</a:t>
-                      </a:r>
-                    </a:p>
-                  </a:txBody>
-                  <a:tcPr marL="54864" marR="54864" marT="27432" marB="27432" anchor="ctr">
-                    <a:lnL w="0">
-                      <a:noFill/>
-                    </a:lnL>
-                    <a:lnR w="0">
-                      <a:noFill/>
-                    </a:lnR>
-                    <a:lnT w="0">
-                      <a:noFill/>
-                    </a:lnT>
-                    <a:lnB w="9525">
-                      <a:solidFill>
-                        <a:srgbClr val="E2DAEC"/>
-                      </a:solidFill>
-                    </a:lnB>
-                    <a:solidFill>
-                      <a:srgbClr val="F1EAF8"/>
-                    </a:solidFill>
-                  </a:tcPr>
-                </a:tc>
-              </a:tr>
-              <a:tr h="475488">
-                <a:tc>
-                  <a:txBody>
-                    <a:bodyPr/>
-                    <a:lstStyle/>
-                    <a:p>
-                      <a:r>
-                        <a:rPr sz="1200" b="0">
-                          <a:solidFill>
-                            <a:srgbClr val="222222"/>
-                          </a:solidFill>
-                          <a:latin typeface="Arial"/>
-                        </a:rPr>
-                        <a:t>02/08</a:t>
-                      </a:r>
-                    </a:p>
-                  </a:txBody>
-                  <a:tcPr marL="54864" marR="54864" marT="27432" marB="27432" anchor="ctr">
-                    <a:lnL w="0">
-                      <a:noFill/>
-                    </a:lnL>
-                    <a:lnR w="0">
-                      <a:noFill/>
-                    </a:lnR>
-                    <a:lnT w="0">
-                      <a:noFill/>
-                    </a:lnT>
-                    <a:lnB w="9525">
-                      <a:solidFill>
-                        <a:srgbClr val="E2DAEC"/>
-                      </a:solidFill>
-                    </a:lnB>
-                    <a:solidFill>
-                      <a:srgbClr val="FFFFFF"/>
-                    </a:solidFill>
-                  </a:tcPr>
-                </a:tc>
-                <a:tc>
-                  <a:txBody>
-                    <a:bodyPr/>
-                    <a:lstStyle/>
-                    <a:p>
-                      <a:r>
-                        <a:rPr sz="1200" b="0">
-                          <a:solidFill>
-                            <a:srgbClr val="222222"/>
-                          </a:solidFill>
-                          <a:latin typeface="Arial"/>
-                        </a:rPr>
-                        <a:t>Mobile banking</a:t>
-                      </a:r>
-                    </a:p>
-                  </a:txBody>
-                  <a:tcPr marL="54864" marR="54864" marT="27432" marB="27432" anchor="ctr">
-                    <a:lnL w="0">
-                      <a:noFill/>
-                    </a:lnL>
-                    <a:lnR w="0">
-                      <a:noFill/>
-                    </a:lnR>
-                    <a:lnT w="0">
-                      <a:noFill/>
-                    </a:lnT>
-                    <a:lnB w="9525">
-                      <a:solidFill>
-                        <a:srgbClr val="E2DAEC"/>
-                      </a:solidFill>
-                    </a:lnB>
-                    <a:solidFill>
-                      <a:srgbClr val="FFFFFF"/>
-                    </a:solidFill>
-                  </a:tcPr>
-                </a:tc>
-                <a:tc>
-                  <a:txBody>
-                    <a:bodyPr/>
-                    <a:lstStyle/>
-                    <a:p>
-                      <a:r>
-                        <a:rPr sz="1200" b="0">
-                          <a:solidFill>
-                            <a:srgbClr val="222222"/>
-                          </a:solidFill>
-                          <a:latin typeface="Arial"/>
-                        </a:rPr>
-                        <a:t>Transfer gagal</a:t>
-                      </a:r>
-                    </a:p>
-                  </a:txBody>
-                  <a:tcPr marL="54864" marR="54864" marT="27432" marB="27432" anchor="ctr">
-                    <a:lnL w="0">
-                      <a:noFill/>
-                    </a:lnL>
-                    <a:lnR w="0">
-                      <a:noFill/>
-                    </a:lnR>
-                    <a:lnT w="0">
-                      <a:noFill/>
-                    </a:lnT>
-                    <a:lnB w="9525">
-                      <a:solidFill>
-                        <a:srgbClr val="E2DAEC"/>
-                      </a:solidFill>
-                    </a:lnB>
-                    <a:solidFill>
-                      <a:srgbClr val="FFFFFF"/>
-                    </a:solidFill>
-                  </a:tcPr>
-                </a:tc>
-                <a:tc>
-                  <a:txBody>
-                    <a:bodyPr/>
-                    <a:lstStyle/>
-                    <a:p>
-                      <a:r>
-                        <a:rPr sz="1200" b="0">
-                          <a:solidFill>
-                            <a:srgbClr val="222222"/>
-                          </a:solidFill>
-                          <a:latin typeface="Arial"/>
-                        </a:rPr>
-                        <a:t>Selesai</a:t>
-                      </a:r>
-                    </a:p>
-                  </a:txBody>
-                  <a:tcPr marL="54864" marR="54864" marT="27432" marB="27432" anchor="ctr">
-                    <a:lnL w="0">
-                      <a:noFill/>
-                    </a:lnL>
-                    <a:lnR w="0">
-                      <a:noFill/>
-                    </a:lnR>
-                    <a:lnT w="0">
-                      <a:noFill/>
-                    </a:lnT>
-                    <a:lnB w="9525">
-                      <a:solidFill>
-                        <a:srgbClr val="E2DAEC"/>
-                      </a:solidFill>
-                    </a:lnB>
-                    <a:solidFill>
-                      <a:srgbClr val="FFFFFF"/>
-                    </a:solidFill>
-                  </a:tcPr>
-                </a:tc>
-                <a:tc>
-                  <a:txBody>
-                    <a:bodyPr/>
-                    <a:lstStyle/>
-                    <a:p>
-                      <a:r>
-                        <a:rPr sz="1200" b="0">
-                          <a:solidFill>
-                            <a:srgbClr val="222222"/>
-                          </a:solidFill>
-                          <a:latin typeface="Arial"/>
-                        </a:rPr>
-                        <a:t>Dana dikembalikan</a:t>
-                      </a:r>
-                    </a:p>
-                  </a:txBody>
-                  <a:tcPr marL="54864" marR="54864" marT="27432" marB="27432" anchor="ctr">
-                    <a:lnL w="0">
-                      <a:noFill/>
-                    </a:lnL>
-                    <a:lnR w="0">
-                      <a:noFill/>
-                    </a:lnR>
-                    <a:lnT w="0">
-                      <a:noFill/>
-                    </a:lnT>
-                    <a:lnB w="9525">
-                      <a:solidFill>
-                        <a:srgbClr val="E2DAEC"/>
-                      </a:solidFill>
-                    </a:lnB>
-                    <a:solidFill>
-                      <a:srgbClr val="FFFFFF"/>
-                    </a:solidFill>
-                  </a:tcPr>
-                </a:tc>
-              </a:tr>
-              <a:tr h="475488">
-                <a:tc>
-                  <a:txBody>
-                    <a:bodyPr/>
-                    <a:lstStyle/>
-                    <a:p>
-                      <a:r>
-                        <a:rPr sz="1200" b="0">
-                          <a:solidFill>
-                            <a:srgbClr val="222222"/>
-                          </a:solidFill>
-                          <a:latin typeface="Arial"/>
-                        </a:rPr>
-                        <a:t>04/08</a:t>
-                      </a:r>
-                    </a:p>
-                  </a:txBody>
-                  <a:tcPr marL="54864" marR="54864" marT="27432" marB="27432" anchor="ctr">
-                    <a:lnL w="0">
-                      <a:noFill/>
-                    </a:lnL>
-                    <a:lnR w="0">
-                      <a:noFill/>
-                    </a:lnR>
-                    <a:lnT w="0">
-                      <a:noFill/>
-                    </a:lnT>
-                    <a:lnB w="9525">
-                      <a:solidFill>
-                        <a:srgbClr val="E2DAEC"/>
-                      </a:solidFill>
-                    </a:lnB>
-                    <a:solidFill>
-                      <a:srgbClr val="FFFFFF"/>
-                    </a:solidFill>
-                  </a:tcPr>
-                </a:tc>
-                <a:tc>
-                  <a:txBody>
-                    <a:bodyPr/>
-                    <a:lstStyle/>
-                    <a:p>
-                      <a:r>
-                        <a:rPr sz="1200" b="0">
-                          <a:solidFill>
-                            <a:srgbClr val="222222"/>
-                          </a:solidFill>
-                          <a:latin typeface="Arial"/>
-                        </a:rPr>
-                        <a:t>Cabang</a:t>
-                      </a:r>
-                    </a:p>
-                  </a:txBody>
-                  <a:tcPr marL="54864" marR="54864" marT="27432" marB="27432" anchor="ctr">
-                    <a:lnL w="0">
-                      <a:noFill/>
-                    </a:lnL>
-                    <a:lnR w="0">
-                      <a:noFill/>
-                    </a:lnR>
-                    <a:lnT w="0">
-                      <a:noFill/>
-                    </a:lnT>
-                    <a:lnB w="9525">
-                      <a:solidFill>
-                        <a:srgbClr val="E2DAEC"/>
-                      </a:solidFill>
-                    </a:lnB>
-                    <a:solidFill>
-                      <a:srgbClr val="FFFFFF"/>
-                    </a:solidFill>
-                  </a:tcPr>
-                </a:tc>
-                <a:tc>
-                  <a:txBody>
-                    <a:bodyPr/>
-                    <a:lstStyle/>
-                    <a:p>
-                      <a:r>
-                        <a:rPr sz="1200" b="0">
-                          <a:solidFill>
-                            <a:srgbClr val="222222"/>
-                          </a:solidFill>
-                          <a:latin typeface="Arial"/>
-                        </a:rPr>
-                        <a:t>Antrean lama</a:t>
-                      </a:r>
-                    </a:p>
-                  </a:txBody>
-                  <a:tcPr marL="54864" marR="54864" marT="27432" marB="27432" anchor="ctr">
-                    <a:lnL w="0">
-                      <a:noFill/>
-                    </a:lnL>
-                    <a:lnR w="0">
-                      <a:noFill/>
-                    </a:lnR>
-                    <a:lnT w="0">
-                      <a:noFill/>
-                    </a:lnT>
-                    <a:lnB w="9525">
-                      <a:solidFill>
-                        <a:srgbClr val="E2DAEC"/>
-                      </a:solidFill>
-                    </a:lnB>
-                    <a:solidFill>
-                      <a:srgbClr val="FFFFFF"/>
-                    </a:solidFill>
-                  </a:tcPr>
-                </a:tc>
-                <a:tc>
-                  <a:txBody>
-                    <a:bodyPr/>
-                    <a:lstStyle/>
-                    <a:p>
-                      <a:r>
-                        <a:rPr sz="1200" b="0">
-                          <a:solidFill>
-                            <a:srgbClr val="222222"/>
-                          </a:solidFill>
-                          <a:latin typeface="Arial"/>
-                        </a:rPr>
-                        <a:t>Proses</a:t>
-                      </a:r>
-                    </a:p>
-                  </a:txBody>
-                  <a:tcPr marL="54864" marR="54864" marT="27432" marB="27432" anchor="ctr">
-                    <a:lnL w="0">
-                      <a:noFill/>
-                    </a:lnL>
-                    <a:lnR w="0">
-                      <a:noFill/>
-                    </a:lnR>
-                    <a:lnT w="0">
-                      <a:noFill/>
-                    </a:lnT>
-                    <a:lnB w="9525">
-                      <a:solidFill>
-                        <a:srgbClr val="E2DAEC"/>
-                      </a:solidFill>
-                    </a:lnB>
-                    <a:solidFill>
-                      <a:srgbClr val="FFFFFF"/>
-                    </a:solidFill>
-                  </a:tcPr>
-                </a:tc>
-                <a:tc>
-                  <a:txBody>
-                    <a:bodyPr/>
-                    <a:lstStyle/>
-                    <a:p>
-                      <a:r>
-                        <a:rPr sz="1200" b="0">
-                          <a:solidFill>
-                            <a:srgbClr val="222222"/>
-                          </a:solidFill>
-                          <a:latin typeface="Arial"/>
-                        </a:rPr>
-                        <a:t>Tambah teller jam sibuk</a:t>
-                      </a:r>
-                    </a:p>
-                  </a:txBody>
-                  <a:tcPr marL="54864" marR="54864" marT="27432" marB="27432" anchor="ctr">
-                    <a:lnL w="0">
-                      <a:noFill/>
-                    </a:lnL>
-                    <a:lnR w="0">
-                      <a:noFill/>
-                    </a:lnR>
-                    <a:lnT w="0">
-                      <a:noFill/>
-                    </a:lnT>
-                    <a:lnB w="9525">
-                      <a:solidFill>
-                        <a:srgbClr val="E2DAEC"/>
-                      </a:solidFill>
-                    </a:lnB>
-                    <a:solidFill>
-                      <a:srgbClr val="FFFFFF"/>
-                    </a:solidFill>
-                  </a:tcPr>
-                </a:tc>
-              </a:tr>
-              <a:tr h="475488">
-                <a:tc>
-                  <a:txBody>
-                    <a:bodyPr/>
-                    <a:lstStyle/>
-                    <a:p>
-                      <a:r>
-                        <a:rPr sz="1200" b="0">
-                          <a:solidFill>
-                            <a:srgbClr val="222222"/>
-                          </a:solidFill>
-                          <a:latin typeface="Arial"/>
-                        </a:rPr>
-                        <a:t>05/08</a:t>
-                      </a:r>
-                    </a:p>
-                  </a:txBody>
-                  <a:tcPr marL="54864" marR="54864" marT="27432" marB="27432" anchor="ctr">
-                    <a:lnL w="0">
-                      <a:noFill/>
-                    </a:lnL>
-                    <a:lnR w="0">
-                      <a:noFill/>
-                    </a:lnR>
-                    <a:lnT w="0">
-                      <a:noFill/>
-                    </a:lnT>
-                    <a:lnB w="9525">
-                      <a:solidFill>
-                        <a:srgbClr val="E2DAEC"/>
-                      </a:solidFill>
-                    </a:lnB>
-                    <a:solidFill>
-                      <a:srgbClr val="FFFFFF"/>
-                    </a:solidFill>
-                  </a:tcPr>
-                </a:tc>
-                <a:tc>
-                  <a:txBody>
-                    <a:bodyPr/>
-                    <a:lstStyle/>
-                    <a:p>
-                      <a:r>
-                        <a:rPr sz="1200" b="0">
-                          <a:solidFill>
-                            <a:srgbClr val="222222"/>
-                          </a:solidFill>
-                          <a:latin typeface="Arial"/>
-                        </a:rPr>
-                        <a:t>Call center</a:t>
-                      </a:r>
-                    </a:p>
-                  </a:txBody>
-                  <a:tcPr marL="54864" marR="54864" marT="27432" marB="27432" anchor="ctr">
-                    <a:lnL w="0">
-                      <a:noFill/>
-                    </a:lnL>
-                    <a:lnR w="0">
-                      <a:noFill/>
-                    </a:lnR>
-                    <a:lnT w="0">
-                      <a:noFill/>
-                    </a:lnT>
-                    <a:lnB w="9525">
-                      <a:solidFill>
-                        <a:srgbClr val="E2DAEC"/>
-                      </a:solidFill>
-                    </a:lnB>
-                    <a:solidFill>
-                      <a:srgbClr val="FFFFFF"/>
-                    </a:solidFill>
-                  </a:tcPr>
-                </a:tc>
-                <a:tc>
-                  <a:txBody>
-                    <a:bodyPr/>
-                    <a:lstStyle/>
-                    <a:p>
-                      <a:r>
-                        <a:rPr sz="1200" b="0">
-                          <a:solidFill>
-                            <a:srgbClr val="222222"/>
-                          </a:solidFill>
-                          <a:latin typeface="Arial"/>
-                        </a:rPr>
-                        <a:t>Kartu tertelan ATM</a:t>
-                      </a:r>
-                    </a:p>
-                  </a:txBody>
-                  <a:tcPr marL="54864" marR="54864" marT="27432" marB="27432" anchor="ctr">
-                    <a:lnL w="0">
-                      <a:noFill/>
-                    </a:lnL>
-                    <a:lnR w="0">
-                      <a:noFill/>
-                    </a:lnR>
-                    <a:lnT w="0">
-                      <a:noFill/>
-                    </a:lnT>
-                    <a:lnB w="9525">
-                      <a:solidFill>
-                        <a:srgbClr val="E2DAEC"/>
-                      </a:solidFill>
-                    </a:lnB>
-                    <a:solidFill>
-                      <a:srgbClr val="FFFFFF"/>
-                    </a:solidFill>
-                  </a:tcPr>
-                </a:tc>
-                <a:tc>
-                  <a:txBody>
-                    <a:bodyPr/>
-                    <a:lstStyle/>
-                    <a:p>
-                      <a:r>
-                        <a:rPr sz="1200" b="0">
-                          <a:solidFill>
-                            <a:srgbClr val="222222"/>
-                          </a:solidFill>
-                          <a:latin typeface="Arial"/>
-                        </a:rPr>
-                        <a:t>Selesai</a:t>
-                      </a:r>
-                    </a:p>
-                  </a:txBody>
-                  <a:tcPr marL="54864" marR="54864" marT="27432" marB="27432" anchor="ctr">
-                    <a:lnL w="0">
-                      <a:noFill/>
-                    </a:lnL>
-                    <a:lnR w="0">
-                      <a:noFill/>
-                    </a:lnR>
-                    <a:lnT w="0">
-                      <a:noFill/>
-                    </a:lnT>
-                    <a:lnB w="9525">
-                      <a:solidFill>
-                        <a:srgbClr val="E2DAEC"/>
-                      </a:solidFill>
-                    </a:lnB>
-                    <a:solidFill>
-                      <a:srgbClr val="FFFFFF"/>
-                    </a:solidFill>
-                  </a:tcPr>
-                </a:tc>
-                <a:tc>
-                  <a:txBody>
-                    <a:bodyPr/>
-                    <a:lstStyle/>
-                    <a:p>
-                      <a:r>
-                        <a:rPr sz="1200" b="1">
-                          <a:solidFill>
-                            <a:srgbClr val="A82E9C"/>
-                          </a:solidFill>
-                          <a:latin typeface="Arial"/>
-                        </a:rPr>
-                        <a:t>N/A</a:t>
-                      </a:r>
-                    </a:p>
-                  </a:txBody>
-                  <a:tcPr marL="54864" marR="54864" marT="27432" marB="27432" anchor="ctr">
-                    <a:lnL w="0">
-                      <a:noFill/>
-                    </a:lnL>
-                    <a:lnR w="0">
-                      <a:noFill/>
-                    </a:lnR>
-                    <a:lnT w="0">
-                      <a:noFill/>
-                    </a:lnT>
-                    <a:lnB w="9525">
-                      <a:solidFill>
-                        <a:srgbClr val="E2DAEC"/>
-                      </a:solidFill>
-                    </a:lnB>
-                    <a:solidFill>
-                      <a:srgbClr val="FBE8F6"/>
-                    </a:solidFill>
-                  </a:tcPr>
-                </a:tc>
-              </a:tr>
-            </a:tbl>
-          </a:graphicData>
-        </a:graphic>
-      </p:graphicFrame>
-      <p:sp>
-        <p:nvSpPr>
-          <p:cNvPr id="18" name="Table note"/>
-          <p:cNvSpPr txBox="1"/>
-          <p:nvPr/>
-        </p:nvSpPr>
-        <p:spPr>
-          <a:xfrm>
-            <a:off x="6446520" y="5605272"/>
-            <a:ext cx="5120640" cy="274320"/>
-          </a:xfrm>
-          <a:prstGeom prst="rect">
-            <a:avLst/>
-          </a:prstGeom>
-          <a:noFill/>
-        </p:spPr>
-        <p:txBody>
-          <a:bodyPr wrap="square" anchor="t" lIns="0" rIns="0" tIns="0" bIns="0">
-            <a:spAutoFit/>
-          </a:bodyPr>
-          <a:lstStyle/>
-          <a:p>
-            <a:pPr algn="l"/>
-            <a:r>
-              <a:rPr sz="1200" b="1">
-                <a:gradFill rotWithShape="1">
-                  <a:gsLst>
-                    <a:gs pos="0">
-                      <a:srgbClr val="6B3FA8"/>
-                    </a:gs>
-                    <a:gs pos="100000">
-                      <a:srgbClr val="C64FC0"/>
-                    </a:gs>
-                  </a:gsLst>
-                  <a:lin ang="0" scaled="0"/>
-                </a:gradFill>
-                <a:latin typeface="Arial"/>
-              </a:rPr>
-              <a:t>✓  </a:t>
-            </a:r>
-            <a:r>
-              <a:rPr sz="1200" b="0">
-                <a:solidFill>
-                  <a:srgbClr val="55555E"/>
-                </a:solidFill>
-                <a:latin typeface="Arial"/>
-              </a:rPr>
-              <a:t>Data kosong ditulis N/A, tidak dikarang.</a:t>
-            </a:r>
-          </a:p>
-        </p:txBody>
-      </p:sp>
     </p:spTree>
   </p:cSld>
   <p:clrMapOvr>

</xml_diff>

<commit_message>
COSTAR slides: rebuild as editable PowerPoint (text, shapes, native table)
Co-Authored-By: Claude Opus 5.5 <noreply@anthropic.com>
Claude-Session: https://claude.ai/code/session_01Nu81SmmHj1XfYpohCK6uwS
</commit_message>
<xml_diff>
--- a/costar-slides.pptx
+++ b/costar-slides.pptx
@@ -3615,9 +3615,1080 @@
         <p:nvPr/>
       </p:nvGrpSpPr>
       <p:grpSpPr/>
+      <p:sp>
+        <p:nvSpPr>
+          <p:cNvPr id="2" name="Badge ring"/>
+          <p:cNvSpPr/>
+          <p:nvPr/>
+        </p:nvSpPr>
+        <p:spPr>
+          <a:xfrm>
+            <a:off x="5135880" y="552450"/>
+            <a:ext cx="304800" cy="304800"/>
+          </a:xfrm>
+          <a:prstGeom prst="ellipse">
+            <a:avLst/>
+          </a:prstGeom>
+          <a:solidFill>
+            <a:srgbClr val="F3ECFB"/>
+          </a:solidFill>
+          <a:ln>
+            <a:noFill/>
+          </a:ln>
+        </p:spPr>
+        <p:txBody>
+          <a:bodyPr rtlCol="0" anchor="ctr"/>
+          <a:lstStyle/>
+          <a:p/>
+        </p:txBody>
+      </p:sp>
+      <p:sp>
+        <p:nvSpPr>
+          <p:cNvPr id="3" name="Badge"/>
+          <p:cNvSpPr/>
+          <p:nvPr/>
+        </p:nvSpPr>
+        <p:spPr>
+          <a:xfrm>
+            <a:off x="5173980" y="590550"/>
+            <a:ext cx="228600" cy="228600"/>
+          </a:xfrm>
+          <a:prstGeom prst="ellipse">
+            <a:avLst/>
+          </a:prstGeom>
+          <a:solidFill>
+            <a:srgbClr val="7B3FC0"/>
+          </a:solidFill>
+          <a:ln>
+            <a:noFill/>
+          </a:ln>
+        </p:spPr>
+        <p:txBody>
+          <a:bodyPr rtlCol="0" anchor="ctr"/>
+          <a:lstStyle/>
+          <a:p/>
+        </p:txBody>
+      </p:sp>
+      <p:sp>
+        <p:nvSpPr>
+          <p:cNvPr id="4" name="Badge sun"/>
+          <p:cNvSpPr/>
+          <p:nvPr/>
+        </p:nvSpPr>
+        <p:spPr>
+          <a:xfrm>
+            <a:off x="5221605" y="685800"/>
+            <a:ext cx="133350" cy="85725"/>
+          </a:xfrm>
+          <a:prstGeom prst="triangle">
+            <a:avLst/>
+          </a:prstGeom>
+          <a:solidFill>
+            <a:srgbClr val="FFFFFF"/>
+          </a:solidFill>
+          <a:ln>
+            <a:noFill/>
+          </a:ln>
+        </p:spPr>
+        <p:txBody>
+          <a:bodyPr rtlCol="0" anchor="ctr"/>
+          <a:lstStyle/>
+          <a:p/>
+        </p:txBody>
+      </p:sp>
+      <p:sp>
+        <p:nvSpPr>
+          <p:cNvPr id="5" name="Badge horizon"/>
+          <p:cNvSpPr/>
+          <p:nvPr/>
+        </p:nvSpPr>
+        <p:spPr>
+          <a:xfrm>
+            <a:off x="5197792" y="754380"/>
+            <a:ext cx="180975" cy="14288"/>
+          </a:xfrm>
+          <a:prstGeom prst="rect">
+            <a:avLst/>
+          </a:prstGeom>
+          <a:solidFill>
+            <a:srgbClr val="FFFFFF"/>
+          </a:solidFill>
+          <a:ln>
+            <a:noFill/>
+          </a:ln>
+        </p:spPr>
+        <p:txBody>
+          <a:bodyPr rtlCol="0" anchor="ctr"/>
+          <a:lstStyle/>
+          <a:p/>
+        </p:txBody>
+      </p:sp>
+      <p:sp>
+        <p:nvSpPr>
+          <p:cNvPr id="6" name="Kicker"/>
+          <p:cNvSpPr txBox="1"/>
+          <p:nvPr/>
+        </p:nvSpPr>
+        <p:spPr>
+          <a:xfrm>
+            <a:off x="5507355" y="590550"/>
+            <a:ext cx="2476500" cy="228600"/>
+          </a:xfrm>
+          <a:prstGeom prst="rect">
+            <a:avLst/>
+          </a:prstGeom>
+          <a:noFill/>
+        </p:spPr>
+        <p:txBody>
+          <a:bodyPr wrap="square" anchor="ctr" lIns="0" rIns="0" tIns="0" bIns="0">
+            <a:spAutoFit/>
+          </a:bodyPr>
+          <a:lstStyle/>
+          <a:p>
+            <a:pPr algn="l"/>
+            <a:r>
+              <a:rPr sz="975" i="0" b="1" spc="136">
+                <a:solidFill>
+                  <a:srgbClr val="7B3FC0"/>
+                </a:solidFill>
+                <a:latin typeface="Arial"/>
+              </a:rPr>
+              <a:t>PART 1 · PROMPTING</a:t>
+            </a:r>
+          </a:p>
+        </p:txBody>
+      </p:sp>
+      <p:sp>
+        <p:nvSpPr>
+          <p:cNvPr id="7" name="Title"/>
+          <p:cNvSpPr txBox="1"/>
+          <p:nvPr/>
+        </p:nvSpPr>
+        <p:spPr>
+          <a:xfrm>
+            <a:off x="723900" y="933450"/>
+            <a:ext cx="10744200" cy="476250"/>
+          </a:xfrm>
+          <a:prstGeom prst="rect">
+            <a:avLst/>
+          </a:prstGeom>
+          <a:noFill/>
+        </p:spPr>
+        <p:txBody>
+          <a:bodyPr wrap="square" anchor="ctr" lIns="0" rIns="0" tIns="0" bIns="0">
+            <a:spAutoFit/>
+          </a:bodyPr>
+          <a:lstStyle/>
+          <a:p>
+            <a:pPr algn="ctr"/>
+            <a:r>
+              <a:rPr sz="2850" i="0" b="1" spc="-57">
+                <a:solidFill>
+                  <a:srgbClr val="1A1A1A"/>
+                </a:solidFill>
+                <a:latin typeface="Arial"/>
+              </a:rPr>
+              <a:t>Or use a framework: COSTAR</a:t>
+            </a:r>
+          </a:p>
+        </p:txBody>
+      </p:sp>
+      <p:sp>
+        <p:nvSpPr>
+          <p:cNvPr id="8" name="Row C"/>
+          <p:cNvSpPr/>
+          <p:nvPr/>
+        </p:nvSpPr>
+        <p:spPr>
+          <a:xfrm>
+            <a:off x="2381250" y="1966912"/>
+            <a:ext cx="7429500" cy="495300"/>
+          </a:xfrm>
+          <a:prstGeom prst="roundRect">
+            <a:avLst>
+              <a:gd name="adj" fmla="val 25000"/>
+            </a:avLst>
+          </a:prstGeom>
+          <a:solidFill>
+            <a:srgbClr val="FFFFFF"/>
+          </a:solidFill>
+          <a:ln w="9525">
+            <a:solidFill>
+              <a:srgbClr val="E4E7EB"/>
+            </a:solidFill>
+          </a:ln>
+          <a:effectLst>
+            <a:outerShdw blurRad="133350" dist="47625" dir="5400000" algn="t" rotWithShape="0">
+              <a:srgbClr val="000000">
+                <a:alpha val="7000"/>
+              </a:srgbClr>
+            </a:outerShdw>
+          </a:effectLst>
+        </p:spPr>
+        <p:txBody>
+          <a:bodyPr rtlCol="0" anchor="ctr"/>
+          <a:lstStyle/>
+          <a:p/>
+        </p:txBody>
+      </p:sp>
+      <p:sp>
+        <p:nvSpPr>
+          <p:cNvPr id="9" name="Letter C"/>
+          <p:cNvSpPr txBox="1"/>
+          <p:nvPr/>
+        </p:nvSpPr>
+        <p:spPr>
+          <a:xfrm>
+            <a:off x="2562225" y="2024062"/>
+            <a:ext cx="381000" cy="381000"/>
+          </a:xfrm>
+          <a:prstGeom prst="rect">
+            <a:avLst/>
+          </a:prstGeom>
+          <a:noFill/>
+        </p:spPr>
+        <p:txBody>
+          <a:bodyPr wrap="square" anchor="ctr" lIns="0" rIns="0" tIns="0" bIns="0">
+            <a:spAutoFit/>
+          </a:bodyPr>
+          <a:lstStyle/>
+          <a:p>
+            <a:pPr algn="ctr"/>
+            <a:r>
+              <a:rPr sz="2250" i="0" b="1">
+                <a:solidFill>
+                  <a:srgbClr val="7B3FC0"/>
+                </a:solidFill>
+                <a:latin typeface="Arial"/>
+              </a:rPr>
+              <a:t>C</a:t>
+            </a:r>
+          </a:p>
+        </p:txBody>
+      </p:sp>
+      <p:sp>
+        <p:nvSpPr>
+          <p:cNvPr id="10" name="Word Context"/>
+          <p:cNvSpPr txBox="1"/>
+          <p:nvPr/>
+        </p:nvSpPr>
+        <p:spPr>
+          <a:xfrm>
+            <a:off x="3076575" y="2062162"/>
+            <a:ext cx="1143000" cy="304800"/>
+          </a:xfrm>
+          <a:prstGeom prst="rect">
+            <a:avLst/>
+          </a:prstGeom>
+          <a:noFill/>
+        </p:spPr>
+        <p:txBody>
+          <a:bodyPr wrap="square" anchor="ctr" lIns="0" rIns="0" tIns="0" bIns="0">
+            <a:spAutoFit/>
+          </a:bodyPr>
+          <a:lstStyle/>
+          <a:p>
+            <a:pPr algn="l"/>
+            <a:r>
+              <a:rPr sz="1200" i="0" b="1">
+                <a:solidFill>
+                  <a:srgbClr val="1A1A1A"/>
+                </a:solidFill>
+                <a:latin typeface="Arial"/>
+              </a:rPr>
+              <a:t>Context</a:t>
+            </a:r>
+          </a:p>
+        </p:txBody>
+      </p:sp>
+      <p:sp>
+        <p:nvSpPr>
+          <p:cNvPr id="11" name="Meaning Context"/>
+          <p:cNvSpPr txBox="1"/>
+          <p:nvPr/>
+        </p:nvSpPr>
+        <p:spPr>
+          <a:xfrm>
+            <a:off x="4295775" y="2062162"/>
+            <a:ext cx="5334000" cy="304800"/>
+          </a:xfrm>
+          <a:prstGeom prst="rect">
+            <a:avLst/>
+          </a:prstGeom>
+          <a:noFill/>
+        </p:spPr>
+        <p:txBody>
+          <a:bodyPr wrap="square" anchor="ctr" lIns="0" rIns="0" tIns="0" bIns="0">
+            <a:spAutoFit/>
+          </a:bodyPr>
+          <a:lstStyle/>
+          <a:p>
+            <a:pPr algn="l"/>
+            <a:r>
+              <a:rPr sz="1012" i="0" b="0">
+                <a:solidFill>
+                  <a:srgbClr val="6B7280"/>
+                </a:solidFill>
+                <a:latin typeface="Arial"/>
+              </a:rPr>
+              <a:t>the background the model needs to know</a:t>
+            </a:r>
+          </a:p>
+        </p:txBody>
+      </p:sp>
+      <p:sp>
+        <p:nvSpPr>
+          <p:cNvPr id="12" name="Row O"/>
+          <p:cNvSpPr/>
+          <p:nvPr/>
+        </p:nvSpPr>
+        <p:spPr>
+          <a:xfrm>
+            <a:off x="2381250" y="2547938"/>
+            <a:ext cx="7429500" cy="495300"/>
+          </a:xfrm>
+          <a:prstGeom prst="roundRect">
+            <a:avLst>
+              <a:gd name="adj" fmla="val 25000"/>
+            </a:avLst>
+          </a:prstGeom>
+          <a:solidFill>
+            <a:srgbClr val="FFFFFF"/>
+          </a:solidFill>
+          <a:ln w="9525">
+            <a:solidFill>
+              <a:srgbClr val="E4E7EB"/>
+            </a:solidFill>
+          </a:ln>
+          <a:effectLst>
+            <a:outerShdw blurRad="133350" dist="47625" dir="5400000" algn="t" rotWithShape="0">
+              <a:srgbClr val="000000">
+                <a:alpha val="7000"/>
+              </a:srgbClr>
+            </a:outerShdw>
+          </a:effectLst>
+        </p:spPr>
+        <p:txBody>
+          <a:bodyPr rtlCol="0" anchor="ctr"/>
+          <a:lstStyle/>
+          <a:p/>
+        </p:txBody>
+      </p:sp>
+      <p:sp>
+        <p:nvSpPr>
+          <p:cNvPr id="13" name="Letter O"/>
+          <p:cNvSpPr txBox="1"/>
+          <p:nvPr/>
+        </p:nvSpPr>
+        <p:spPr>
+          <a:xfrm>
+            <a:off x="2562225" y="2605088"/>
+            <a:ext cx="381000" cy="381000"/>
+          </a:xfrm>
+          <a:prstGeom prst="rect">
+            <a:avLst/>
+          </a:prstGeom>
+          <a:noFill/>
+        </p:spPr>
+        <p:txBody>
+          <a:bodyPr wrap="square" anchor="ctr" lIns="0" rIns="0" tIns="0" bIns="0">
+            <a:spAutoFit/>
+          </a:bodyPr>
+          <a:lstStyle/>
+          <a:p>
+            <a:pPr algn="ctr"/>
+            <a:r>
+              <a:rPr sz="2250" i="0" b="1">
+                <a:solidFill>
+                  <a:srgbClr val="7B3FC0"/>
+                </a:solidFill>
+                <a:latin typeface="Arial"/>
+              </a:rPr>
+              <a:t>O</a:t>
+            </a:r>
+          </a:p>
+        </p:txBody>
+      </p:sp>
+      <p:sp>
+        <p:nvSpPr>
+          <p:cNvPr id="14" name="Word Objective"/>
+          <p:cNvSpPr txBox="1"/>
+          <p:nvPr/>
+        </p:nvSpPr>
+        <p:spPr>
+          <a:xfrm>
+            <a:off x="3076575" y="2643188"/>
+            <a:ext cx="1143000" cy="304800"/>
+          </a:xfrm>
+          <a:prstGeom prst="rect">
+            <a:avLst/>
+          </a:prstGeom>
+          <a:noFill/>
+        </p:spPr>
+        <p:txBody>
+          <a:bodyPr wrap="square" anchor="ctr" lIns="0" rIns="0" tIns="0" bIns="0">
+            <a:spAutoFit/>
+          </a:bodyPr>
+          <a:lstStyle/>
+          <a:p>
+            <a:pPr algn="l"/>
+            <a:r>
+              <a:rPr sz="1200" i="0" b="1">
+                <a:solidFill>
+                  <a:srgbClr val="1A1A1A"/>
+                </a:solidFill>
+                <a:latin typeface="Arial"/>
+              </a:rPr>
+              <a:t>Objective</a:t>
+            </a:r>
+          </a:p>
+        </p:txBody>
+      </p:sp>
+      <p:sp>
+        <p:nvSpPr>
+          <p:cNvPr id="15" name="Meaning Objective"/>
+          <p:cNvSpPr txBox="1"/>
+          <p:nvPr/>
+        </p:nvSpPr>
+        <p:spPr>
+          <a:xfrm>
+            <a:off x="4295775" y="2643188"/>
+            <a:ext cx="5334000" cy="304800"/>
+          </a:xfrm>
+          <a:prstGeom prst="rect">
+            <a:avLst/>
+          </a:prstGeom>
+          <a:noFill/>
+        </p:spPr>
+        <p:txBody>
+          <a:bodyPr wrap="square" anchor="ctr" lIns="0" rIns="0" tIns="0" bIns="0">
+            <a:spAutoFit/>
+          </a:bodyPr>
+          <a:lstStyle/>
+          <a:p>
+            <a:pPr algn="l"/>
+            <a:r>
+              <a:rPr sz="1012" i="0" b="0">
+                <a:solidFill>
+                  <a:srgbClr val="6B7280"/>
+                </a:solidFill>
+                <a:latin typeface="Arial"/>
+              </a:rPr>
+              <a:t>the task, stated exactly</a:t>
+            </a:r>
+          </a:p>
+        </p:txBody>
+      </p:sp>
+      <p:sp>
+        <p:nvSpPr>
+          <p:cNvPr id="16" name="Row S"/>
+          <p:cNvSpPr/>
+          <p:nvPr/>
+        </p:nvSpPr>
+        <p:spPr>
+          <a:xfrm>
+            <a:off x="2381250" y="3128962"/>
+            <a:ext cx="7429500" cy="495300"/>
+          </a:xfrm>
+          <a:prstGeom prst="roundRect">
+            <a:avLst>
+              <a:gd name="adj" fmla="val 25000"/>
+            </a:avLst>
+          </a:prstGeom>
+          <a:solidFill>
+            <a:srgbClr val="FFFFFF"/>
+          </a:solidFill>
+          <a:ln w="9525">
+            <a:solidFill>
+              <a:srgbClr val="E4E7EB"/>
+            </a:solidFill>
+          </a:ln>
+          <a:effectLst>
+            <a:outerShdw blurRad="133350" dist="47625" dir="5400000" algn="t" rotWithShape="0">
+              <a:srgbClr val="000000">
+                <a:alpha val="7000"/>
+              </a:srgbClr>
+            </a:outerShdw>
+          </a:effectLst>
+        </p:spPr>
+        <p:txBody>
+          <a:bodyPr rtlCol="0" anchor="ctr"/>
+          <a:lstStyle/>
+          <a:p/>
+        </p:txBody>
+      </p:sp>
+      <p:sp>
+        <p:nvSpPr>
+          <p:cNvPr id="17" name="Letter S"/>
+          <p:cNvSpPr txBox="1"/>
+          <p:nvPr/>
+        </p:nvSpPr>
+        <p:spPr>
+          <a:xfrm>
+            <a:off x="2562225" y="3186112"/>
+            <a:ext cx="381000" cy="381000"/>
+          </a:xfrm>
+          <a:prstGeom prst="rect">
+            <a:avLst/>
+          </a:prstGeom>
+          <a:noFill/>
+        </p:spPr>
+        <p:txBody>
+          <a:bodyPr wrap="square" anchor="ctr" lIns="0" rIns="0" tIns="0" bIns="0">
+            <a:spAutoFit/>
+          </a:bodyPr>
+          <a:lstStyle/>
+          <a:p>
+            <a:pPr algn="ctr"/>
+            <a:r>
+              <a:rPr sz="2250" i="0" b="1">
+                <a:solidFill>
+                  <a:srgbClr val="7B3FC0"/>
+                </a:solidFill>
+                <a:latin typeface="Arial"/>
+              </a:rPr>
+              <a:t>S</a:t>
+            </a:r>
+          </a:p>
+        </p:txBody>
+      </p:sp>
+      <p:sp>
+        <p:nvSpPr>
+          <p:cNvPr id="18" name="Word Style"/>
+          <p:cNvSpPr txBox="1"/>
+          <p:nvPr/>
+        </p:nvSpPr>
+        <p:spPr>
+          <a:xfrm>
+            <a:off x="3076575" y="3224212"/>
+            <a:ext cx="1143000" cy="304800"/>
+          </a:xfrm>
+          <a:prstGeom prst="rect">
+            <a:avLst/>
+          </a:prstGeom>
+          <a:noFill/>
+        </p:spPr>
+        <p:txBody>
+          <a:bodyPr wrap="square" anchor="ctr" lIns="0" rIns="0" tIns="0" bIns="0">
+            <a:spAutoFit/>
+          </a:bodyPr>
+          <a:lstStyle/>
+          <a:p>
+            <a:pPr algn="l"/>
+            <a:r>
+              <a:rPr sz="1200" i="0" b="1">
+                <a:solidFill>
+                  <a:srgbClr val="1A1A1A"/>
+                </a:solidFill>
+                <a:latin typeface="Arial"/>
+              </a:rPr>
+              <a:t>Style</a:t>
+            </a:r>
+          </a:p>
+        </p:txBody>
+      </p:sp>
+      <p:sp>
+        <p:nvSpPr>
+          <p:cNvPr id="19" name="Meaning Style"/>
+          <p:cNvSpPr txBox="1"/>
+          <p:nvPr/>
+        </p:nvSpPr>
+        <p:spPr>
+          <a:xfrm>
+            <a:off x="4295775" y="3224212"/>
+            <a:ext cx="5334000" cy="304800"/>
+          </a:xfrm>
+          <a:prstGeom prst="rect">
+            <a:avLst/>
+          </a:prstGeom>
+          <a:noFill/>
+        </p:spPr>
+        <p:txBody>
+          <a:bodyPr wrap="square" anchor="ctr" lIns="0" rIns="0" tIns="0" bIns="0">
+            <a:spAutoFit/>
+          </a:bodyPr>
+          <a:lstStyle/>
+          <a:p>
+            <a:pPr algn="l"/>
+            <a:r>
+              <a:rPr sz="1012" i="0" b="0">
+                <a:solidFill>
+                  <a:srgbClr val="6B7280"/>
+                </a:solidFill>
+                <a:latin typeface="Arial"/>
+              </a:rPr>
+              <a:t>how it should be written</a:t>
+            </a:r>
+          </a:p>
+        </p:txBody>
+      </p:sp>
+      <p:sp>
+        <p:nvSpPr>
+          <p:cNvPr id="20" name="Row T"/>
+          <p:cNvSpPr/>
+          <p:nvPr/>
+        </p:nvSpPr>
+        <p:spPr>
+          <a:xfrm>
+            <a:off x="2381250" y="3709988"/>
+            <a:ext cx="7429500" cy="495300"/>
+          </a:xfrm>
+          <a:prstGeom prst="roundRect">
+            <a:avLst>
+              <a:gd name="adj" fmla="val 25000"/>
+            </a:avLst>
+          </a:prstGeom>
+          <a:solidFill>
+            <a:srgbClr val="FFFFFF"/>
+          </a:solidFill>
+          <a:ln w="9525">
+            <a:solidFill>
+              <a:srgbClr val="E4E7EB"/>
+            </a:solidFill>
+          </a:ln>
+          <a:effectLst>
+            <a:outerShdw blurRad="133350" dist="47625" dir="5400000" algn="t" rotWithShape="0">
+              <a:srgbClr val="000000">
+                <a:alpha val="7000"/>
+              </a:srgbClr>
+            </a:outerShdw>
+          </a:effectLst>
+        </p:spPr>
+        <p:txBody>
+          <a:bodyPr rtlCol="0" anchor="ctr"/>
+          <a:lstStyle/>
+          <a:p/>
+        </p:txBody>
+      </p:sp>
+      <p:sp>
+        <p:nvSpPr>
+          <p:cNvPr id="21" name="Letter T"/>
+          <p:cNvSpPr txBox="1"/>
+          <p:nvPr/>
+        </p:nvSpPr>
+        <p:spPr>
+          <a:xfrm>
+            <a:off x="2562225" y="3767138"/>
+            <a:ext cx="381000" cy="381000"/>
+          </a:xfrm>
+          <a:prstGeom prst="rect">
+            <a:avLst/>
+          </a:prstGeom>
+          <a:noFill/>
+        </p:spPr>
+        <p:txBody>
+          <a:bodyPr wrap="square" anchor="ctr" lIns="0" rIns="0" tIns="0" bIns="0">
+            <a:spAutoFit/>
+          </a:bodyPr>
+          <a:lstStyle/>
+          <a:p>
+            <a:pPr algn="ctr"/>
+            <a:r>
+              <a:rPr sz="2250" i="0" b="1">
+                <a:solidFill>
+                  <a:srgbClr val="7B3FC0"/>
+                </a:solidFill>
+                <a:latin typeface="Arial"/>
+              </a:rPr>
+              <a:t>T</a:t>
+            </a:r>
+          </a:p>
+        </p:txBody>
+      </p:sp>
+      <p:sp>
+        <p:nvSpPr>
+          <p:cNvPr id="22" name="Word Tone"/>
+          <p:cNvSpPr txBox="1"/>
+          <p:nvPr/>
+        </p:nvSpPr>
+        <p:spPr>
+          <a:xfrm>
+            <a:off x="3076575" y="3805238"/>
+            <a:ext cx="1143000" cy="304800"/>
+          </a:xfrm>
+          <a:prstGeom prst="rect">
+            <a:avLst/>
+          </a:prstGeom>
+          <a:noFill/>
+        </p:spPr>
+        <p:txBody>
+          <a:bodyPr wrap="square" anchor="ctr" lIns="0" rIns="0" tIns="0" bIns="0">
+            <a:spAutoFit/>
+          </a:bodyPr>
+          <a:lstStyle/>
+          <a:p>
+            <a:pPr algn="l"/>
+            <a:r>
+              <a:rPr sz="1200" i="0" b="1">
+                <a:solidFill>
+                  <a:srgbClr val="1A1A1A"/>
+                </a:solidFill>
+                <a:latin typeface="Arial"/>
+              </a:rPr>
+              <a:t>Tone</a:t>
+            </a:r>
+          </a:p>
+        </p:txBody>
+      </p:sp>
+      <p:sp>
+        <p:nvSpPr>
+          <p:cNvPr id="23" name="Meaning Tone"/>
+          <p:cNvSpPr txBox="1"/>
+          <p:nvPr/>
+        </p:nvSpPr>
+        <p:spPr>
+          <a:xfrm>
+            <a:off x="4295775" y="3805238"/>
+            <a:ext cx="5334000" cy="304800"/>
+          </a:xfrm>
+          <a:prstGeom prst="rect">
+            <a:avLst/>
+          </a:prstGeom>
+          <a:noFill/>
+        </p:spPr>
+        <p:txBody>
+          <a:bodyPr wrap="square" anchor="ctr" lIns="0" rIns="0" tIns="0" bIns="0">
+            <a:spAutoFit/>
+          </a:bodyPr>
+          <a:lstStyle/>
+          <a:p>
+            <a:pPr algn="l"/>
+            <a:r>
+              <a:rPr sz="1012" i="0" b="0">
+                <a:solidFill>
+                  <a:srgbClr val="6B7280"/>
+                </a:solidFill>
+                <a:latin typeface="Arial"/>
+              </a:rPr>
+              <a:t>how it should feel to the reader</a:t>
+            </a:r>
+          </a:p>
+        </p:txBody>
+      </p:sp>
+      <p:sp>
+        <p:nvSpPr>
+          <p:cNvPr id="24" name="Row A"/>
+          <p:cNvSpPr/>
+          <p:nvPr/>
+        </p:nvSpPr>
+        <p:spPr>
+          <a:xfrm>
+            <a:off x="2381250" y="4291012"/>
+            <a:ext cx="7429500" cy="495300"/>
+          </a:xfrm>
+          <a:prstGeom prst="roundRect">
+            <a:avLst>
+              <a:gd name="adj" fmla="val 25000"/>
+            </a:avLst>
+          </a:prstGeom>
+          <a:solidFill>
+            <a:srgbClr val="FFFFFF"/>
+          </a:solidFill>
+          <a:ln w="9525">
+            <a:solidFill>
+              <a:srgbClr val="E4E7EB"/>
+            </a:solidFill>
+          </a:ln>
+          <a:effectLst>
+            <a:outerShdw blurRad="133350" dist="47625" dir="5400000" algn="t" rotWithShape="0">
+              <a:srgbClr val="000000">
+                <a:alpha val="7000"/>
+              </a:srgbClr>
+            </a:outerShdw>
+          </a:effectLst>
+        </p:spPr>
+        <p:txBody>
+          <a:bodyPr rtlCol="0" anchor="ctr"/>
+          <a:lstStyle/>
+          <a:p/>
+        </p:txBody>
+      </p:sp>
+      <p:sp>
+        <p:nvSpPr>
+          <p:cNvPr id="25" name="Letter A"/>
+          <p:cNvSpPr txBox="1"/>
+          <p:nvPr/>
+        </p:nvSpPr>
+        <p:spPr>
+          <a:xfrm>
+            <a:off x="2562225" y="4348162"/>
+            <a:ext cx="381000" cy="381000"/>
+          </a:xfrm>
+          <a:prstGeom prst="rect">
+            <a:avLst/>
+          </a:prstGeom>
+          <a:noFill/>
+        </p:spPr>
+        <p:txBody>
+          <a:bodyPr wrap="square" anchor="ctr" lIns="0" rIns="0" tIns="0" bIns="0">
+            <a:spAutoFit/>
+          </a:bodyPr>
+          <a:lstStyle/>
+          <a:p>
+            <a:pPr algn="ctr"/>
+            <a:r>
+              <a:rPr sz="2250" i="0" b="1">
+                <a:solidFill>
+                  <a:srgbClr val="7B3FC0"/>
+                </a:solidFill>
+                <a:latin typeface="Arial"/>
+              </a:rPr>
+              <a:t>A</a:t>
+            </a:r>
+          </a:p>
+        </p:txBody>
+      </p:sp>
+      <p:sp>
+        <p:nvSpPr>
+          <p:cNvPr id="26" name="Word Audience"/>
+          <p:cNvSpPr txBox="1"/>
+          <p:nvPr/>
+        </p:nvSpPr>
+        <p:spPr>
+          <a:xfrm>
+            <a:off x="3076575" y="4386262"/>
+            <a:ext cx="1143000" cy="304800"/>
+          </a:xfrm>
+          <a:prstGeom prst="rect">
+            <a:avLst/>
+          </a:prstGeom>
+          <a:noFill/>
+        </p:spPr>
+        <p:txBody>
+          <a:bodyPr wrap="square" anchor="ctr" lIns="0" rIns="0" tIns="0" bIns="0">
+            <a:spAutoFit/>
+          </a:bodyPr>
+          <a:lstStyle/>
+          <a:p>
+            <a:pPr algn="l"/>
+            <a:r>
+              <a:rPr sz="1200" i="0" b="1">
+                <a:solidFill>
+                  <a:srgbClr val="1A1A1A"/>
+                </a:solidFill>
+                <a:latin typeface="Arial"/>
+              </a:rPr>
+              <a:t>Audience</a:t>
+            </a:r>
+          </a:p>
+        </p:txBody>
+      </p:sp>
+      <p:sp>
+        <p:nvSpPr>
+          <p:cNvPr id="27" name="Meaning Audience"/>
+          <p:cNvSpPr txBox="1"/>
+          <p:nvPr/>
+        </p:nvSpPr>
+        <p:spPr>
+          <a:xfrm>
+            <a:off x="4295775" y="4386262"/>
+            <a:ext cx="5334000" cy="304800"/>
+          </a:xfrm>
+          <a:prstGeom prst="rect">
+            <a:avLst/>
+          </a:prstGeom>
+          <a:noFill/>
+        </p:spPr>
+        <p:txBody>
+          <a:bodyPr wrap="square" anchor="ctr" lIns="0" rIns="0" tIns="0" bIns="0">
+            <a:spAutoFit/>
+          </a:bodyPr>
+          <a:lstStyle/>
+          <a:p>
+            <a:pPr algn="l"/>
+            <a:r>
+              <a:rPr sz="1012" i="0" b="0">
+                <a:solidFill>
+                  <a:srgbClr val="6B7280"/>
+                </a:solidFill>
+                <a:latin typeface="Arial"/>
+              </a:rPr>
+              <a:t>who will read it</a:t>
+            </a:r>
+          </a:p>
+        </p:txBody>
+      </p:sp>
+      <p:sp>
+        <p:nvSpPr>
+          <p:cNvPr id="28" name="Row R"/>
+          <p:cNvSpPr/>
+          <p:nvPr/>
+        </p:nvSpPr>
+        <p:spPr>
+          <a:xfrm>
+            <a:off x="2381250" y="4872038"/>
+            <a:ext cx="7429500" cy="495300"/>
+          </a:xfrm>
+          <a:prstGeom prst="roundRect">
+            <a:avLst>
+              <a:gd name="adj" fmla="val 25000"/>
+            </a:avLst>
+          </a:prstGeom>
+          <a:solidFill>
+            <a:srgbClr val="FFFFFF"/>
+          </a:solidFill>
+          <a:ln w="9525">
+            <a:solidFill>
+              <a:srgbClr val="E4E7EB"/>
+            </a:solidFill>
+          </a:ln>
+          <a:effectLst>
+            <a:outerShdw blurRad="133350" dist="47625" dir="5400000" algn="t" rotWithShape="0">
+              <a:srgbClr val="000000">
+                <a:alpha val="7000"/>
+              </a:srgbClr>
+            </a:outerShdw>
+          </a:effectLst>
+        </p:spPr>
+        <p:txBody>
+          <a:bodyPr rtlCol="0" anchor="ctr"/>
+          <a:lstStyle/>
+          <a:p/>
+        </p:txBody>
+      </p:sp>
+      <p:sp>
+        <p:nvSpPr>
+          <p:cNvPr id="29" name="Letter R"/>
+          <p:cNvSpPr txBox="1"/>
+          <p:nvPr/>
+        </p:nvSpPr>
+        <p:spPr>
+          <a:xfrm>
+            <a:off x="2562225" y="4929188"/>
+            <a:ext cx="381000" cy="381000"/>
+          </a:xfrm>
+          <a:prstGeom prst="rect">
+            <a:avLst/>
+          </a:prstGeom>
+          <a:noFill/>
+        </p:spPr>
+        <p:txBody>
+          <a:bodyPr wrap="square" anchor="ctr" lIns="0" rIns="0" tIns="0" bIns="0">
+            <a:spAutoFit/>
+          </a:bodyPr>
+          <a:lstStyle/>
+          <a:p>
+            <a:pPr algn="ctr"/>
+            <a:r>
+              <a:rPr sz="2250" i="0" b="1">
+                <a:solidFill>
+                  <a:srgbClr val="7B3FC0"/>
+                </a:solidFill>
+                <a:latin typeface="Arial"/>
+              </a:rPr>
+              <a:t>R</a:t>
+            </a:r>
+          </a:p>
+        </p:txBody>
+      </p:sp>
+      <p:sp>
+        <p:nvSpPr>
+          <p:cNvPr id="30" name="Word Response"/>
+          <p:cNvSpPr txBox="1"/>
+          <p:nvPr/>
+        </p:nvSpPr>
+        <p:spPr>
+          <a:xfrm>
+            <a:off x="3076575" y="4967288"/>
+            <a:ext cx="1143000" cy="304800"/>
+          </a:xfrm>
+          <a:prstGeom prst="rect">
+            <a:avLst/>
+          </a:prstGeom>
+          <a:noFill/>
+        </p:spPr>
+        <p:txBody>
+          <a:bodyPr wrap="square" anchor="ctr" lIns="0" rIns="0" tIns="0" bIns="0">
+            <a:spAutoFit/>
+          </a:bodyPr>
+          <a:lstStyle/>
+          <a:p>
+            <a:pPr algn="l"/>
+            <a:r>
+              <a:rPr sz="1200" i="0" b="1">
+                <a:solidFill>
+                  <a:srgbClr val="1A1A1A"/>
+                </a:solidFill>
+                <a:latin typeface="Arial"/>
+              </a:rPr>
+              <a:t>Response</a:t>
+            </a:r>
+          </a:p>
+        </p:txBody>
+      </p:sp>
+      <p:sp>
+        <p:nvSpPr>
+          <p:cNvPr id="31" name="Meaning Response"/>
+          <p:cNvSpPr txBox="1"/>
+          <p:nvPr/>
+        </p:nvSpPr>
+        <p:spPr>
+          <a:xfrm>
+            <a:off x="4295775" y="4967288"/>
+            <a:ext cx="5334000" cy="304800"/>
+          </a:xfrm>
+          <a:prstGeom prst="rect">
+            <a:avLst/>
+          </a:prstGeom>
+          <a:noFill/>
+        </p:spPr>
+        <p:txBody>
+          <a:bodyPr wrap="square" anchor="ctr" lIns="0" rIns="0" tIns="0" bIns="0">
+            <a:spAutoFit/>
+          </a:bodyPr>
+          <a:lstStyle/>
+          <a:p>
+            <a:pPr algn="l"/>
+            <a:r>
+              <a:rPr sz="1012" i="0" b="0">
+                <a:solidFill>
+                  <a:srgbClr val="6B7280"/>
+                </a:solidFill>
+                <a:latin typeface="Arial"/>
+              </a:rPr>
+              <a:t>format, length and language of the answer</a:t>
+            </a:r>
+          </a:p>
+        </p:txBody>
+      </p:sp>
+      <p:sp>
+        <p:nvSpPr>
+          <p:cNvPr id="32" name="Caption"/>
+          <p:cNvSpPr txBox="1"/>
+          <p:nvPr/>
+        </p:nvSpPr>
+        <p:spPr>
+          <a:xfrm>
+            <a:off x="2381250" y="5581650"/>
+            <a:ext cx="7429500" cy="228600"/>
+          </a:xfrm>
+          <a:prstGeom prst="rect">
+            <a:avLst/>
+          </a:prstGeom>
+          <a:noFill/>
+        </p:spPr>
+        <p:txBody>
+          <a:bodyPr wrap="square" anchor="ctr" lIns="0" rIns="0" tIns="0" bIns="0">
+            <a:spAutoFit/>
+          </a:bodyPr>
+          <a:lstStyle/>
+          <a:p>
+            <a:pPr algn="ctr"/>
+            <a:r>
+              <a:rPr sz="1050" i="1" b="0">
+                <a:solidFill>
+                  <a:srgbClr val="6B7280"/>
+                </a:solidFill>
+                <a:latin typeface="Arial"/>
+              </a:rPr>
+              <a:t>Six boxes to fill before you press enter. Skip what you do not need.</a:t>
+            </a:r>
+          </a:p>
+        </p:txBody>
+      </p:sp>
       <p:pic>
         <p:nvPicPr>
-          <p:cNvPr id="2" name="Or use a framework: COSTAR" descr="Or use a framework: COSTAR"/>
+          <p:cNvPr id="33" name="OCBC icon" descr="ocbc-icon.png"/>
           <p:cNvPicPr>
             <a:picLocks noChangeAspect="1"/>
           </p:cNvPicPr>
@@ -3631,14 +4702,49 @@
         </p:blipFill>
         <p:spPr>
           <a:xfrm>
-            <a:off x="0" y="0"/>
-            <a:ext cx="12192000" cy="6858000"/>
+            <a:off x="723900" y="6438900"/>
+            <a:ext cx="171450" cy="171450"/>
           </a:xfrm>
           <a:prstGeom prst="rect">
             <a:avLst/>
           </a:prstGeom>
         </p:spPr>
       </p:pic>
+      <p:sp>
+        <p:nvSpPr>
+          <p:cNvPr id="34" name="Footer"/>
+          <p:cNvSpPr txBox="1"/>
+          <p:nvPr/>
+        </p:nvSpPr>
+        <p:spPr>
+          <a:xfrm>
+            <a:off x="981075" y="6438900"/>
+            <a:ext cx="1905000" cy="171450"/>
+          </a:xfrm>
+          <a:prstGeom prst="rect">
+            <a:avLst/>
+          </a:prstGeom>
+          <a:noFill/>
+        </p:spPr>
+        <p:txBody>
+          <a:bodyPr wrap="square" anchor="ctr" lIns="0" rIns="0" tIns="0" bIns="0">
+            <a:spAutoFit/>
+          </a:bodyPr>
+          <a:lstStyle/>
+          <a:p>
+            <a:pPr algn="l"/>
+            <a:r>
+              <a:rPr sz="900" i="0" b="1" spc="18">
+                <a:solidFill>
+                  <a:srgbClr val="6B7280"/>
+                </a:solidFill>
+                <a:latin typeface="Arial"/>
+              </a:rPr>
+              <a:t>Learning at Lunch</a:t>
+            </a:r>
+          </a:p>
+        </p:txBody>
+      </p:sp>
     </p:spTree>
   </p:cSld>
   <p:clrMapOvr>
@@ -3657,9 +4763,2025 @@
         <p:nvPr/>
       </p:nvGrpSpPr>
       <p:grpSpPr/>
+      <p:sp>
+        <p:nvSpPr>
+          <p:cNvPr id="2" name="Badge ring"/>
+          <p:cNvSpPr/>
+          <p:nvPr/>
+        </p:nvSpPr>
+        <p:spPr>
+          <a:xfrm>
+            <a:off x="685800" y="552450"/>
+            <a:ext cx="304800" cy="304800"/>
+          </a:xfrm>
+          <a:prstGeom prst="ellipse">
+            <a:avLst/>
+          </a:prstGeom>
+          <a:solidFill>
+            <a:srgbClr val="F3ECFB"/>
+          </a:solidFill>
+          <a:ln>
+            <a:noFill/>
+          </a:ln>
+        </p:spPr>
+        <p:txBody>
+          <a:bodyPr rtlCol="0" anchor="ctr"/>
+          <a:lstStyle/>
+          <a:p/>
+        </p:txBody>
+      </p:sp>
+      <p:sp>
+        <p:nvSpPr>
+          <p:cNvPr id="3" name="Badge"/>
+          <p:cNvSpPr/>
+          <p:nvPr/>
+        </p:nvSpPr>
+        <p:spPr>
+          <a:xfrm>
+            <a:off x="723900" y="590550"/>
+            <a:ext cx="228600" cy="228600"/>
+          </a:xfrm>
+          <a:prstGeom prst="ellipse">
+            <a:avLst/>
+          </a:prstGeom>
+          <a:solidFill>
+            <a:srgbClr val="7B3FC0"/>
+          </a:solidFill>
+          <a:ln>
+            <a:noFill/>
+          </a:ln>
+        </p:spPr>
+        <p:txBody>
+          <a:bodyPr rtlCol="0" anchor="ctr"/>
+          <a:lstStyle/>
+          <a:p/>
+        </p:txBody>
+      </p:sp>
+      <p:sp>
+        <p:nvSpPr>
+          <p:cNvPr id="4" name="Badge sun"/>
+          <p:cNvSpPr/>
+          <p:nvPr/>
+        </p:nvSpPr>
+        <p:spPr>
+          <a:xfrm>
+            <a:off x="771525" y="685800"/>
+            <a:ext cx="133350" cy="85725"/>
+          </a:xfrm>
+          <a:prstGeom prst="triangle">
+            <a:avLst/>
+          </a:prstGeom>
+          <a:solidFill>
+            <a:srgbClr val="FFFFFF"/>
+          </a:solidFill>
+          <a:ln>
+            <a:noFill/>
+          </a:ln>
+        </p:spPr>
+        <p:txBody>
+          <a:bodyPr rtlCol="0" anchor="ctr"/>
+          <a:lstStyle/>
+          <a:p/>
+        </p:txBody>
+      </p:sp>
+      <p:sp>
+        <p:nvSpPr>
+          <p:cNvPr id="5" name="Badge horizon"/>
+          <p:cNvSpPr/>
+          <p:nvPr/>
+        </p:nvSpPr>
+        <p:spPr>
+          <a:xfrm>
+            <a:off x="747712" y="754380"/>
+            <a:ext cx="180975" cy="14288"/>
+          </a:xfrm>
+          <a:prstGeom prst="rect">
+            <a:avLst/>
+          </a:prstGeom>
+          <a:solidFill>
+            <a:srgbClr val="FFFFFF"/>
+          </a:solidFill>
+          <a:ln>
+            <a:noFill/>
+          </a:ln>
+        </p:spPr>
+        <p:txBody>
+          <a:bodyPr rtlCol="0" anchor="ctr"/>
+          <a:lstStyle/>
+          <a:p/>
+        </p:txBody>
+      </p:sp>
+      <p:sp>
+        <p:nvSpPr>
+          <p:cNvPr id="6" name="Kicker"/>
+          <p:cNvSpPr txBox="1"/>
+          <p:nvPr/>
+        </p:nvSpPr>
+        <p:spPr>
+          <a:xfrm>
+            <a:off x="1057275" y="590550"/>
+            <a:ext cx="2476500" cy="228600"/>
+          </a:xfrm>
+          <a:prstGeom prst="rect">
+            <a:avLst/>
+          </a:prstGeom>
+          <a:noFill/>
+        </p:spPr>
+        <p:txBody>
+          <a:bodyPr wrap="square" anchor="ctr" lIns="0" rIns="0" tIns="0" bIns="0">
+            <a:spAutoFit/>
+          </a:bodyPr>
+          <a:lstStyle/>
+          <a:p>
+            <a:pPr algn="l"/>
+            <a:r>
+              <a:rPr sz="975" i="0" b="1" spc="136">
+                <a:solidFill>
+                  <a:srgbClr val="7B3FC0"/>
+                </a:solidFill>
+                <a:latin typeface="Arial"/>
+              </a:rPr>
+              <a:t>PART 1 · PROMPTING</a:t>
+            </a:r>
+          </a:p>
+        </p:txBody>
+      </p:sp>
+      <p:sp>
+        <p:nvSpPr>
+          <p:cNvPr id="7" name="Title"/>
+          <p:cNvSpPr txBox="1"/>
+          <p:nvPr/>
+        </p:nvSpPr>
+        <p:spPr>
+          <a:xfrm>
+            <a:off x="723900" y="933450"/>
+            <a:ext cx="8572500" cy="476250"/>
+          </a:xfrm>
+          <a:prstGeom prst="rect">
+            <a:avLst/>
+          </a:prstGeom>
+          <a:noFill/>
+        </p:spPr>
+        <p:txBody>
+          <a:bodyPr wrap="square" anchor="ctr" lIns="0" rIns="0" tIns="0" bIns="0">
+            <a:spAutoFit/>
+          </a:bodyPr>
+          <a:lstStyle/>
+          <a:p>
+            <a:pPr algn="l"/>
+            <a:r>
+              <a:rPr sz="2850" i="0" b="1" spc="-57">
+                <a:solidFill>
+                  <a:srgbClr val="1A1A1A"/>
+                </a:solidFill>
+                <a:latin typeface="Arial"/>
+              </a:rPr>
+              <a:t>COSTAR, filled in</a:t>
+            </a:r>
+          </a:p>
+        </p:txBody>
+      </p:sp>
+      <p:sp>
+        <p:nvSpPr>
+          <p:cNvPr id="8" name="Prompt card"/>
+          <p:cNvSpPr/>
+          <p:nvPr/>
+        </p:nvSpPr>
+        <p:spPr>
+          <a:xfrm>
+            <a:off x="723900" y="2069782"/>
+            <a:ext cx="4455795" cy="3605212"/>
+          </a:xfrm>
+          <a:prstGeom prst="roundRect">
+            <a:avLst>
+              <a:gd name="adj" fmla="val 4227"/>
+            </a:avLst>
+          </a:prstGeom>
+          <a:solidFill>
+            <a:srgbClr val="FFFFFF"/>
+          </a:solidFill>
+          <a:ln w="9525">
+            <a:solidFill>
+              <a:srgbClr val="E4E7EB"/>
+            </a:solidFill>
+          </a:ln>
+          <a:effectLst>
+            <a:outerShdw blurRad="247650" dist="95250" dir="5400000" algn="t" rotWithShape="0">
+              <a:srgbClr val="000000">
+                <a:alpha val="9000"/>
+              </a:srgbClr>
+            </a:outerShdw>
+          </a:effectLst>
+        </p:spPr>
+        <p:txBody>
+          <a:bodyPr rtlCol="0" anchor="ctr"/>
+          <a:lstStyle/>
+          <a:p/>
+        </p:txBody>
+      </p:sp>
+      <p:sp>
+        <p:nvSpPr>
+          <p:cNvPr id="9" name="Window dot 1"/>
+          <p:cNvSpPr/>
+          <p:nvPr/>
+        </p:nvSpPr>
+        <p:spPr>
+          <a:xfrm>
+            <a:off x="962025" y="2288858"/>
+            <a:ext cx="95250" cy="95250"/>
+          </a:xfrm>
+          <a:prstGeom prst="ellipse">
+            <a:avLst/>
+          </a:prstGeom>
+          <a:solidFill>
+            <a:srgbClr val="7B3FC0"/>
+          </a:solidFill>
+          <a:ln>
+            <a:noFill/>
+          </a:ln>
+        </p:spPr>
+        <p:txBody>
+          <a:bodyPr rtlCol="0" anchor="ctr"/>
+          <a:lstStyle/>
+          <a:p/>
+        </p:txBody>
+      </p:sp>
+      <p:sp>
+        <p:nvSpPr>
+          <p:cNvPr id="10" name="Window dot 2"/>
+          <p:cNvSpPr/>
+          <p:nvPr/>
+        </p:nvSpPr>
+        <p:spPr>
+          <a:xfrm>
+            <a:off x="1123950" y="2288858"/>
+            <a:ext cx="95250" cy="95250"/>
+          </a:xfrm>
+          <a:prstGeom prst="ellipse">
+            <a:avLst/>
+          </a:prstGeom>
+          <a:solidFill>
+            <a:srgbClr val="E6E8EC"/>
+          </a:solidFill>
+          <a:ln>
+            <a:noFill/>
+          </a:ln>
+        </p:spPr>
+        <p:txBody>
+          <a:bodyPr rtlCol="0" anchor="ctr"/>
+          <a:lstStyle/>
+          <a:p/>
+        </p:txBody>
+      </p:sp>
+      <p:sp>
+        <p:nvSpPr>
+          <p:cNvPr id="11" name="Window dot 3"/>
+          <p:cNvSpPr/>
+          <p:nvPr/>
+        </p:nvSpPr>
+        <p:spPr>
+          <a:xfrm>
+            <a:off x="1285875" y="2288858"/>
+            <a:ext cx="95250" cy="95250"/>
+          </a:xfrm>
+          <a:prstGeom prst="ellipse">
+            <a:avLst/>
+          </a:prstGeom>
+          <a:solidFill>
+            <a:srgbClr val="E6E8EC"/>
+          </a:solidFill>
+          <a:ln>
+            <a:noFill/>
+          </a:ln>
+        </p:spPr>
+        <p:txBody>
+          <a:bodyPr rtlCol="0" anchor="ctr"/>
+          <a:lstStyle/>
+          <a:p/>
+        </p:txBody>
+      </p:sp>
+      <p:sp>
+        <p:nvSpPr>
+          <p:cNvPr id="12" name="Prompt label"/>
+          <p:cNvSpPr txBox="1"/>
+          <p:nvPr/>
+        </p:nvSpPr>
+        <p:spPr>
+          <a:xfrm>
+            <a:off x="1504950" y="2250758"/>
+            <a:ext cx="2381250" cy="171450"/>
+          </a:xfrm>
+          <a:prstGeom prst="rect">
+            <a:avLst/>
+          </a:prstGeom>
+          <a:noFill/>
+        </p:spPr>
+        <p:txBody>
+          <a:bodyPr wrap="square" anchor="ctr" lIns="0" rIns="0" tIns="0" bIns="0">
+            <a:spAutoFit/>
+          </a:bodyPr>
+          <a:lstStyle/>
+          <a:p>
+            <a:pPr algn="l"/>
+            <a:r>
+              <a:rPr sz="825" i="0" b="0">
+                <a:solidFill>
+                  <a:srgbClr val="9AA1AC"/>
+                </a:solidFill>
+                <a:latin typeface="Courier New"/>
+              </a:rPr>
+              <a:t>prompt · costar · bahasa</a:t>
+            </a:r>
+          </a:p>
+        </p:txBody>
+      </p:sp>
+      <p:sp>
+        <p:nvSpPr>
+          <p:cNvPr id="13" name="Tag C disc"/>
+          <p:cNvSpPr/>
+          <p:nvPr/>
+        </p:nvSpPr>
+        <p:spPr>
+          <a:xfrm>
+            <a:off x="962025" y="2607945"/>
+            <a:ext cx="228600" cy="228600"/>
+          </a:xfrm>
+          <a:prstGeom prst="ellipse">
+            <a:avLst/>
+          </a:prstGeom>
+          <a:solidFill>
+            <a:srgbClr val="F3ECFB"/>
+          </a:solidFill>
+          <a:ln>
+            <a:noFill/>
+          </a:ln>
+        </p:spPr>
+        <p:txBody>
+          <a:bodyPr rtlCol="0" anchor="ctr"/>
+          <a:lstStyle/>
+          <a:p/>
+        </p:txBody>
+      </p:sp>
+      <p:sp>
+        <p:nvSpPr>
+          <p:cNvPr id="14" name="Tag C"/>
+          <p:cNvSpPr txBox="1"/>
+          <p:nvPr/>
+        </p:nvSpPr>
+        <p:spPr>
+          <a:xfrm>
+            <a:off x="962025" y="2607945"/>
+            <a:ext cx="228600" cy="228600"/>
+          </a:xfrm>
+          <a:prstGeom prst="rect">
+            <a:avLst/>
+          </a:prstGeom>
+          <a:noFill/>
+        </p:spPr>
+        <p:txBody>
+          <a:bodyPr wrap="square" anchor="ctr" lIns="0" rIns="0" tIns="0" bIns="0">
+            <a:spAutoFit/>
+          </a:bodyPr>
+          <a:lstStyle/>
+          <a:p>
+            <a:pPr algn="ctr"/>
+            <a:r>
+              <a:rPr sz="900" i="0" b="1">
+                <a:solidFill>
+                  <a:srgbClr val="7B3FC0"/>
+                </a:solidFill>
+                <a:latin typeface="Arial"/>
+              </a:rPr>
+              <a:t>C</a:t>
+            </a:r>
+          </a:p>
+        </p:txBody>
+      </p:sp>
+      <p:sp>
+        <p:nvSpPr>
+          <p:cNvPr id="15" name="Prompt C"/>
+          <p:cNvSpPr txBox="1"/>
+          <p:nvPr/>
+        </p:nvSpPr>
+        <p:spPr>
+          <a:xfrm>
+            <a:off x="1304925" y="2598420"/>
+            <a:ext cx="3714750" cy="433388"/>
+          </a:xfrm>
+          <a:prstGeom prst="rect">
+            <a:avLst/>
+          </a:prstGeom>
+          <a:noFill/>
+        </p:spPr>
+        <p:txBody>
+          <a:bodyPr wrap="square" anchor="t" lIns="0" rIns="0" tIns="0" bIns="0">
+            <a:spAutoFit/>
+          </a:bodyPr>
+          <a:lstStyle/>
+          <a:p>
+            <a:pPr algn="l">
+              <a:lnSpc>
+                <a:spcPts val="1631"/>
+              </a:lnSpc>
+            </a:pPr>
+            <a:r>
+              <a:rPr sz="1087" i="0" b="0">
+                <a:solidFill>
+                  <a:srgbClr val="1F2937"/>
+                </a:solidFill>
+                <a:latin typeface="Arial"/>
+              </a:rPr>
+              <a:t>Saya team leader operasional cabang. Di bawah saya tempel </a:t>
+            </a:r>
+            <a:r>
+              <a:rPr sz="1087" i="0" b="1">
+                <a:solidFill>
+                  <a:srgbClr val="1A1A1A"/>
+                </a:solidFill>
+                <a:latin typeface="Arial"/>
+              </a:rPr>
+              <a:t>catatan komplain nasabah</a:t>
+            </a:r>
+            <a:r>
+              <a:rPr sz="1087" i="0" b="0">
+                <a:solidFill>
+                  <a:srgbClr val="1F2937"/>
+                </a:solidFill>
+                <a:latin typeface="Arial"/>
+              </a:rPr>
+              <a:t> minggu ini.</a:t>
+            </a:r>
+          </a:p>
+        </p:txBody>
+      </p:sp>
+      <p:sp>
+        <p:nvSpPr>
+          <p:cNvPr id="16" name="Tag O disc"/>
+          <p:cNvSpPr/>
+          <p:nvPr/>
+        </p:nvSpPr>
+        <p:spPr>
+          <a:xfrm>
+            <a:off x="962025" y="3146108"/>
+            <a:ext cx="228600" cy="228600"/>
+          </a:xfrm>
+          <a:prstGeom prst="ellipse">
+            <a:avLst/>
+          </a:prstGeom>
+          <a:solidFill>
+            <a:srgbClr val="F3ECFB"/>
+          </a:solidFill>
+          <a:ln>
+            <a:noFill/>
+          </a:ln>
+        </p:spPr>
+        <p:txBody>
+          <a:bodyPr rtlCol="0" anchor="ctr"/>
+          <a:lstStyle/>
+          <a:p/>
+        </p:txBody>
+      </p:sp>
+      <p:sp>
+        <p:nvSpPr>
+          <p:cNvPr id="17" name="Tag O"/>
+          <p:cNvSpPr txBox="1"/>
+          <p:nvPr/>
+        </p:nvSpPr>
+        <p:spPr>
+          <a:xfrm>
+            <a:off x="962025" y="3146108"/>
+            <a:ext cx="228600" cy="228600"/>
+          </a:xfrm>
+          <a:prstGeom prst="rect">
+            <a:avLst/>
+          </a:prstGeom>
+          <a:noFill/>
+        </p:spPr>
+        <p:txBody>
+          <a:bodyPr wrap="square" anchor="ctr" lIns="0" rIns="0" tIns="0" bIns="0">
+            <a:spAutoFit/>
+          </a:bodyPr>
+          <a:lstStyle/>
+          <a:p>
+            <a:pPr algn="ctr"/>
+            <a:r>
+              <a:rPr sz="900" i="0" b="1">
+                <a:solidFill>
+                  <a:srgbClr val="7B3FC0"/>
+                </a:solidFill>
+                <a:latin typeface="Arial"/>
+              </a:rPr>
+              <a:t>O</a:t>
+            </a:r>
+          </a:p>
+        </p:txBody>
+      </p:sp>
+      <p:sp>
+        <p:nvSpPr>
+          <p:cNvPr id="18" name="Prompt O"/>
+          <p:cNvSpPr txBox="1"/>
+          <p:nvPr/>
+        </p:nvSpPr>
+        <p:spPr>
+          <a:xfrm>
+            <a:off x="1304925" y="3136582"/>
+            <a:ext cx="3714750" cy="226695"/>
+          </a:xfrm>
+          <a:prstGeom prst="rect">
+            <a:avLst/>
+          </a:prstGeom>
+          <a:noFill/>
+        </p:spPr>
+        <p:txBody>
+          <a:bodyPr wrap="square" anchor="t" lIns="0" rIns="0" tIns="0" bIns="0">
+            <a:spAutoFit/>
+          </a:bodyPr>
+          <a:lstStyle/>
+          <a:p>
+            <a:pPr algn="l">
+              <a:lnSpc>
+                <a:spcPts val="1631"/>
+              </a:lnSpc>
+            </a:pPr>
+            <a:r>
+              <a:rPr sz="1087" i="0" b="0">
+                <a:solidFill>
+                  <a:srgbClr val="1F2937"/>
+                </a:solidFill>
+                <a:latin typeface="Arial"/>
+              </a:rPr>
+              <a:t>Buat </a:t>
+            </a:r>
+            <a:r>
+              <a:rPr sz="1087" i="0" b="1">
+                <a:solidFill>
+                  <a:srgbClr val="1A1A1A"/>
+                </a:solidFill>
+                <a:latin typeface="Arial"/>
+              </a:rPr>
+              <a:t>laporan rekap komplain</a:t>
+            </a:r>
+            <a:r>
+              <a:rPr sz="1087" i="0" b="0">
+                <a:solidFill>
+                  <a:srgbClr val="1F2937"/>
+                </a:solidFill>
+                <a:latin typeface="Arial"/>
+              </a:rPr>
+              <a:t> berbentuk tabel.</a:t>
+            </a:r>
+          </a:p>
+        </p:txBody>
+      </p:sp>
+      <p:sp>
+        <p:nvSpPr>
+          <p:cNvPr id="19" name="Tag S disc"/>
+          <p:cNvSpPr/>
+          <p:nvPr/>
+        </p:nvSpPr>
+        <p:spPr>
+          <a:xfrm>
+            <a:off x="962025" y="3508058"/>
+            <a:ext cx="228600" cy="228600"/>
+          </a:xfrm>
+          <a:prstGeom prst="ellipse">
+            <a:avLst/>
+          </a:prstGeom>
+          <a:solidFill>
+            <a:srgbClr val="F3ECFB"/>
+          </a:solidFill>
+          <a:ln>
+            <a:noFill/>
+          </a:ln>
+        </p:spPr>
+        <p:txBody>
+          <a:bodyPr rtlCol="0" anchor="ctr"/>
+          <a:lstStyle/>
+          <a:p/>
+        </p:txBody>
+      </p:sp>
+      <p:sp>
+        <p:nvSpPr>
+          <p:cNvPr id="20" name="Tag S"/>
+          <p:cNvSpPr txBox="1"/>
+          <p:nvPr/>
+        </p:nvSpPr>
+        <p:spPr>
+          <a:xfrm>
+            <a:off x="962025" y="3508058"/>
+            <a:ext cx="228600" cy="228600"/>
+          </a:xfrm>
+          <a:prstGeom prst="rect">
+            <a:avLst/>
+          </a:prstGeom>
+          <a:noFill/>
+        </p:spPr>
+        <p:txBody>
+          <a:bodyPr wrap="square" anchor="ctr" lIns="0" rIns="0" tIns="0" bIns="0">
+            <a:spAutoFit/>
+          </a:bodyPr>
+          <a:lstStyle/>
+          <a:p>
+            <a:pPr algn="ctr"/>
+            <a:r>
+              <a:rPr sz="900" i="0" b="1">
+                <a:solidFill>
+                  <a:srgbClr val="7B3FC0"/>
+                </a:solidFill>
+                <a:latin typeface="Arial"/>
+              </a:rPr>
+              <a:t>S</a:t>
+            </a:r>
+          </a:p>
+        </p:txBody>
+      </p:sp>
+      <p:sp>
+        <p:nvSpPr>
+          <p:cNvPr id="21" name="Prompt S"/>
+          <p:cNvSpPr txBox="1"/>
+          <p:nvPr/>
+        </p:nvSpPr>
+        <p:spPr>
+          <a:xfrm>
+            <a:off x="1304925" y="3498532"/>
+            <a:ext cx="3714750" cy="226695"/>
+          </a:xfrm>
+          <a:prstGeom prst="rect">
+            <a:avLst/>
+          </a:prstGeom>
+          <a:noFill/>
+        </p:spPr>
+        <p:txBody>
+          <a:bodyPr wrap="square" anchor="t" lIns="0" rIns="0" tIns="0" bIns="0">
+            <a:spAutoFit/>
+          </a:bodyPr>
+          <a:lstStyle/>
+          <a:p>
+            <a:pPr algn="l">
+              <a:lnSpc>
+                <a:spcPts val="1631"/>
+              </a:lnSpc>
+            </a:pPr>
+            <a:r>
+              <a:rPr sz="1087" i="0" b="1">
+                <a:solidFill>
+                  <a:srgbClr val="1A1A1A"/>
+                </a:solidFill>
+                <a:latin typeface="Arial"/>
+              </a:rPr>
+              <a:t>Ringkas dan rapi</a:t>
+            </a:r>
+            <a:r>
+              <a:rPr sz="1087" i="0" b="0">
+                <a:solidFill>
+                  <a:srgbClr val="1F2937"/>
+                </a:solidFill>
+                <a:latin typeface="Arial"/>
+              </a:rPr>
+              <a:t>, siap tempel ke email.</a:t>
+            </a:r>
+          </a:p>
+        </p:txBody>
+      </p:sp>
+      <p:sp>
+        <p:nvSpPr>
+          <p:cNvPr id="22" name="Tag T disc"/>
+          <p:cNvSpPr/>
+          <p:nvPr/>
+        </p:nvSpPr>
+        <p:spPr>
+          <a:xfrm>
+            <a:off x="962025" y="3870008"/>
+            <a:ext cx="228600" cy="228600"/>
+          </a:xfrm>
+          <a:prstGeom prst="ellipse">
+            <a:avLst/>
+          </a:prstGeom>
+          <a:solidFill>
+            <a:srgbClr val="F3ECFB"/>
+          </a:solidFill>
+          <a:ln>
+            <a:noFill/>
+          </a:ln>
+        </p:spPr>
+        <p:txBody>
+          <a:bodyPr rtlCol="0" anchor="ctr"/>
+          <a:lstStyle/>
+          <a:p/>
+        </p:txBody>
+      </p:sp>
+      <p:sp>
+        <p:nvSpPr>
+          <p:cNvPr id="23" name="Tag T"/>
+          <p:cNvSpPr txBox="1"/>
+          <p:nvPr/>
+        </p:nvSpPr>
+        <p:spPr>
+          <a:xfrm>
+            <a:off x="962025" y="3870008"/>
+            <a:ext cx="228600" cy="228600"/>
+          </a:xfrm>
+          <a:prstGeom prst="rect">
+            <a:avLst/>
+          </a:prstGeom>
+          <a:noFill/>
+        </p:spPr>
+        <p:txBody>
+          <a:bodyPr wrap="square" anchor="ctr" lIns="0" rIns="0" tIns="0" bIns="0">
+            <a:spAutoFit/>
+          </a:bodyPr>
+          <a:lstStyle/>
+          <a:p>
+            <a:pPr algn="ctr"/>
+            <a:r>
+              <a:rPr sz="900" i="0" b="1">
+                <a:solidFill>
+                  <a:srgbClr val="7B3FC0"/>
+                </a:solidFill>
+                <a:latin typeface="Arial"/>
+              </a:rPr>
+              <a:t>T</a:t>
+            </a:r>
+          </a:p>
+        </p:txBody>
+      </p:sp>
+      <p:sp>
+        <p:nvSpPr>
+          <p:cNvPr id="24" name="Prompt T"/>
+          <p:cNvSpPr txBox="1"/>
+          <p:nvPr/>
+        </p:nvSpPr>
+        <p:spPr>
+          <a:xfrm>
+            <a:off x="1304925" y="3860482"/>
+            <a:ext cx="3714750" cy="226695"/>
+          </a:xfrm>
+          <a:prstGeom prst="rect">
+            <a:avLst/>
+          </a:prstGeom>
+          <a:noFill/>
+        </p:spPr>
+        <p:txBody>
+          <a:bodyPr wrap="square" anchor="t" lIns="0" rIns="0" tIns="0" bIns="0">
+            <a:spAutoFit/>
+          </a:bodyPr>
+          <a:lstStyle/>
+          <a:p>
+            <a:pPr algn="l">
+              <a:lnSpc>
+                <a:spcPts val="1631"/>
+              </a:lnSpc>
+            </a:pPr>
+            <a:r>
+              <a:rPr sz="1087" i="0" b="1">
+                <a:solidFill>
+                  <a:srgbClr val="1A1A1A"/>
+                </a:solidFill>
+                <a:latin typeface="Arial"/>
+              </a:rPr>
+              <a:t>Netral dan faktual.</a:t>
+            </a:r>
+          </a:p>
+        </p:txBody>
+      </p:sp>
+      <p:sp>
+        <p:nvSpPr>
+          <p:cNvPr id="25" name="Tag A disc"/>
+          <p:cNvSpPr/>
+          <p:nvPr/>
+        </p:nvSpPr>
+        <p:spPr>
+          <a:xfrm>
+            <a:off x="962025" y="4231958"/>
+            <a:ext cx="228600" cy="228600"/>
+          </a:xfrm>
+          <a:prstGeom prst="ellipse">
+            <a:avLst/>
+          </a:prstGeom>
+          <a:solidFill>
+            <a:srgbClr val="F3ECFB"/>
+          </a:solidFill>
+          <a:ln>
+            <a:noFill/>
+          </a:ln>
+        </p:spPr>
+        <p:txBody>
+          <a:bodyPr rtlCol="0" anchor="ctr"/>
+          <a:lstStyle/>
+          <a:p/>
+        </p:txBody>
+      </p:sp>
+      <p:sp>
+        <p:nvSpPr>
+          <p:cNvPr id="26" name="Tag A"/>
+          <p:cNvSpPr txBox="1"/>
+          <p:nvPr/>
+        </p:nvSpPr>
+        <p:spPr>
+          <a:xfrm>
+            <a:off x="962025" y="4231958"/>
+            <a:ext cx="228600" cy="228600"/>
+          </a:xfrm>
+          <a:prstGeom prst="rect">
+            <a:avLst/>
+          </a:prstGeom>
+          <a:noFill/>
+        </p:spPr>
+        <p:txBody>
+          <a:bodyPr wrap="square" anchor="ctr" lIns="0" rIns="0" tIns="0" bIns="0">
+            <a:spAutoFit/>
+          </a:bodyPr>
+          <a:lstStyle/>
+          <a:p>
+            <a:pPr algn="ctr"/>
+            <a:r>
+              <a:rPr sz="900" i="0" b="1">
+                <a:solidFill>
+                  <a:srgbClr val="7B3FC0"/>
+                </a:solidFill>
+                <a:latin typeface="Arial"/>
+              </a:rPr>
+              <a:t>A</a:t>
+            </a:r>
+          </a:p>
+        </p:txBody>
+      </p:sp>
+      <p:sp>
+        <p:nvSpPr>
+          <p:cNvPr id="27" name="Prompt A"/>
+          <p:cNvSpPr txBox="1"/>
+          <p:nvPr/>
+        </p:nvSpPr>
+        <p:spPr>
+          <a:xfrm>
+            <a:off x="1304925" y="4222432"/>
+            <a:ext cx="3714750" cy="226695"/>
+          </a:xfrm>
+          <a:prstGeom prst="rect">
+            <a:avLst/>
+          </a:prstGeom>
+          <a:noFill/>
+        </p:spPr>
+        <p:txBody>
+          <a:bodyPr wrap="square" anchor="t" lIns="0" rIns="0" tIns="0" bIns="0">
+            <a:spAutoFit/>
+          </a:bodyPr>
+          <a:lstStyle/>
+          <a:p>
+            <a:pPr algn="l">
+              <a:lnSpc>
+                <a:spcPts val="1631"/>
+              </a:lnSpc>
+            </a:pPr>
+            <a:r>
+              <a:rPr sz="1087" i="0" b="0">
+                <a:solidFill>
+                  <a:srgbClr val="1F2937"/>
+                </a:solidFill>
+                <a:latin typeface="Arial"/>
+              </a:rPr>
+              <a:t>Kepala cabang, membaca dalam </a:t>
+            </a:r>
+            <a:r>
+              <a:rPr sz="1087" i="0" b="1">
+                <a:solidFill>
+                  <a:srgbClr val="1A1A1A"/>
+                </a:solidFill>
+                <a:latin typeface="Arial"/>
+              </a:rPr>
+              <a:t>1 menit</a:t>
+            </a:r>
+            <a:r>
+              <a:rPr sz="1087" i="0" b="0">
+                <a:solidFill>
+                  <a:srgbClr val="1F2937"/>
+                </a:solidFill>
+                <a:latin typeface="Arial"/>
+              </a:rPr>
+              <a:t>.</a:t>
+            </a:r>
+          </a:p>
+        </p:txBody>
+      </p:sp>
+      <p:sp>
+        <p:nvSpPr>
+          <p:cNvPr id="28" name="Tag R disc"/>
+          <p:cNvSpPr/>
+          <p:nvPr/>
+        </p:nvSpPr>
+        <p:spPr>
+          <a:xfrm>
+            <a:off x="962025" y="4593908"/>
+            <a:ext cx="228600" cy="228600"/>
+          </a:xfrm>
+          <a:prstGeom prst="ellipse">
+            <a:avLst/>
+          </a:prstGeom>
+          <a:solidFill>
+            <a:srgbClr val="F3ECFB"/>
+          </a:solidFill>
+          <a:ln>
+            <a:noFill/>
+          </a:ln>
+        </p:spPr>
+        <p:txBody>
+          <a:bodyPr rtlCol="0" anchor="ctr"/>
+          <a:lstStyle/>
+          <a:p/>
+        </p:txBody>
+      </p:sp>
+      <p:sp>
+        <p:nvSpPr>
+          <p:cNvPr id="29" name="Tag R"/>
+          <p:cNvSpPr txBox="1"/>
+          <p:nvPr/>
+        </p:nvSpPr>
+        <p:spPr>
+          <a:xfrm>
+            <a:off x="962025" y="4593908"/>
+            <a:ext cx="228600" cy="228600"/>
+          </a:xfrm>
+          <a:prstGeom prst="rect">
+            <a:avLst/>
+          </a:prstGeom>
+          <a:noFill/>
+        </p:spPr>
+        <p:txBody>
+          <a:bodyPr wrap="square" anchor="ctr" lIns="0" rIns="0" tIns="0" bIns="0">
+            <a:spAutoFit/>
+          </a:bodyPr>
+          <a:lstStyle/>
+          <a:p>
+            <a:pPr algn="ctr"/>
+            <a:r>
+              <a:rPr sz="900" i="0" b="1">
+                <a:solidFill>
+                  <a:srgbClr val="7B3FC0"/>
+                </a:solidFill>
+                <a:latin typeface="Arial"/>
+              </a:rPr>
+              <a:t>R</a:t>
+            </a:r>
+          </a:p>
+        </p:txBody>
+      </p:sp>
+      <p:sp>
+        <p:nvSpPr>
+          <p:cNvPr id="30" name="Prompt R"/>
+          <p:cNvSpPr txBox="1"/>
+          <p:nvPr/>
+        </p:nvSpPr>
+        <p:spPr>
+          <a:xfrm>
+            <a:off x="1304925" y="4584382"/>
+            <a:ext cx="3714750" cy="847725"/>
+          </a:xfrm>
+          <a:prstGeom prst="rect">
+            <a:avLst/>
+          </a:prstGeom>
+          <a:noFill/>
+        </p:spPr>
+        <p:txBody>
+          <a:bodyPr wrap="square" anchor="t" lIns="0" rIns="0" tIns="0" bIns="0">
+            <a:spAutoFit/>
+          </a:bodyPr>
+          <a:lstStyle/>
+          <a:p>
+            <a:pPr algn="l">
+              <a:lnSpc>
+                <a:spcPts val="1631"/>
+              </a:lnSpc>
+            </a:pPr>
+            <a:r>
+              <a:rPr sz="1087" i="0" b="0">
+                <a:solidFill>
+                  <a:srgbClr val="1F2937"/>
+                </a:solidFill>
+                <a:latin typeface="Arial"/>
+              </a:rPr>
+              <a:t>Kolom persis: </a:t>
+            </a:r>
+            <a:r>
+              <a:rPr sz="1087" i="0" b="1">
+                <a:solidFill>
+                  <a:srgbClr val="1A1A1A"/>
+                </a:solidFill>
+                <a:latin typeface="Arial"/>
+              </a:rPr>
+              <a:t>Tanggal, Kanal, Jenis Komplain, Status, Tindak Lanjut</a:t>
+            </a:r>
+            <a:r>
+              <a:rPr sz="1087" i="0" b="0">
+                <a:solidFill>
+                  <a:srgbClr val="1F2937"/>
+                </a:solidFill>
+                <a:latin typeface="Arial"/>
+              </a:rPr>
+              <a:t>. Hanya dari catatan saya; data yang tidak ada tulis </a:t>
+            </a:r>
+            <a:r>
+              <a:rPr sz="1087" i="0" b="1">
+                <a:solidFill>
+                  <a:srgbClr val="1A1A1A"/>
+                </a:solidFill>
+                <a:latin typeface="Arial"/>
+              </a:rPr>
+              <a:t>N/A</a:t>
+            </a:r>
+            <a:r>
+              <a:rPr sz="1087" i="0" b="0">
+                <a:solidFill>
+                  <a:srgbClr val="1F2937"/>
+                </a:solidFill>
+                <a:latin typeface="Arial"/>
+              </a:rPr>
+              <a:t>. Jangan menambah atau mengarang.</a:t>
+            </a:r>
+          </a:p>
+        </p:txBody>
+      </p:sp>
+      <p:sp>
+        <p:nvSpPr>
+          <p:cNvPr id="31" name="Result pill"/>
+          <p:cNvSpPr/>
+          <p:nvPr/>
+        </p:nvSpPr>
+        <p:spPr>
+          <a:xfrm>
+            <a:off x="5560695" y="2771775"/>
+            <a:ext cx="1076325" cy="247650"/>
+          </a:xfrm>
+          <a:prstGeom prst="roundRect">
+            <a:avLst>
+              <a:gd name="adj" fmla="val 50000"/>
+            </a:avLst>
+          </a:prstGeom>
+          <a:solidFill>
+            <a:srgbClr val="E9F7EE"/>
+          </a:solidFill>
+          <a:ln w="9525">
+            <a:solidFill>
+              <a:srgbClr val="CDEBD8"/>
+            </a:solidFill>
+          </a:ln>
+        </p:spPr>
+        <p:txBody>
+          <a:bodyPr rtlCol="0" anchor="ctr"/>
+          <a:lstStyle/>
+          <a:p/>
+        </p:txBody>
+      </p:sp>
+      <p:sp>
+        <p:nvSpPr>
+          <p:cNvPr id="32" name="Result label"/>
+          <p:cNvSpPr txBox="1"/>
+          <p:nvPr/>
+        </p:nvSpPr>
+        <p:spPr>
+          <a:xfrm>
+            <a:off x="5560695" y="2771775"/>
+            <a:ext cx="1076325" cy="247650"/>
+          </a:xfrm>
+          <a:prstGeom prst="rect">
+            <a:avLst/>
+          </a:prstGeom>
+          <a:noFill/>
+        </p:spPr>
+        <p:txBody>
+          <a:bodyPr wrap="square" anchor="ctr" lIns="0" rIns="0" tIns="0" bIns="0">
+            <a:spAutoFit/>
+          </a:bodyPr>
+          <a:lstStyle/>
+          <a:p>
+            <a:pPr algn="ctr"/>
+            <a:r>
+              <a:rPr sz="787" i="0" b="1" spc="70">
+                <a:solidFill>
+                  <a:srgbClr val="14663F"/>
+                </a:solidFill>
+                <a:latin typeface="Courier New"/>
+              </a:rPr>
+              <a:t>✓ THE RESULT</a:t>
+            </a:r>
+          </a:p>
+        </p:txBody>
+      </p:sp>
+      <p:sp>
+        <p:nvSpPr>
+          <p:cNvPr id="33" name="Report card"/>
+          <p:cNvSpPr/>
+          <p:nvPr/>
+        </p:nvSpPr>
+        <p:spPr>
+          <a:xfrm>
+            <a:off x="5560695" y="3105150"/>
+            <a:ext cx="4476750" cy="1514475"/>
+          </a:xfrm>
+          <a:prstGeom prst="roundRect">
+            <a:avLst>
+              <a:gd name="adj" fmla="val 8805"/>
+            </a:avLst>
+          </a:prstGeom>
+          <a:solidFill>
+            <a:srgbClr val="FFFFFF"/>
+          </a:solidFill>
+          <a:ln w="9525">
+            <a:solidFill>
+              <a:srgbClr val="E4E7EB"/>
+            </a:solidFill>
+          </a:ln>
+          <a:effectLst>
+            <a:outerShdw blurRad="247650" dist="95250" dir="5400000" algn="t" rotWithShape="0">
+              <a:srgbClr val="000000">
+                <a:alpha val="11000"/>
+              </a:srgbClr>
+            </a:outerShdw>
+          </a:effectLst>
+        </p:spPr>
+        <p:txBody>
+          <a:bodyPr rtlCol="0" anchor="ctr"/>
+          <a:lstStyle/>
+          <a:p/>
+        </p:txBody>
+      </p:sp>
+      <p:sp>
+        <p:nvSpPr>
+          <p:cNvPr id="34" name="Report header"/>
+          <p:cNvSpPr/>
+          <p:nvPr/>
+        </p:nvSpPr>
+        <p:spPr>
+          <a:xfrm>
+            <a:off x="5570220" y="3114675"/>
+            <a:ext cx="4457700" cy="361950"/>
+          </a:xfrm>
+          <a:prstGeom prst="round2SameRect">
+            <a:avLst>
+              <a:gd name="adj1" fmla="val 34210"/>
+              <a:gd name="adj2" fmla="val 0"/>
+            </a:avLst>
+          </a:prstGeom>
+          <a:solidFill>
+            <a:srgbClr val="F5F5F6"/>
+          </a:solidFill>
+          <a:ln>
+            <a:noFill/>
+          </a:ln>
+        </p:spPr>
+        <p:txBody>
+          <a:bodyPr rtlCol="0" anchor="ctr"/>
+          <a:lstStyle/>
+          <a:p/>
+        </p:txBody>
+      </p:sp>
+      <p:sp>
+        <p:nvSpPr>
+          <p:cNvPr id="35" name="Report header rule"/>
+          <p:cNvSpPr/>
+          <p:nvPr/>
+        </p:nvSpPr>
+        <p:spPr>
+          <a:xfrm>
+            <a:off x="5570220" y="3471862"/>
+            <a:ext cx="4457700" cy="7144"/>
+          </a:xfrm>
+          <a:prstGeom prst="rect">
+            <a:avLst/>
+          </a:prstGeom>
+          <a:solidFill>
+            <a:srgbClr val="E4E7EB"/>
+          </a:solidFill>
+          <a:ln>
+            <a:noFill/>
+          </a:ln>
+        </p:spPr>
+        <p:txBody>
+          <a:bodyPr rtlCol="0" anchor="ctr"/>
+          <a:lstStyle/>
+          <a:p/>
+        </p:txBody>
+      </p:sp>
+      <p:sp>
+        <p:nvSpPr>
+          <p:cNvPr id="36" name="Report title"/>
+          <p:cNvSpPr txBox="1"/>
+          <p:nvPr/>
+        </p:nvSpPr>
+        <p:spPr>
+          <a:xfrm>
+            <a:off x="5713095" y="3114675"/>
+            <a:ext cx="4191000" cy="361950"/>
+          </a:xfrm>
+          <a:prstGeom prst="rect">
+            <a:avLst/>
+          </a:prstGeom>
+          <a:noFill/>
+        </p:spPr>
+        <p:txBody>
+          <a:bodyPr wrap="square" anchor="ctr" lIns="0" rIns="0" tIns="0" bIns="0">
+            <a:spAutoFit/>
+          </a:bodyPr>
+          <a:lstStyle/>
+          <a:p>
+            <a:pPr algn="l"/>
+            <a:r>
+              <a:rPr sz="937" i="0" b="1">
+                <a:solidFill>
+                  <a:srgbClr val="1A1A1A"/>
+                </a:solidFill>
+                <a:latin typeface="Arial"/>
+              </a:rPr>
+              <a:t>Rekap Komplain Nasabah · Minggu ke-2 Agustus</a:t>
+            </a:r>
+          </a:p>
+        </p:txBody>
+      </p:sp>
+      <p:graphicFrame>
+        <p:nvGraphicFramePr>
+          <p:cNvPr id="37" name="Report table"/>
+          <p:cNvGraphicFramePr>
+            <a:graphicFrameLocks noGrp="1"/>
+          </p:cNvGraphicFramePr>
+          <p:nvPr/>
+        </p:nvGraphicFramePr>
+        <p:xfrm>
+          <a:off x="5570220" y="3479006"/>
+          <a:ext cx="4457699" cy="1133474"/>
+        </p:xfrm>
+        <a:graphic>
+          <a:graphicData uri="http://schemas.openxmlformats.org/drawingml/2006/table">
+            <a:tbl>
+              <a:tblPr firstRow="1"/>
+              <a:tblGrid>
+                <a:gridCol w="561975"/>
+                <a:gridCol w="929640"/>
+                <a:gridCol w="1098232"/>
+                <a:gridCol w="525780"/>
+                <a:gridCol w="1342072"/>
+              </a:tblGrid>
+              <a:tr h="252412">
+                <a:tc>
+                  <a:txBody>
+                    <a:bodyPr/>
+                    <a:lstStyle/>
+                    <a:p>
+                      <a:r>
+                        <a:rPr sz="675" b="1" spc="33">
+                          <a:solidFill>
+                            <a:srgbClr val="7B3FC0"/>
+                          </a:solidFill>
+                          <a:latin typeface="Courier New"/>
+                        </a:rPr>
+                        <a:t>TANGGAL</a:t>
+                      </a:r>
+                    </a:p>
+                  </a:txBody>
+                  <a:tcPr marL="85725" marR="85725" marT="66675" marB="66675" anchor="ctr">
+                    <a:lnL w="0">
+                      <a:noFill/>
+                    </a:lnL>
+                    <a:lnR w="0">
+                      <a:noFill/>
+                    </a:lnR>
+                    <a:lnT w="0">
+                      <a:noFill/>
+                    </a:lnT>
+                    <a:lnB w="9525">
+                      <a:solidFill>
+                        <a:srgbClr val="E2D2F5"/>
+                      </a:solidFill>
+                    </a:lnB>
+                    <a:solidFill>
+                      <a:srgbClr val="F3ECFB"/>
+                    </a:solidFill>
+                  </a:tcPr>
+                </a:tc>
+                <a:tc>
+                  <a:txBody>
+                    <a:bodyPr/>
+                    <a:lstStyle/>
+                    <a:p>
+                      <a:r>
+                        <a:rPr sz="675" b="1" spc="33">
+                          <a:solidFill>
+                            <a:srgbClr val="7B3FC0"/>
+                          </a:solidFill>
+                          <a:latin typeface="Courier New"/>
+                        </a:rPr>
+                        <a:t>KANAL</a:t>
+                      </a:r>
+                    </a:p>
+                  </a:txBody>
+                  <a:tcPr marL="85725" marR="85725" marT="66675" marB="66675" anchor="ctr">
+                    <a:lnL w="0">
+                      <a:noFill/>
+                    </a:lnL>
+                    <a:lnR w="0">
+                      <a:noFill/>
+                    </a:lnR>
+                    <a:lnT w="0">
+                      <a:noFill/>
+                    </a:lnT>
+                    <a:lnB w="9525">
+                      <a:solidFill>
+                        <a:srgbClr val="E2D2F5"/>
+                      </a:solidFill>
+                    </a:lnB>
+                    <a:solidFill>
+                      <a:srgbClr val="F3ECFB"/>
+                    </a:solidFill>
+                  </a:tcPr>
+                </a:tc>
+                <a:tc>
+                  <a:txBody>
+                    <a:bodyPr/>
+                    <a:lstStyle/>
+                    <a:p>
+                      <a:r>
+                        <a:rPr sz="675" b="1" spc="33">
+                          <a:solidFill>
+                            <a:srgbClr val="7B3FC0"/>
+                          </a:solidFill>
+                          <a:latin typeface="Courier New"/>
+                        </a:rPr>
+                        <a:t>JENIS KOMPLAIN</a:t>
+                      </a:r>
+                    </a:p>
+                  </a:txBody>
+                  <a:tcPr marL="85725" marR="85725" marT="66675" marB="66675" anchor="ctr">
+                    <a:lnL w="0">
+                      <a:noFill/>
+                    </a:lnL>
+                    <a:lnR w="0">
+                      <a:noFill/>
+                    </a:lnR>
+                    <a:lnT w="0">
+                      <a:noFill/>
+                    </a:lnT>
+                    <a:lnB w="9525">
+                      <a:solidFill>
+                        <a:srgbClr val="E2D2F5"/>
+                      </a:solidFill>
+                    </a:lnB>
+                    <a:solidFill>
+                      <a:srgbClr val="F3ECFB"/>
+                    </a:solidFill>
+                  </a:tcPr>
+                </a:tc>
+                <a:tc>
+                  <a:txBody>
+                    <a:bodyPr/>
+                    <a:lstStyle/>
+                    <a:p>
+                      <a:r>
+                        <a:rPr sz="675" b="1" spc="33">
+                          <a:solidFill>
+                            <a:srgbClr val="7B3FC0"/>
+                          </a:solidFill>
+                          <a:latin typeface="Courier New"/>
+                        </a:rPr>
+                        <a:t>STATUS</a:t>
+                      </a:r>
+                    </a:p>
+                  </a:txBody>
+                  <a:tcPr marL="85725" marR="85725" marT="66675" marB="66675" anchor="ctr">
+                    <a:lnL w="0">
+                      <a:noFill/>
+                    </a:lnL>
+                    <a:lnR w="0">
+                      <a:noFill/>
+                    </a:lnR>
+                    <a:lnT w="0">
+                      <a:noFill/>
+                    </a:lnT>
+                    <a:lnB w="9525">
+                      <a:solidFill>
+                        <a:srgbClr val="E2D2F5"/>
+                      </a:solidFill>
+                    </a:lnB>
+                    <a:solidFill>
+                      <a:srgbClr val="F3ECFB"/>
+                    </a:solidFill>
+                  </a:tcPr>
+                </a:tc>
+                <a:tc>
+                  <a:txBody>
+                    <a:bodyPr/>
+                    <a:lstStyle/>
+                    <a:p>
+                      <a:r>
+                        <a:rPr sz="675" b="1" spc="33">
+                          <a:solidFill>
+                            <a:srgbClr val="7B3FC0"/>
+                          </a:solidFill>
+                          <a:latin typeface="Courier New"/>
+                        </a:rPr>
+                        <a:t>TINDAK LANJUT</a:t>
+                      </a:r>
+                    </a:p>
+                  </a:txBody>
+                  <a:tcPr marL="85725" marR="85725" marT="66675" marB="66675" anchor="ctr">
+                    <a:lnL w="0">
+                      <a:noFill/>
+                    </a:lnL>
+                    <a:lnR w="0">
+                      <a:noFill/>
+                    </a:lnR>
+                    <a:lnT w="0">
+                      <a:noFill/>
+                    </a:lnT>
+                    <a:lnB w="9525">
+                      <a:solidFill>
+                        <a:srgbClr val="E2D2F5"/>
+                      </a:solidFill>
+                    </a:lnB>
+                    <a:solidFill>
+                      <a:srgbClr val="F3ECFB"/>
+                    </a:solidFill>
+                  </a:tcPr>
+                </a:tc>
+              </a:tr>
+              <a:tr h="295275">
+                <a:tc>
+                  <a:txBody>
+                    <a:bodyPr/>
+                    <a:lstStyle/>
+                    <a:p>
+                      <a:r>
+                        <a:rPr sz="825" b="0">
+                          <a:solidFill>
+                            <a:srgbClr val="1F2937"/>
+                          </a:solidFill>
+                          <a:latin typeface="Arial"/>
+                        </a:rPr>
+                        <a:t>02/08</a:t>
+                      </a:r>
+                    </a:p>
+                  </a:txBody>
+                  <a:tcPr marL="85725" marR="85725" marT="76200" marB="76200" anchor="t">
+                    <a:lnL w="0">
+                      <a:noFill/>
+                    </a:lnL>
+                    <a:lnR w="0">
+                      <a:noFill/>
+                    </a:lnR>
+                    <a:lnT w="0">
+                      <a:noFill/>
+                    </a:lnT>
+                    <a:lnB w="9525">
+                      <a:solidFill>
+                        <a:srgbClr val="E4E7EB"/>
+                      </a:solidFill>
+                    </a:lnB>
+                    <a:noFill/>
+                  </a:tcPr>
+                </a:tc>
+                <a:tc>
+                  <a:txBody>
+                    <a:bodyPr/>
+                    <a:lstStyle/>
+                    <a:p>
+                      <a:r>
+                        <a:rPr sz="825" b="0">
+                          <a:solidFill>
+                            <a:srgbClr val="1F2937"/>
+                          </a:solidFill>
+                          <a:latin typeface="Arial"/>
+                        </a:rPr>
+                        <a:t>Mobile banking</a:t>
+                      </a:r>
+                    </a:p>
+                  </a:txBody>
+                  <a:tcPr marL="85725" marR="85725" marT="76200" marB="76200" anchor="t">
+                    <a:lnL w="0">
+                      <a:noFill/>
+                    </a:lnL>
+                    <a:lnR w="0">
+                      <a:noFill/>
+                    </a:lnR>
+                    <a:lnT w="0">
+                      <a:noFill/>
+                    </a:lnT>
+                    <a:lnB w="9525">
+                      <a:solidFill>
+                        <a:srgbClr val="E4E7EB"/>
+                      </a:solidFill>
+                    </a:lnB>
+                    <a:noFill/>
+                  </a:tcPr>
+                </a:tc>
+                <a:tc>
+                  <a:txBody>
+                    <a:bodyPr/>
+                    <a:lstStyle/>
+                    <a:p>
+                      <a:r>
+                        <a:rPr sz="825" b="0">
+                          <a:solidFill>
+                            <a:srgbClr val="1F2937"/>
+                          </a:solidFill>
+                          <a:latin typeface="Arial"/>
+                        </a:rPr>
+                        <a:t>Transfer gagal</a:t>
+                      </a:r>
+                    </a:p>
+                  </a:txBody>
+                  <a:tcPr marL="85725" marR="85725" marT="76200" marB="76200" anchor="t">
+                    <a:lnL w="0">
+                      <a:noFill/>
+                    </a:lnL>
+                    <a:lnR w="0">
+                      <a:noFill/>
+                    </a:lnR>
+                    <a:lnT w="0">
+                      <a:noFill/>
+                    </a:lnT>
+                    <a:lnB w="9525">
+                      <a:solidFill>
+                        <a:srgbClr val="E4E7EB"/>
+                      </a:solidFill>
+                    </a:lnB>
+                    <a:noFill/>
+                  </a:tcPr>
+                </a:tc>
+                <a:tc>
+                  <a:txBody>
+                    <a:bodyPr/>
+                    <a:lstStyle/>
+                    <a:p>
+                      <a:r>
+                        <a:rPr sz="825" b="0">
+                          <a:solidFill>
+                            <a:srgbClr val="1F2937"/>
+                          </a:solidFill>
+                          <a:latin typeface="Arial"/>
+                        </a:rPr>
+                        <a:t>Selesai</a:t>
+                      </a:r>
+                    </a:p>
+                  </a:txBody>
+                  <a:tcPr marL="85725" marR="85725" marT="76200" marB="76200" anchor="t">
+                    <a:lnL w="0">
+                      <a:noFill/>
+                    </a:lnL>
+                    <a:lnR w="0">
+                      <a:noFill/>
+                    </a:lnR>
+                    <a:lnT w="0">
+                      <a:noFill/>
+                    </a:lnT>
+                    <a:lnB w="9525">
+                      <a:solidFill>
+                        <a:srgbClr val="E4E7EB"/>
+                      </a:solidFill>
+                    </a:lnB>
+                    <a:noFill/>
+                  </a:tcPr>
+                </a:tc>
+                <a:tc>
+                  <a:txBody>
+                    <a:bodyPr/>
+                    <a:lstStyle/>
+                    <a:p>
+                      <a:r>
+                        <a:rPr sz="825" b="0">
+                          <a:solidFill>
+                            <a:srgbClr val="1F2937"/>
+                          </a:solidFill>
+                          <a:latin typeface="Arial"/>
+                        </a:rPr>
+                        <a:t>Dana dikembalikan</a:t>
+                      </a:r>
+                    </a:p>
+                  </a:txBody>
+                  <a:tcPr marL="85725" marR="85725" marT="76200" marB="76200" anchor="t">
+                    <a:lnL w="0">
+                      <a:noFill/>
+                    </a:lnL>
+                    <a:lnR w="0">
+                      <a:noFill/>
+                    </a:lnR>
+                    <a:lnT w="0">
+                      <a:noFill/>
+                    </a:lnT>
+                    <a:lnB w="9525">
+                      <a:solidFill>
+                        <a:srgbClr val="E4E7EB"/>
+                      </a:solidFill>
+                    </a:lnB>
+                    <a:noFill/>
+                  </a:tcPr>
+                </a:tc>
+              </a:tr>
+              <a:tr h="295275">
+                <a:tc>
+                  <a:txBody>
+                    <a:bodyPr/>
+                    <a:lstStyle/>
+                    <a:p>
+                      <a:r>
+                        <a:rPr sz="825" b="0">
+                          <a:solidFill>
+                            <a:srgbClr val="1F2937"/>
+                          </a:solidFill>
+                          <a:latin typeface="Arial"/>
+                        </a:rPr>
+                        <a:t>04/08</a:t>
+                      </a:r>
+                    </a:p>
+                  </a:txBody>
+                  <a:tcPr marL="85725" marR="85725" marT="76200" marB="76200" anchor="t">
+                    <a:lnL w="0">
+                      <a:noFill/>
+                    </a:lnL>
+                    <a:lnR w="0">
+                      <a:noFill/>
+                    </a:lnR>
+                    <a:lnT w="0">
+                      <a:noFill/>
+                    </a:lnT>
+                    <a:lnB w="9525">
+                      <a:solidFill>
+                        <a:srgbClr val="E4E7EB"/>
+                      </a:solidFill>
+                    </a:lnB>
+                    <a:noFill/>
+                  </a:tcPr>
+                </a:tc>
+                <a:tc>
+                  <a:txBody>
+                    <a:bodyPr/>
+                    <a:lstStyle/>
+                    <a:p>
+                      <a:r>
+                        <a:rPr sz="825" b="0">
+                          <a:solidFill>
+                            <a:srgbClr val="1F2937"/>
+                          </a:solidFill>
+                          <a:latin typeface="Arial"/>
+                        </a:rPr>
+                        <a:t>Cabang</a:t>
+                      </a:r>
+                    </a:p>
+                  </a:txBody>
+                  <a:tcPr marL="85725" marR="85725" marT="76200" marB="76200" anchor="t">
+                    <a:lnL w="0">
+                      <a:noFill/>
+                    </a:lnL>
+                    <a:lnR w="0">
+                      <a:noFill/>
+                    </a:lnR>
+                    <a:lnT w="0">
+                      <a:noFill/>
+                    </a:lnT>
+                    <a:lnB w="9525">
+                      <a:solidFill>
+                        <a:srgbClr val="E4E7EB"/>
+                      </a:solidFill>
+                    </a:lnB>
+                    <a:noFill/>
+                  </a:tcPr>
+                </a:tc>
+                <a:tc>
+                  <a:txBody>
+                    <a:bodyPr/>
+                    <a:lstStyle/>
+                    <a:p>
+                      <a:r>
+                        <a:rPr sz="825" b="0">
+                          <a:solidFill>
+                            <a:srgbClr val="1F2937"/>
+                          </a:solidFill>
+                          <a:latin typeface="Arial"/>
+                        </a:rPr>
+                        <a:t>Antrean lama</a:t>
+                      </a:r>
+                    </a:p>
+                  </a:txBody>
+                  <a:tcPr marL="85725" marR="85725" marT="76200" marB="76200" anchor="t">
+                    <a:lnL w="0">
+                      <a:noFill/>
+                    </a:lnL>
+                    <a:lnR w="0">
+                      <a:noFill/>
+                    </a:lnR>
+                    <a:lnT w="0">
+                      <a:noFill/>
+                    </a:lnT>
+                    <a:lnB w="9525">
+                      <a:solidFill>
+                        <a:srgbClr val="E4E7EB"/>
+                      </a:solidFill>
+                    </a:lnB>
+                    <a:noFill/>
+                  </a:tcPr>
+                </a:tc>
+                <a:tc>
+                  <a:txBody>
+                    <a:bodyPr/>
+                    <a:lstStyle/>
+                    <a:p>
+                      <a:r>
+                        <a:rPr sz="825" b="0">
+                          <a:solidFill>
+                            <a:srgbClr val="1F2937"/>
+                          </a:solidFill>
+                          <a:latin typeface="Arial"/>
+                        </a:rPr>
+                        <a:t>Proses</a:t>
+                      </a:r>
+                    </a:p>
+                  </a:txBody>
+                  <a:tcPr marL="85725" marR="85725" marT="76200" marB="76200" anchor="t">
+                    <a:lnL w="0">
+                      <a:noFill/>
+                    </a:lnL>
+                    <a:lnR w="0">
+                      <a:noFill/>
+                    </a:lnR>
+                    <a:lnT w="0">
+                      <a:noFill/>
+                    </a:lnT>
+                    <a:lnB w="9525">
+                      <a:solidFill>
+                        <a:srgbClr val="E4E7EB"/>
+                      </a:solidFill>
+                    </a:lnB>
+                    <a:noFill/>
+                  </a:tcPr>
+                </a:tc>
+                <a:tc>
+                  <a:txBody>
+                    <a:bodyPr/>
+                    <a:lstStyle/>
+                    <a:p>
+                      <a:r>
+                        <a:rPr sz="825" b="0">
+                          <a:solidFill>
+                            <a:srgbClr val="1F2937"/>
+                          </a:solidFill>
+                          <a:latin typeface="Arial"/>
+                        </a:rPr>
+                        <a:t>Tambah teller jam sibuk</a:t>
+                      </a:r>
+                    </a:p>
+                  </a:txBody>
+                  <a:tcPr marL="85725" marR="85725" marT="76200" marB="76200" anchor="t">
+                    <a:lnL w="0">
+                      <a:noFill/>
+                    </a:lnL>
+                    <a:lnR w="0">
+                      <a:noFill/>
+                    </a:lnR>
+                    <a:lnT w="0">
+                      <a:noFill/>
+                    </a:lnT>
+                    <a:lnB w="9525">
+                      <a:solidFill>
+                        <a:srgbClr val="E4E7EB"/>
+                      </a:solidFill>
+                    </a:lnB>
+                    <a:noFill/>
+                  </a:tcPr>
+                </a:tc>
+              </a:tr>
+              <a:tr h="290512">
+                <a:tc>
+                  <a:txBody>
+                    <a:bodyPr/>
+                    <a:lstStyle/>
+                    <a:p>
+                      <a:r>
+                        <a:rPr sz="825" b="0">
+                          <a:solidFill>
+                            <a:srgbClr val="1F2937"/>
+                          </a:solidFill>
+                          <a:latin typeface="Arial"/>
+                        </a:rPr>
+                        <a:t>05/08</a:t>
+                      </a:r>
+                    </a:p>
+                  </a:txBody>
+                  <a:tcPr marL="85725" marR="85725" marT="76200" marB="76200" anchor="t">
+                    <a:lnL w="0">
+                      <a:noFill/>
+                    </a:lnL>
+                    <a:lnR w="0">
+                      <a:noFill/>
+                    </a:lnR>
+                    <a:lnT w="0">
+                      <a:noFill/>
+                    </a:lnT>
+                    <a:lnB w="0">
+                      <a:noFill/>
+                    </a:lnB>
+                    <a:noFill/>
+                  </a:tcPr>
+                </a:tc>
+                <a:tc>
+                  <a:txBody>
+                    <a:bodyPr/>
+                    <a:lstStyle/>
+                    <a:p>
+                      <a:r>
+                        <a:rPr sz="825" b="0">
+                          <a:solidFill>
+                            <a:srgbClr val="1F2937"/>
+                          </a:solidFill>
+                          <a:latin typeface="Arial"/>
+                        </a:rPr>
+                        <a:t>Call center</a:t>
+                      </a:r>
+                    </a:p>
+                  </a:txBody>
+                  <a:tcPr marL="85725" marR="85725" marT="76200" marB="76200" anchor="t">
+                    <a:lnL w="0">
+                      <a:noFill/>
+                    </a:lnL>
+                    <a:lnR w="0">
+                      <a:noFill/>
+                    </a:lnR>
+                    <a:lnT w="0">
+                      <a:noFill/>
+                    </a:lnT>
+                    <a:lnB w="0">
+                      <a:noFill/>
+                    </a:lnB>
+                    <a:noFill/>
+                  </a:tcPr>
+                </a:tc>
+                <a:tc>
+                  <a:txBody>
+                    <a:bodyPr/>
+                    <a:lstStyle/>
+                    <a:p>
+                      <a:r>
+                        <a:rPr sz="825" b="0">
+                          <a:solidFill>
+                            <a:srgbClr val="1F2937"/>
+                          </a:solidFill>
+                          <a:latin typeface="Arial"/>
+                        </a:rPr>
+                        <a:t>Kartu tertelan ATM</a:t>
+                      </a:r>
+                    </a:p>
+                  </a:txBody>
+                  <a:tcPr marL="85725" marR="85725" marT="76200" marB="76200" anchor="t">
+                    <a:lnL w="0">
+                      <a:noFill/>
+                    </a:lnL>
+                    <a:lnR w="0">
+                      <a:noFill/>
+                    </a:lnR>
+                    <a:lnT w="0">
+                      <a:noFill/>
+                    </a:lnT>
+                    <a:lnB w="0">
+                      <a:noFill/>
+                    </a:lnB>
+                    <a:noFill/>
+                  </a:tcPr>
+                </a:tc>
+                <a:tc>
+                  <a:txBody>
+                    <a:bodyPr/>
+                    <a:lstStyle/>
+                    <a:p>
+                      <a:r>
+                        <a:rPr sz="825" b="0">
+                          <a:solidFill>
+                            <a:srgbClr val="1F2937"/>
+                          </a:solidFill>
+                          <a:latin typeface="Arial"/>
+                        </a:rPr>
+                        <a:t>Selesai</a:t>
+                      </a:r>
+                    </a:p>
+                  </a:txBody>
+                  <a:tcPr marL="85725" marR="85725" marT="76200" marB="76200" anchor="t">
+                    <a:lnL w="0">
+                      <a:noFill/>
+                    </a:lnL>
+                    <a:lnR w="0">
+                      <a:noFill/>
+                    </a:lnR>
+                    <a:lnT w="0">
+                      <a:noFill/>
+                    </a:lnT>
+                    <a:lnB w="0">
+                      <a:noFill/>
+                    </a:lnB>
+                    <a:noFill/>
+                  </a:tcPr>
+                </a:tc>
+                <a:tc>
+                  <a:txBody>
+                    <a:bodyPr/>
+                    <a:lstStyle/>
+                    <a:p>
+                      <a:r>
+                        <a:rPr sz="825" b="1">
+                          <a:solidFill>
+                            <a:srgbClr val="14663F"/>
+                          </a:solidFill>
+                          <a:latin typeface="Arial"/>
+                        </a:rPr>
+                        <a:t>N/A</a:t>
+                      </a:r>
+                    </a:p>
+                  </a:txBody>
+                  <a:tcPr marL="85725" marR="85725" marT="76200" marB="76200" anchor="t">
+                    <a:lnL w="0">
+                      <a:noFill/>
+                    </a:lnL>
+                    <a:lnR w="0">
+                      <a:noFill/>
+                    </a:lnR>
+                    <a:lnT w="0">
+                      <a:noFill/>
+                    </a:lnT>
+                    <a:lnB w="0">
+                      <a:noFill/>
+                    </a:lnB>
+                    <a:solidFill>
+                      <a:srgbClr val="E9F7EE"/>
+                    </a:solidFill>
+                  </a:tcPr>
+                </a:tc>
+              </a:tr>
+            </a:tbl>
+          </a:graphicData>
+        </a:graphic>
+      </p:graphicFrame>
+      <p:sp>
+        <p:nvSpPr>
+          <p:cNvPr id="38" name="Note pill"/>
+          <p:cNvSpPr/>
+          <p:nvPr/>
+        </p:nvSpPr>
+        <p:spPr>
+          <a:xfrm>
+            <a:off x="5560695" y="4714875"/>
+            <a:ext cx="2401252" cy="257175"/>
+          </a:xfrm>
+          <a:prstGeom prst="roundRect">
+            <a:avLst>
+              <a:gd name="adj" fmla="val 50000"/>
+            </a:avLst>
+          </a:prstGeom>
+          <a:solidFill>
+            <a:srgbClr val="E9F7EE"/>
+          </a:solidFill>
+          <a:ln w="9525">
+            <a:solidFill>
+              <a:srgbClr val="CDEBD8"/>
+            </a:solidFill>
+          </a:ln>
+        </p:spPr>
+        <p:txBody>
+          <a:bodyPr rtlCol="0" anchor="ctr"/>
+          <a:lstStyle/>
+          <a:p/>
+        </p:txBody>
+      </p:sp>
+      <p:sp>
+        <p:nvSpPr>
+          <p:cNvPr id="39" name="Note"/>
+          <p:cNvSpPr txBox="1"/>
+          <p:nvPr/>
+        </p:nvSpPr>
+        <p:spPr>
+          <a:xfrm>
+            <a:off x="5560695" y="4714875"/>
+            <a:ext cx="2401252" cy="257175"/>
+          </a:xfrm>
+          <a:prstGeom prst="rect">
+            <a:avLst/>
+          </a:prstGeom>
+          <a:noFill/>
+        </p:spPr>
+        <p:txBody>
+          <a:bodyPr wrap="square" anchor="ctr" lIns="0" rIns="0" tIns="0" bIns="0">
+            <a:spAutoFit/>
+          </a:bodyPr>
+          <a:lstStyle/>
+          <a:p>
+            <a:pPr algn="ctr"/>
+            <a:r>
+              <a:rPr sz="862" i="0" b="1">
+                <a:solidFill>
+                  <a:srgbClr val="14663F"/>
+                </a:solidFill>
+                <a:latin typeface="Arial"/>
+              </a:rPr>
+              <a:t>✓ data kosong ditulis N/A, tidak dikarang</a:t>
+            </a:r>
+          </a:p>
+        </p:txBody>
+      </p:sp>
       <p:pic>
         <p:nvPicPr>
-          <p:cNvPr id="2" name="COSTAR, filled in" descr="COSTAR, filled in"/>
+          <p:cNvPr id="40" name="OCBC icon" descr="ocbc-icon.png"/>
           <p:cNvPicPr>
             <a:picLocks noChangeAspect="1"/>
           </p:cNvPicPr>
@@ -3673,14 +6795,49 @@
         </p:blipFill>
         <p:spPr>
           <a:xfrm>
-            <a:off x="0" y="0"/>
-            <a:ext cx="12192000" cy="6858000"/>
+            <a:off x="723900" y="6438900"/>
+            <a:ext cx="171450" cy="171450"/>
           </a:xfrm>
           <a:prstGeom prst="rect">
             <a:avLst/>
           </a:prstGeom>
         </p:spPr>
       </p:pic>
+      <p:sp>
+        <p:nvSpPr>
+          <p:cNvPr id="41" name="Footer"/>
+          <p:cNvSpPr txBox="1"/>
+          <p:nvPr/>
+        </p:nvSpPr>
+        <p:spPr>
+          <a:xfrm>
+            <a:off x="981075" y="6438900"/>
+            <a:ext cx="1905000" cy="171450"/>
+          </a:xfrm>
+          <a:prstGeom prst="rect">
+            <a:avLst/>
+          </a:prstGeom>
+          <a:noFill/>
+        </p:spPr>
+        <p:txBody>
+          <a:bodyPr wrap="square" anchor="ctr" lIns="0" rIns="0" tIns="0" bIns="0">
+            <a:spAutoFit/>
+          </a:bodyPr>
+          <a:lstStyle/>
+          <a:p>
+            <a:pPr algn="l"/>
+            <a:r>
+              <a:rPr sz="900" i="0" b="1" spc="18">
+                <a:solidFill>
+                  <a:srgbClr val="6B7280"/>
+                </a:solidFill>
+                <a:latin typeface="Arial"/>
+              </a:rPr>
+              <a:t>Learning at Lunch</a:t>
+            </a:r>
+          </a:p>
+        </p:txBody>
+      </p:sp>
     </p:spTree>
   </p:cSld>
   <p:clrMapOvr>

</xml_diff>